<commit_message>
Align 9-slide deck with the official problem statement and team details
Co-Authored-By: Claude Opus 5.5 <noreply@anthropic.com>
Claude-Session: https://claude.ai/code/session_01RiioRpvzPREAo253VWx5eZ
</commit_message>
<xml_diff>
--- a/docs/pitch/ChainSight_Round1_9slides.pptx
+++ b/docs/pitch/ChainSight_Round1_9slides.pptx
@@ -115,43 +115,43 @@
   <p:extLst>
     <p:ext uri="{521415D9-36F7-43E2-AB2F-B90AF26B5E84}">
       <p14:sectionLst xmlns:p14="http://schemas.microsoft.com/office/powerpoint/2010/main">
-        <p14:section name="Team Details" id="{ac0056f2-26af-d5e6-c303-90083eced024}">
+        <p14:section name="Team Details" id="{6e4cd788-1c80-71c2-1c13-7e262ac037df}">
           <p14:sldIdLst>
             <p14:sldId id="256"/>
           </p14:sldIdLst>
         </p14:section>
-        <p14:section name="Problem" id="{f504e33c-1b00-7c6b-feda-5b67ed0e8a6e}">
+        <p14:section name="Problem" id="{9996a751-3f9d-9e7b-ce78-890478f3ebc9}">
           <p14:sldIdLst>
             <p14:sldId id="257"/>
           </p14:sldIdLst>
         </p14:section>
-        <p14:section name="Solution" id="{88aa3711-c723-d873-003b-c24c24f48050}">
+        <p14:section name="Solution" id="{319ba565-1335-3e64-188d-a25f0200a6fe}">
           <p14:sldIdLst>
             <p14:sldId id="258"/>
           </p14:sldIdLst>
         </p14:section>
-        <p14:section name="Users" id="{dde50d3c-8465-4602-0b57-b28935d70c11}">
+        <p14:section name="Users" id="{45e605ed-5ee1-7b34-49d7-98b9cf29d33e}">
           <p14:sldIdLst>
             <p14:sldId id="259"/>
           </p14:sldIdLst>
         </p14:section>
-        <p14:section name="Architecture" id="{7d6b78d6-3a3e-468b-5d80-7e43f170b5df}">
+        <p14:section name="Architecture" id="{eeac9a9c-5bc7-c862-5650-7e6c33122dea}">
           <p14:sldIdLst>
             <p14:sldId id="260"/>
           </p14:sldIdLst>
         </p14:section>
-        <p14:section name="TinyFish" id="{f7ef3b15-fcad-64be-5ace-118b985f488c}">
+        <p14:section name="TinyFish" id="{52d7420b-3be8-c7b5-4f5d-4ef99fecb17e}">
           <p14:sldIdLst>
             <p14:sldId id="261"/>
           </p14:sldIdLst>
         </p14:section>
-        <p14:section name="Scale" id="{1d5fe445-18c4-0320-8f7e-51047706582e}">
+        <p14:section name="Scale" id="{0b7506f0-c0a8-3758-e63c-f9891a141a39}">
           <p14:sldIdLst>
             <p14:sldId id="262"/>
             <p14:sldId id="263"/>
           </p14:sldIdLst>
         </p14:section>
-        <p14:section name="Prototype" id="{10aa21ea-e586-4f7c-b93b-d8deb12959d4}">
+        <p14:section name="Prototype" id="{b1893a3f-9013-a539-d6c9-af75ba47696b}">
           <p14:sldIdLst>
             <p14:sldId id="264"/>
           </p14:sldIdLst>
@@ -560,7 +560,7 @@
           <a:p>
             <a:r>
               <a:rPr lang="en-US" dirty="0"/>
-              <a:t>Replace bracketed placeholders with real team details before submitting.</a:t>
+              <a:t/>
             </a:r>
             <a:endParaRPr lang="en-US" dirty="0"/>
           </a:p>
@@ -2054,7 +2054,7 @@
                   <a:schemeClr val="bg2"/>
                 </a:solidFill>
               </a:rPr>
-              <a:t>Wallet in. Exchange, contact and evidence out.</a:t>
+              <a:t>Real-time crypto fraud attribution: wallet in, exchange, contact and evidence out</a:t>
             </a:r>
             <a:endParaRPr lang="en-US" sz="2200" dirty="0"/>
           </a:p>
@@ -2353,54 +2353,18 @@
       </p:sp>
       <p:sp>
         <p:nvSpPr>
-          <p:cNvPr id="16" name="Text 14"/>
-          <p:cNvSpPr txBox="1"/>
-          <p:nvPr/>
-        </p:nvSpPr>
-        <p:spPr>
-          <a:xfrm>
-            <a:off x="548640" y="3977640"/>
-            <a:ext cx="10972800" cy="365760"/>
-          </a:xfrm>
-          <a:prstGeom prst="rect">
-            <a:avLst/>
-          </a:prstGeom>
-          <a:noFill/>
-          <a:ln/>
-        </p:spPr>
-        <p:txBody>
-          <a:bodyPr wrap="square" lIns="0" tIns="0" rIns="0" bIns="0" rtlCol="0" anchor="t"/>
-          <a:lstStyle/>
-          <a:p>
-            <a:pPr indent="0" marL="0">
-              <a:buNone/>
-            </a:pPr>
-            <a:r>
-              <a:rPr lang="en-US" sz="1600" b="1" dirty="0">
-                <a:solidFill>
-                  <a:schemeClr val="accent1"/>
-                </a:solidFill>
-              </a:rPr>
-              <a:t>Team [Team name]   |   [Institution]   |   [Contact email / phone]</a:t>
-            </a:r>
-            <a:endParaRPr lang="en-US" sz="1600" dirty="0"/>
-          </a:p>
-        </p:txBody>
-      </p:sp>
-      <p:sp>
-        <p:nvSpPr>
-          <p:cNvPr id="17" name="team0"/>
-          <p:cNvSpPr/>
-          <p:nvPr/>
-        </p:nvSpPr>
-        <p:spPr>
-          <a:xfrm>
-            <a:off x="548640" y="4526280"/>
-            <a:ext cx="2602154" cy="1325880"/>
+          <p:cNvPr id="16" name="ps-card"/>
+          <p:cNvSpPr/>
+          <p:nvPr/>
+        </p:nvSpPr>
+        <p:spPr>
+          <a:xfrm>
+            <a:off x="548640" y="3886200"/>
+            <a:ext cx="6949440" cy="2194560"/>
           </a:xfrm>
           <a:prstGeom prst="roundRect">
             <a:avLst>
-              <a:gd name="adj" fmla="val 5517"/>
+              <a:gd name="adj" fmla="val 3333"/>
             </a:avLst>
           </a:prstGeom>
           <a:solidFill>
@@ -2416,14 +2380,50 @@
       </p:sp>
       <p:sp>
         <p:nvSpPr>
+          <p:cNvPr id="17" name="Text 15"/>
+          <p:cNvSpPr txBox="1"/>
+          <p:nvPr/>
+        </p:nvSpPr>
+        <p:spPr>
+          <a:xfrm>
+            <a:off x="822960" y="4069080"/>
+            <a:ext cx="4572000" cy="274320"/>
+          </a:xfrm>
+          <a:prstGeom prst="rect">
+            <a:avLst/>
+          </a:prstGeom>
+          <a:noFill/>
+          <a:ln/>
+        </p:spPr>
+        <p:txBody>
+          <a:bodyPr wrap="square" lIns="0" tIns="0" rIns="0" bIns="0" rtlCol="0" anchor="t"/>
+          <a:lstStyle/>
+          <a:p>
+            <a:pPr indent="0" marL="0">
+              <a:buNone/>
+            </a:pPr>
+            <a:r>
+              <a:rPr lang="en-US" sz="1200" b="1" spc="200" kern="0" dirty="0">
+                <a:solidFill>
+                  <a:schemeClr val="accent1"/>
+                </a:solidFill>
+              </a:rPr>
+              <a:t>PROBLEM STATEMENT</a:t>
+            </a:r>
+            <a:endParaRPr lang="en-US" sz="1200" dirty="0"/>
+          </a:p>
+        </p:txBody>
+      </p:sp>
+      <p:sp>
+        <p:nvSpPr>
           <p:cNvPr id="18" name="Text 16"/>
           <p:cNvSpPr txBox="1"/>
           <p:nvPr/>
         </p:nvSpPr>
         <p:spPr>
           <a:xfrm>
-            <a:off x="777240" y="4709160"/>
-            <a:ext cx="2144954" cy="365760"/>
+            <a:off x="822960" y="4434840"/>
+            <a:ext cx="6400800" cy="1005840"/>
           </a:xfrm>
           <a:prstGeom prst="rect">
             <a:avLst/>
@@ -2439,14 +2439,14 @@
               <a:buNone/>
             </a:pPr>
             <a:r>
-              <a:rPr lang="en-US" sz="1800" b="1" dirty="0">
+              <a:rPr lang="en-US" sz="1600" b="1" dirty="0">
                 <a:solidFill>
                   <a:schemeClr val="bg1"/>
                 </a:solidFill>
               </a:rPr>
-              <a:t>[Member 1]</a:t>
-            </a:r>
-            <a:endParaRPr lang="en-US" sz="1800" dirty="0"/>
+              <a:t>Real-Time Identification of Fraud-Linked Cryptocurrency Exchanges from Victim-Reported Suspect Wallet Addresses through Automated Blockchain Analytics</a:t>
+            </a:r>
+            <a:endParaRPr lang="en-US" sz="1600" dirty="0"/>
           </a:p>
         </p:txBody>
       </p:sp>
@@ -2458,8 +2458,8 @@
         </p:nvSpPr>
         <p:spPr>
           <a:xfrm>
-            <a:off x="777240" y="5120640"/>
-            <a:ext cx="2144954" cy="320040"/>
+            <a:off x="822960" y="5532120"/>
+            <a:ext cx="6400800" cy="365760"/>
           </a:xfrm>
           <a:prstGeom prst="rect">
             <a:avLst/>
@@ -2475,12 +2475,45 @@
               <a:buNone/>
             </a:pPr>
             <a:r>
+              <a:rPr lang="en-US" sz="1400" b="1" dirty="0">
+                <a:solidFill>
+                  <a:schemeClr val="accent1"/>
+                </a:solidFill>
+              </a:rPr>
+              <a:t>Theme: </a:t>
+            </a:r>
+            <a:pPr indent="0" marL="0">
+              <a:buNone/>
+            </a:pPr>
+            <a:r>
               <a:rPr lang="en-US" sz="1400" dirty="0">
                 <a:solidFill>
-                  <a:schemeClr val="bg2"/>
-                </a:solidFill>
-              </a:rPr>
-              <a:t>Lead, product and pitch</a:t>
+                  <a:schemeClr val="bg1"/>
+                </a:solidFill>
+              </a:rPr>
+              <a:t>Blockchain &amp; Cybersecurity      </a:t>
+            </a:r>
+            <a:pPr indent="0" marL="0">
+              <a:buNone/>
+            </a:pPr>
+            <a:r>
+              <a:rPr lang="en-US" sz="1400" b="1" dirty="0">
+                <a:solidFill>
+                  <a:schemeClr val="accent1"/>
+                </a:solidFill>
+              </a:rPr>
+              <a:t>Category: </a:t>
+            </a:r>
+            <a:pPr indent="0" marL="0">
+              <a:buNone/>
+            </a:pPr>
+            <a:r>
+              <a:rPr lang="en-US" sz="1400" dirty="0">
+                <a:solidFill>
+                  <a:schemeClr val="bg1"/>
+                </a:solidFill>
+              </a:rPr>
+              <a:t>Software</a:t>
             </a:r>
             <a:endParaRPr lang="en-US" sz="1400" dirty="0"/>
           </a:p>
@@ -2494,8 +2527,8 @@
         </p:nvSpPr>
         <p:spPr>
           <a:xfrm>
-            <a:off x="777240" y="5440680"/>
-            <a:ext cx="2144954" cy="274320"/>
+            <a:off x="7909560" y="3886200"/>
+            <a:ext cx="3657600" cy="274320"/>
           </a:xfrm>
           <a:prstGeom prst="rect">
             <a:avLst/>
@@ -2511,12 +2544,12 @@
               <a:buNone/>
             </a:pPr>
             <a:r>
-              <a:rPr lang="en-US" sz="1200" dirty="0">
-                <a:solidFill>
-                  <a:schemeClr val="accent5"/>
-                </a:solidFill>
-              </a:rPr>
-              <a:t>[College / year]</a:t>
+              <a:rPr lang="en-US" sz="1200" b="1" spc="200" kern="0" dirty="0">
+                <a:solidFill>
+                  <a:schemeClr val="accent1"/>
+                </a:solidFill>
+              </a:rPr>
+              <a:t>TEAM MEMBERS</a:t>
             </a:r>
             <a:endParaRPr lang="en-US" sz="1200" dirty="0"/>
           </a:p>
@@ -2524,18 +2557,18 @@
       </p:sp>
       <p:sp>
         <p:nvSpPr>
-          <p:cNvPr id="21" name="team1"/>
-          <p:cNvSpPr/>
-          <p:nvPr/>
-        </p:nvSpPr>
-        <p:spPr>
-          <a:xfrm>
-            <a:off x="3379394" y="4526280"/>
-            <a:ext cx="2602154" cy="1325880"/>
+          <p:cNvPr id="21" name="member0"/>
+          <p:cNvSpPr/>
+          <p:nvPr/>
+        </p:nvSpPr>
+        <p:spPr>
+          <a:xfrm>
+            <a:off x="7909560" y="4297680"/>
+            <a:ext cx="3733495" cy="777240"/>
           </a:xfrm>
           <a:prstGeom prst="roundRect">
             <a:avLst>
-              <a:gd name="adj" fmla="val 5517"/>
+              <a:gd name="adj" fmla="val 9412"/>
             </a:avLst>
           </a:prstGeom>
           <a:solidFill>
@@ -2551,23 +2584,72 @@
       </p:sp>
       <p:sp>
         <p:nvSpPr>
-          <p:cNvPr id="22" name="Text 20"/>
-          <p:cNvSpPr txBox="1"/>
-          <p:nvPr/>
-        </p:nvSpPr>
-        <p:spPr>
-          <a:xfrm>
-            <a:off x="3607994" y="4709160"/>
-            <a:ext cx="2144954" cy="365760"/>
-          </a:xfrm>
-          <a:prstGeom prst="rect">
-            <a:avLst/>
-          </a:prstGeom>
-          <a:noFill/>
-          <a:ln/>
-        </p:spPr>
-        <p:txBody>
-          <a:bodyPr wrap="square" lIns="0" tIns="0" rIns="0" bIns="0" rtlCol="0" anchor="t"/>
+          <p:cNvPr id="22" name="mem0-circle"/>
+          <p:cNvSpPr/>
+          <p:nvPr/>
+        </p:nvSpPr>
+        <p:spPr>
+          <a:xfrm>
+            <a:off x="8092440" y="4434840"/>
+            <a:ext cx="502920" cy="502920"/>
+          </a:xfrm>
+          <a:prstGeom prst="ellipse">
+            <a:avLst/>
+          </a:prstGeom>
+          <a:solidFill>
+            <a:schemeClr val="accent1"/>
+          </a:solidFill>
+          <a:ln w="12700">
+            <a:solidFill>
+              <a:schemeClr val="accent1"/>
+            </a:solidFill>
+            <a:prstDash val="solid"/>
+          </a:ln>
+        </p:spPr>
+      </p:sp>
+      <p:pic>
+        <p:nvPicPr>
+          <p:cNvPr id="23" name="mem0-icon" descr="preencoded.png">    </p:cNvPr>
+          <p:cNvPicPr>
+            <a:picLocks noChangeAspect="1"/>
+          </p:cNvPicPr>
+          <p:nvPr/>
+        </p:nvPicPr>
+        <p:blipFill>
+          <a:blip r:embed="rId1"/>
+          <a:stretch>
+            <a:fillRect/>
+          </a:stretch>
+        </p:blipFill>
+        <p:spPr>
+          <a:xfrm>
+            <a:off x="8223199" y="4565599"/>
+            <a:ext cx="241402" cy="241402"/>
+          </a:xfrm>
+          <a:prstGeom prst="rect">
+            <a:avLst/>
+          </a:prstGeom>
+        </p:spPr>
+      </p:pic>
+      <p:sp>
+        <p:nvSpPr>
+          <p:cNvPr id="24" name="Text 21"/>
+          <p:cNvSpPr txBox="1"/>
+          <p:nvPr/>
+        </p:nvSpPr>
+        <p:spPr>
+          <a:xfrm>
+            <a:off x="8778240" y="4297680"/>
+            <a:ext cx="2743200" cy="777240"/>
+          </a:xfrm>
+          <a:prstGeom prst="rect">
+            <a:avLst/>
+          </a:prstGeom>
+          <a:noFill/>
+          <a:ln/>
+        </p:spPr>
+        <p:txBody>
+          <a:bodyPr wrap="square" lIns="0" tIns="0" rIns="0" bIns="0" rtlCol="0" anchor="ctr"/>
           <a:lstStyle/>
           <a:p>
             <a:pPr indent="0" marL="0">
@@ -2579,7 +2661,7 @@
                   <a:schemeClr val="bg1"/>
                 </a:solidFill>
               </a:rPr>
-              <a:t>[Member 2]</a:t>
+              <a:t>Ayush Sharma</a:t>
             </a:r>
             <a:endParaRPr lang="en-US" sz="1800" dirty="0"/>
           </a:p>
@@ -2587,90 +2669,18 @@
       </p:sp>
       <p:sp>
         <p:nvSpPr>
-          <p:cNvPr id="23" name="Text 21"/>
-          <p:cNvSpPr txBox="1"/>
-          <p:nvPr/>
-        </p:nvSpPr>
-        <p:spPr>
-          <a:xfrm>
-            <a:off x="3607994" y="5120640"/>
-            <a:ext cx="2144954" cy="320040"/>
-          </a:xfrm>
-          <a:prstGeom prst="rect">
-            <a:avLst/>
-          </a:prstGeom>
-          <a:noFill/>
-          <a:ln/>
-        </p:spPr>
-        <p:txBody>
-          <a:bodyPr wrap="square" lIns="0" tIns="0" rIns="0" bIns="0" rtlCol="0" anchor="t"/>
-          <a:lstStyle/>
-          <a:p>
-            <a:pPr indent="0" marL="0">
-              <a:buNone/>
-            </a:pPr>
-            <a:r>
-              <a:rPr lang="en-US" sz="1400" dirty="0">
-                <a:solidFill>
-                  <a:schemeClr val="bg2"/>
-                </a:solidFill>
-              </a:rPr>
-              <a:t>On-chain tracing</a:t>
-            </a:r>
-            <a:endParaRPr lang="en-US" sz="1400" dirty="0"/>
-          </a:p>
-        </p:txBody>
-      </p:sp>
-      <p:sp>
-        <p:nvSpPr>
-          <p:cNvPr id="24" name="Text 22"/>
-          <p:cNvSpPr txBox="1"/>
-          <p:nvPr/>
-        </p:nvSpPr>
-        <p:spPr>
-          <a:xfrm>
-            <a:off x="3607994" y="5440680"/>
-            <a:ext cx="2144954" cy="274320"/>
-          </a:xfrm>
-          <a:prstGeom prst="rect">
-            <a:avLst/>
-          </a:prstGeom>
-          <a:noFill/>
-          <a:ln/>
-        </p:spPr>
-        <p:txBody>
-          <a:bodyPr wrap="square" lIns="0" tIns="0" rIns="0" bIns="0" rtlCol="0" anchor="t"/>
-          <a:lstStyle/>
-          <a:p>
-            <a:pPr indent="0" marL="0">
-              <a:buNone/>
-            </a:pPr>
-            <a:r>
-              <a:rPr lang="en-US" sz="1200" dirty="0">
-                <a:solidFill>
-                  <a:schemeClr val="accent5"/>
-                </a:solidFill>
-              </a:rPr>
-              <a:t>[College / year]</a:t>
-            </a:r>
-            <a:endParaRPr lang="en-US" sz="1200" dirty="0"/>
-          </a:p>
-        </p:txBody>
-      </p:sp>
-      <p:sp>
-        <p:nvSpPr>
-          <p:cNvPr id="25" name="team2"/>
-          <p:cNvSpPr/>
-          <p:nvPr/>
-        </p:nvSpPr>
-        <p:spPr>
-          <a:xfrm>
-            <a:off x="6210148" y="4526280"/>
-            <a:ext cx="2602154" cy="1325880"/>
+          <p:cNvPr id="25" name="member1"/>
+          <p:cNvSpPr/>
+          <p:nvPr/>
+        </p:nvSpPr>
+        <p:spPr>
+          <a:xfrm>
+            <a:off x="7909560" y="5212080"/>
+            <a:ext cx="3733495" cy="777240"/>
           </a:xfrm>
           <a:prstGeom prst="roundRect">
             <a:avLst>
-              <a:gd name="adj" fmla="val 5517"/>
+              <a:gd name="adj" fmla="val 9412"/>
             </a:avLst>
           </a:prstGeom>
           <a:solidFill>
@@ -2686,23 +2696,72 @@
       </p:sp>
       <p:sp>
         <p:nvSpPr>
-          <p:cNvPr id="26" name="Text 24"/>
-          <p:cNvSpPr txBox="1"/>
-          <p:nvPr/>
-        </p:nvSpPr>
-        <p:spPr>
-          <a:xfrm>
-            <a:off x="6438748" y="4709160"/>
-            <a:ext cx="2144954" cy="365760"/>
-          </a:xfrm>
-          <a:prstGeom prst="rect">
-            <a:avLst/>
-          </a:prstGeom>
-          <a:noFill/>
-          <a:ln/>
-        </p:spPr>
-        <p:txBody>
-          <a:bodyPr wrap="square" lIns="0" tIns="0" rIns="0" bIns="0" rtlCol="0" anchor="t"/>
+          <p:cNvPr id="26" name="mem1-circle"/>
+          <p:cNvSpPr/>
+          <p:nvPr/>
+        </p:nvSpPr>
+        <p:spPr>
+          <a:xfrm>
+            <a:off x="8092440" y="5349240"/>
+            <a:ext cx="502920" cy="502920"/>
+          </a:xfrm>
+          <a:prstGeom prst="ellipse">
+            <a:avLst/>
+          </a:prstGeom>
+          <a:solidFill>
+            <a:schemeClr val="accent2"/>
+          </a:solidFill>
+          <a:ln w="12700">
+            <a:solidFill>
+              <a:schemeClr val="accent2"/>
+            </a:solidFill>
+            <a:prstDash val="solid"/>
+          </a:ln>
+        </p:spPr>
+      </p:sp>
+      <p:pic>
+        <p:nvPicPr>
+          <p:cNvPr id="27" name="mem1-icon" descr="preencoded.png">    </p:cNvPr>
+          <p:cNvPicPr>
+            <a:picLocks noChangeAspect="1"/>
+          </p:cNvPicPr>
+          <p:nvPr/>
+        </p:nvPicPr>
+        <p:blipFill>
+          <a:blip r:embed="rId2"/>
+          <a:stretch>
+            <a:fillRect/>
+          </a:stretch>
+        </p:blipFill>
+        <p:spPr>
+          <a:xfrm>
+            <a:off x="8223199" y="5479999"/>
+            <a:ext cx="241402" cy="241402"/>
+          </a:xfrm>
+          <a:prstGeom prst="rect">
+            <a:avLst/>
+          </a:prstGeom>
+        </p:spPr>
+      </p:pic>
+      <p:sp>
+        <p:nvSpPr>
+          <p:cNvPr id="28" name="Text 24"/>
+          <p:cNvSpPr txBox="1"/>
+          <p:nvPr/>
+        </p:nvSpPr>
+        <p:spPr>
+          <a:xfrm>
+            <a:off x="8778240" y="5212080"/>
+            <a:ext cx="2743200" cy="777240"/>
+          </a:xfrm>
+          <a:prstGeom prst="rect">
+            <a:avLst/>
+          </a:prstGeom>
+          <a:noFill/>
+          <a:ln/>
+        </p:spPr>
+        <p:txBody>
+          <a:bodyPr wrap="square" lIns="0" tIns="0" rIns="0" bIns="0" rtlCol="0" anchor="ctr"/>
           <a:lstStyle/>
           <a:p>
             <a:pPr indent="0" marL="0">
@@ -2714,216 +2773,9 @@
                   <a:schemeClr val="bg1"/>
                 </a:solidFill>
               </a:rPr>
-              <a:t>[Member 3]</a:t>
+              <a:t>Chhaya Attri</a:t>
             </a:r>
             <a:endParaRPr lang="en-US" sz="1800" dirty="0"/>
-          </a:p>
-        </p:txBody>
-      </p:sp>
-      <p:sp>
-        <p:nvSpPr>
-          <p:cNvPr id="27" name="Text 25"/>
-          <p:cNvSpPr txBox="1"/>
-          <p:nvPr/>
-        </p:nvSpPr>
-        <p:spPr>
-          <a:xfrm>
-            <a:off x="6438748" y="5120640"/>
-            <a:ext cx="2144954" cy="320040"/>
-          </a:xfrm>
-          <a:prstGeom prst="rect">
-            <a:avLst/>
-          </a:prstGeom>
-          <a:noFill/>
-          <a:ln/>
-        </p:spPr>
-        <p:txBody>
-          <a:bodyPr wrap="square" lIns="0" tIns="0" rIns="0" bIns="0" rtlCol="0" anchor="t"/>
-          <a:lstStyle/>
-          <a:p>
-            <a:pPr indent="0" marL="0">
-              <a:buNone/>
-            </a:pPr>
-            <a:r>
-              <a:rPr lang="en-US" sz="1400" dirty="0">
-                <a:solidFill>
-                  <a:schemeClr val="bg2"/>
-                </a:solidFill>
-              </a:rPr>
-              <a:t>TinyFish agents, backend</a:t>
-            </a:r>
-            <a:endParaRPr lang="en-US" sz="1400" dirty="0"/>
-          </a:p>
-        </p:txBody>
-      </p:sp>
-      <p:sp>
-        <p:nvSpPr>
-          <p:cNvPr id="28" name="Text 26"/>
-          <p:cNvSpPr txBox="1"/>
-          <p:nvPr/>
-        </p:nvSpPr>
-        <p:spPr>
-          <a:xfrm>
-            <a:off x="6438748" y="5440680"/>
-            <a:ext cx="2144954" cy="274320"/>
-          </a:xfrm>
-          <a:prstGeom prst="rect">
-            <a:avLst/>
-          </a:prstGeom>
-          <a:noFill/>
-          <a:ln/>
-        </p:spPr>
-        <p:txBody>
-          <a:bodyPr wrap="square" lIns="0" tIns="0" rIns="0" bIns="0" rtlCol="0" anchor="t"/>
-          <a:lstStyle/>
-          <a:p>
-            <a:pPr indent="0" marL="0">
-              <a:buNone/>
-            </a:pPr>
-            <a:r>
-              <a:rPr lang="en-US" sz="1200" dirty="0">
-                <a:solidFill>
-                  <a:schemeClr val="accent5"/>
-                </a:solidFill>
-              </a:rPr>
-              <a:t>[College / year]</a:t>
-            </a:r>
-            <a:endParaRPr lang="en-US" sz="1200" dirty="0"/>
-          </a:p>
-        </p:txBody>
-      </p:sp>
-      <p:sp>
-        <p:nvSpPr>
-          <p:cNvPr id="29" name="team3"/>
-          <p:cNvSpPr/>
-          <p:nvPr/>
-        </p:nvSpPr>
-        <p:spPr>
-          <a:xfrm>
-            <a:off x="9040901" y="4526280"/>
-            <a:ext cx="2602154" cy="1325880"/>
-          </a:xfrm>
-          <a:prstGeom prst="roundRect">
-            <a:avLst>
-              <a:gd name="adj" fmla="val 5517"/>
-            </a:avLst>
-          </a:prstGeom>
-          <a:solidFill>
-            <a:schemeClr val="tx2"/>
-          </a:solidFill>
-          <a:ln w="12700">
-            <a:solidFill>
-              <a:schemeClr val="tx2"/>
-            </a:solidFill>
-            <a:prstDash val="solid"/>
-          </a:ln>
-        </p:spPr>
-      </p:sp>
-      <p:sp>
-        <p:nvSpPr>
-          <p:cNvPr id="30" name="Text 28"/>
-          <p:cNvSpPr txBox="1"/>
-          <p:nvPr/>
-        </p:nvSpPr>
-        <p:spPr>
-          <a:xfrm>
-            <a:off x="9269501" y="4709160"/>
-            <a:ext cx="2144954" cy="365760"/>
-          </a:xfrm>
-          <a:prstGeom prst="rect">
-            <a:avLst/>
-          </a:prstGeom>
-          <a:noFill/>
-          <a:ln/>
-        </p:spPr>
-        <p:txBody>
-          <a:bodyPr wrap="square" lIns="0" tIns="0" rIns="0" bIns="0" rtlCol="0" anchor="t"/>
-          <a:lstStyle/>
-          <a:p>
-            <a:pPr indent="0" marL="0">
-              <a:buNone/>
-            </a:pPr>
-            <a:r>
-              <a:rPr lang="en-US" sz="1800" b="1" dirty="0">
-                <a:solidFill>
-                  <a:schemeClr val="bg1"/>
-                </a:solidFill>
-              </a:rPr>
-              <a:t>[Member 4]</a:t>
-            </a:r>
-            <a:endParaRPr lang="en-US" sz="1800" dirty="0"/>
-          </a:p>
-        </p:txBody>
-      </p:sp>
-      <p:sp>
-        <p:nvSpPr>
-          <p:cNvPr id="31" name="Text 29"/>
-          <p:cNvSpPr txBox="1"/>
-          <p:nvPr/>
-        </p:nvSpPr>
-        <p:spPr>
-          <a:xfrm>
-            <a:off x="9269501" y="5120640"/>
-            <a:ext cx="2144954" cy="320040"/>
-          </a:xfrm>
-          <a:prstGeom prst="rect">
-            <a:avLst/>
-          </a:prstGeom>
-          <a:noFill/>
-          <a:ln/>
-        </p:spPr>
-        <p:txBody>
-          <a:bodyPr wrap="square" lIns="0" tIns="0" rIns="0" bIns="0" rtlCol="0" anchor="t"/>
-          <a:lstStyle/>
-          <a:p>
-            <a:pPr indent="0" marL="0">
-              <a:buNone/>
-            </a:pPr>
-            <a:r>
-              <a:rPr lang="en-US" sz="1400" dirty="0">
-                <a:solidFill>
-                  <a:schemeClr val="bg2"/>
-                </a:solidFill>
-              </a:rPr>
-              <a:t>UI/UX and report</a:t>
-            </a:r>
-            <a:endParaRPr lang="en-US" sz="1400" dirty="0"/>
-          </a:p>
-        </p:txBody>
-      </p:sp>
-      <p:sp>
-        <p:nvSpPr>
-          <p:cNvPr id="32" name="Text 30"/>
-          <p:cNvSpPr txBox="1"/>
-          <p:nvPr/>
-        </p:nvSpPr>
-        <p:spPr>
-          <a:xfrm>
-            <a:off x="9269501" y="5440680"/>
-            <a:ext cx="2144954" cy="274320"/>
-          </a:xfrm>
-          <a:prstGeom prst="rect">
-            <a:avLst/>
-          </a:prstGeom>
-          <a:noFill/>
-          <a:ln/>
-        </p:spPr>
-        <p:txBody>
-          <a:bodyPr wrap="square" lIns="0" tIns="0" rIns="0" bIns="0" rtlCol="0" anchor="t"/>
-          <a:lstStyle/>
-          <a:p>
-            <a:pPr indent="0" marL="0">
-              <a:buNone/>
-            </a:pPr>
-            <a:r>
-              <a:rPr lang="en-US" sz="1200" dirty="0">
-                <a:solidFill>
-                  <a:schemeClr val="accent5"/>
-                </a:solidFill>
-              </a:rPr>
-              <a:t>[College / year]</a:t>
-            </a:r>
-            <a:endParaRPr lang="en-US" sz="1200" dirty="0"/>
           </a:p>
         </p:txBody>
       </p:sp>
@@ -3001,8 +2853,8 @@
         </p:nvSpPr>
         <p:spPr>
           <a:xfrm>
-            <a:off x="548640" y="1143000"/>
-            <a:ext cx="11094415" cy="457200"/>
+            <a:off x="548640" y="1051560"/>
+            <a:ext cx="11094415" cy="685800"/>
           </a:xfrm>
           <a:prstGeom prst="rect">
             <a:avLst/>
@@ -3018,14 +2870,14 @@
               <a:buNone/>
             </a:pPr>
             <a:r>
-              <a:rPr lang="en-US" sz="2200" b="1" dirty="0">
+              <a:rPr lang="en-US" sz="1800" b="1" dirty="0">
                 <a:solidFill>
                   <a:schemeClr val="accent1"/>
                 </a:solidFill>
               </a:rPr>
-              <a:t>Funds move within hours. Finding the right exchange takes days.</a:t>
-            </a:r>
-            <a:endParaRPr lang="en-US" sz="2200" dirty="0"/>
+              <a:t>Victims report the scammer's wallet. Investigators can't quickly tell which exchange (VASP) holds the money, so it moves on before it can be frozen.</a:t>
+            </a:r>
+            <a:endParaRPr lang="en-US" sz="1800" dirty="0"/>
           </a:p>
         </p:txBody>
       </p:sp>
@@ -3037,12 +2889,12 @@
         </p:nvSpPr>
         <p:spPr>
           <a:xfrm>
-            <a:off x="548640" y="1874520"/>
-            <a:ext cx="4206240" cy="4160520"/>
+            <a:off x="548640" y="1920240"/>
+            <a:ext cx="3749040" cy="4206240"/>
           </a:xfrm>
           <a:prstGeom prst="roundRect">
             <a:avLst>
-              <a:gd name="adj" fmla="val 1758"/>
+              <a:gd name="adj" fmla="val 1951"/>
             </a:avLst>
           </a:prstGeom>
           <a:solidFill>
@@ -3064,8 +2916,8 @@
         </p:nvSpPr>
         <p:spPr>
           <a:xfrm>
-            <a:off x="868680" y="2148840"/>
-            <a:ext cx="3657600" cy="914400"/>
+            <a:off x="822960" y="2148840"/>
+            <a:ext cx="3291840" cy="868680"/>
           </a:xfrm>
           <a:prstGeom prst="rect">
             <a:avLst/>
@@ -3081,7 +2933,7 @@
               <a:buNone/>
             </a:pPr>
             <a:r>
-              <a:rPr lang="en-US" sz="5400" b="1" dirty="0">
+              <a:rPr lang="en-US" sz="4800" b="1" dirty="0">
                 <a:solidFill>
                   <a:schemeClr val="bg1"/>
                 </a:solidFill>
@@ -3091,7 +2943,7 @@
               </a:rPr>
               <a:t>₹22,845 cr</a:t>
             </a:r>
-            <a:endParaRPr lang="en-US" sz="5400" dirty="0"/>
+            <a:endParaRPr lang="en-US" sz="4800" dirty="0"/>
           </a:p>
         </p:txBody>
       </p:sp>
@@ -3103,8 +2955,8 @@
         </p:nvSpPr>
         <p:spPr>
           <a:xfrm>
-            <a:off x="868680" y="3154680"/>
-            <a:ext cx="3566160" cy="914400"/>
+            <a:off x="822960" y="3063240"/>
+            <a:ext cx="3200400" cy="914400"/>
           </a:xfrm>
           <a:prstGeom prst="rect">
             <a:avLst/>
@@ -3120,14 +2972,14 @@
               <a:buNone/>
             </a:pPr>
             <a:r>
-              <a:rPr lang="en-US" sz="1600" dirty="0">
+              <a:rPr lang="en-US" sz="1500" dirty="0">
                 <a:solidFill>
                   <a:schemeClr val="bg2"/>
                 </a:solidFill>
               </a:rPr>
               <a:t>lost by Indians to cyber fraud in 2024, about 3× the ₹7,465 crore lost in 2023</a:t>
             </a:r>
-            <a:endParaRPr lang="en-US" sz="1600" dirty="0"/>
+            <a:endParaRPr lang="en-US" sz="1500" dirty="0"/>
           </a:p>
         </p:txBody>
       </p:sp>
@@ -3139,8 +2991,8 @@
         </p:nvSpPr>
         <p:spPr>
           <a:xfrm>
-            <a:off x="868680" y="4160520"/>
-            <a:ext cx="3566160" cy="640080"/>
+            <a:off x="822960" y="4069080"/>
+            <a:ext cx="3200400" cy="640080"/>
           </a:xfrm>
           <a:prstGeom prst="rect">
             <a:avLst/>
@@ -3175,8 +3027,8 @@
         </p:nvSpPr>
         <p:spPr>
           <a:xfrm>
-            <a:off x="868680" y="5257800"/>
-            <a:ext cx="3566160" cy="548640"/>
+            <a:off x="822960" y="5394960"/>
+            <a:ext cx="3200400" cy="548640"/>
           </a:xfrm>
           <a:prstGeom prst="rect">
             <a:avLst/>
@@ -3205,14 +3057,14 @@
       </p:sp>
       <p:sp>
         <p:nvSpPr>
-          <p:cNvPr id="9" name="pain0-circle"/>
-          <p:cNvSpPr/>
-          <p:nvPr/>
-        </p:nvSpPr>
-        <p:spPr>
-          <a:xfrm>
-            <a:off x="5074920" y="1947672"/>
-            <a:ext cx="594360" cy="594360"/>
+          <p:cNvPr id="9" name="grp0-circle"/>
+          <p:cNvSpPr/>
+          <p:nvPr/>
+        </p:nvSpPr>
+        <p:spPr>
+          <a:xfrm>
+            <a:off x="4572000" y="1965960"/>
+            <a:ext cx="548640" cy="548640"/>
           </a:xfrm>
           <a:prstGeom prst="ellipse">
             <a:avLst/>
@@ -3230,7 +3082,7 @@
       </p:sp>
       <p:pic>
         <p:nvPicPr>
-          <p:cNvPr id="10" name="pain0-icon" descr="preencoded.png">    </p:cNvPr>
+          <p:cNvPr id="10" name="grp0-icon" descr="preencoded.png">    </p:cNvPr>
           <p:cNvPicPr>
             <a:picLocks noChangeAspect="1"/>
           </p:cNvPicPr>
@@ -3244,8 +3096,8 @@
         </p:blipFill>
         <p:spPr>
           <a:xfrm>
-            <a:off x="5229454" y="2102206"/>
-            <a:ext cx="285293" cy="285293"/>
+            <a:off x="4714646" y="2108606"/>
+            <a:ext cx="263347" cy="263347"/>
           </a:xfrm>
           <a:prstGeom prst="rect">
             <a:avLst/>
@@ -3260,8 +3112,8 @@
         </p:nvSpPr>
         <p:spPr>
           <a:xfrm>
-            <a:off x="5897880" y="1874520"/>
-            <a:ext cx="5669280" cy="365760"/>
+            <a:off x="5303520" y="1920240"/>
+            <a:ext cx="6309360" cy="347472"/>
           </a:xfrm>
           <a:prstGeom prst="rect">
             <a:avLst/>
@@ -3277,73 +3129,478 @@
               <a:buNone/>
             </a:pPr>
             <a:r>
-              <a:rPr lang="en-US" sz="1700" b="1" dirty="0">
+              <a:rPr lang="en-US" sz="1600" b="1" dirty="0">
                 <a:solidFill>
                   <a:schemeClr val="tx1"/>
                 </a:solidFill>
               </a:rPr>
-              <a:t>Who is hurt</a:t>
-            </a:r>
-            <a:endParaRPr lang="en-US" sz="1700" dirty="0"/>
-          </a:p>
-        </p:txBody>
-      </p:sp>
-      <p:sp>
-        <p:nvSpPr>
-          <p:cNvPr id="12" name="Text 9"/>
-          <p:cNvSpPr txBox="1"/>
-          <p:nvPr/>
-        </p:nvSpPr>
-        <p:spPr>
-          <a:xfrm>
-            <a:off x="5897880" y="2258568"/>
-            <a:ext cx="5669280" cy="594360"/>
-          </a:xfrm>
-          <a:prstGeom prst="rect">
-            <a:avLst/>
-          </a:prstGeom>
-          <a:noFill/>
-          <a:ln/>
-        </p:spPr>
-        <p:txBody>
-          <a:bodyPr wrap="square" lIns="0" tIns="0" rIns="0" bIns="0" rtlCol="0" anchor="t"/>
-          <a:lstStyle/>
-          <a:p>
-            <a:pPr indent="0" marL="0">
-              <a:buNone/>
-            </a:pPr>
-            <a:r>
-              <a:rPr lang="en-US" sz="1400" dirty="0">
-                <a:solidFill>
-                  <a:schemeClr val="tx2"/>
-                </a:solidFill>
-              </a:rPr>
-              <a:t>Victims of investment, task, sextortion, phishing and ransomware scams paid in crypto</a:t>
-            </a:r>
-            <a:endParaRPr lang="en-US" sz="1400" dirty="0"/>
-          </a:p>
-        </p:txBody>
-      </p:sp>
-      <p:sp>
-        <p:nvSpPr>
-          <p:cNvPr id="13" name="pain1-circle"/>
-          <p:cNvSpPr/>
-          <p:nvPr/>
-        </p:nvSpPr>
-        <p:spPr>
-          <a:xfrm>
-            <a:off x="5074920" y="3017520"/>
-            <a:ext cx="594360" cy="594360"/>
+              <a:t>Fraud types</a:t>
+            </a:r>
+            <a:endParaRPr lang="en-US" sz="1600" dirty="0"/>
+          </a:p>
+        </p:txBody>
+      </p:sp>
+      <p:sp>
+        <p:nvSpPr>
+          <p:cNvPr id="12" name="chip0-0"/>
+          <p:cNvSpPr/>
+          <p:nvPr/>
+        </p:nvSpPr>
+        <p:spPr>
+          <a:xfrm>
+            <a:off x="5303520" y="2359152"/>
+            <a:ext cx="859536" cy="329184"/>
+          </a:xfrm>
+          <a:prstGeom prst="roundRect">
+            <a:avLst>
+              <a:gd name="adj" fmla="val 50000"/>
+            </a:avLst>
+          </a:prstGeom>
+          <a:solidFill>
+            <a:schemeClr val="accent4"/>
+          </a:solidFill>
+          <a:ln w="12700">
+            <a:solidFill>
+              <a:schemeClr val="accent4"/>
+            </a:solidFill>
+            <a:prstDash val="solid"/>
+          </a:ln>
+        </p:spPr>
+      </p:sp>
+      <p:sp>
+        <p:nvSpPr>
+          <p:cNvPr id="13" name="Text 10"/>
+          <p:cNvSpPr txBox="1"/>
+          <p:nvPr/>
+        </p:nvSpPr>
+        <p:spPr>
+          <a:xfrm>
+            <a:off x="5303520" y="2359152"/>
+            <a:ext cx="859536" cy="329184"/>
+          </a:xfrm>
+          <a:prstGeom prst="rect">
+            <a:avLst/>
+          </a:prstGeom>
+          <a:noFill/>
+          <a:ln/>
+        </p:spPr>
+        <p:txBody>
+          <a:bodyPr wrap="square" lIns="0" tIns="0" rIns="0" bIns="0" rtlCol="0" anchor="ctr"/>
+          <a:lstStyle/>
+          <a:p>
+            <a:pPr algn="ctr" indent="0" marL="0">
+              <a:buNone/>
+            </a:pPr>
+            <a:r>
+              <a:rPr lang="en-US" sz="1100" b="1" dirty="0">
+                <a:solidFill>
+                  <a:schemeClr val="bg1"/>
+                </a:solidFill>
+              </a:rPr>
+              <a:t>Investment</a:t>
+            </a:r>
+            <a:endParaRPr lang="en-US" sz="1100" dirty="0"/>
+          </a:p>
+        </p:txBody>
+      </p:sp>
+      <p:sp>
+        <p:nvSpPr>
+          <p:cNvPr id="14" name="chip0-1"/>
+          <p:cNvSpPr/>
+          <p:nvPr/>
+        </p:nvSpPr>
+        <p:spPr>
+          <a:xfrm>
+            <a:off x="6236208" y="2359152"/>
+            <a:ext cx="859536" cy="329184"/>
+          </a:xfrm>
+          <a:prstGeom prst="roundRect">
+            <a:avLst>
+              <a:gd name="adj" fmla="val 50000"/>
+            </a:avLst>
+          </a:prstGeom>
+          <a:solidFill>
+            <a:schemeClr val="accent4"/>
+          </a:solidFill>
+          <a:ln w="12700">
+            <a:solidFill>
+              <a:schemeClr val="accent4"/>
+            </a:solidFill>
+            <a:prstDash val="solid"/>
+          </a:ln>
+        </p:spPr>
+      </p:sp>
+      <p:sp>
+        <p:nvSpPr>
+          <p:cNvPr id="15" name="Text 12"/>
+          <p:cNvSpPr txBox="1"/>
+          <p:nvPr/>
+        </p:nvSpPr>
+        <p:spPr>
+          <a:xfrm>
+            <a:off x="6236208" y="2359152"/>
+            <a:ext cx="859536" cy="329184"/>
+          </a:xfrm>
+          <a:prstGeom prst="rect">
+            <a:avLst/>
+          </a:prstGeom>
+          <a:noFill/>
+          <a:ln/>
+        </p:spPr>
+        <p:txBody>
+          <a:bodyPr wrap="square" lIns="0" tIns="0" rIns="0" bIns="0" rtlCol="0" anchor="ctr"/>
+          <a:lstStyle/>
+          <a:p>
+            <a:pPr algn="ctr" indent="0" marL="0">
+              <a:buNone/>
+            </a:pPr>
+            <a:r>
+              <a:rPr lang="en-US" sz="1100" b="1" dirty="0">
+                <a:solidFill>
+                  <a:schemeClr val="bg1"/>
+                </a:solidFill>
+              </a:rPr>
+              <a:t>Task-based</a:t>
+            </a:r>
+            <a:endParaRPr lang="en-US" sz="1100" dirty="0"/>
+          </a:p>
+        </p:txBody>
+      </p:sp>
+      <p:sp>
+        <p:nvSpPr>
+          <p:cNvPr id="16" name="chip0-2"/>
+          <p:cNvSpPr/>
+          <p:nvPr/>
+        </p:nvSpPr>
+        <p:spPr>
+          <a:xfrm>
+            <a:off x="7168896" y="2359152"/>
+            <a:ext cx="859536" cy="329184"/>
+          </a:xfrm>
+          <a:prstGeom prst="roundRect">
+            <a:avLst>
+              <a:gd name="adj" fmla="val 50000"/>
+            </a:avLst>
+          </a:prstGeom>
+          <a:solidFill>
+            <a:schemeClr val="accent4"/>
+          </a:solidFill>
+          <a:ln w="12700">
+            <a:solidFill>
+              <a:schemeClr val="accent4"/>
+            </a:solidFill>
+            <a:prstDash val="solid"/>
+          </a:ln>
+        </p:spPr>
+      </p:sp>
+      <p:sp>
+        <p:nvSpPr>
+          <p:cNvPr id="17" name="Text 14"/>
+          <p:cNvSpPr txBox="1"/>
+          <p:nvPr/>
+        </p:nvSpPr>
+        <p:spPr>
+          <a:xfrm>
+            <a:off x="7168896" y="2359152"/>
+            <a:ext cx="859536" cy="329184"/>
+          </a:xfrm>
+          <a:prstGeom prst="rect">
+            <a:avLst/>
+          </a:prstGeom>
+          <a:noFill/>
+          <a:ln/>
+        </p:spPr>
+        <p:txBody>
+          <a:bodyPr wrap="square" lIns="0" tIns="0" rIns="0" bIns="0" rtlCol="0" anchor="ctr"/>
+          <a:lstStyle/>
+          <a:p>
+            <a:pPr algn="ctr" indent="0" marL="0">
+              <a:buNone/>
+            </a:pPr>
+            <a:r>
+              <a:rPr lang="en-US" sz="1100" b="1" dirty="0">
+                <a:solidFill>
+                  <a:schemeClr val="bg1"/>
+                </a:solidFill>
+              </a:rPr>
+              <a:t>Sextortion</a:t>
+            </a:r>
+            <a:endParaRPr lang="en-US" sz="1100" dirty="0"/>
+          </a:p>
+        </p:txBody>
+      </p:sp>
+      <p:sp>
+        <p:nvSpPr>
+          <p:cNvPr id="18" name="chip0-3"/>
+          <p:cNvSpPr/>
+          <p:nvPr/>
+        </p:nvSpPr>
+        <p:spPr>
+          <a:xfrm>
+            <a:off x="8101584" y="2359152"/>
+            <a:ext cx="859536" cy="329184"/>
+          </a:xfrm>
+          <a:prstGeom prst="roundRect">
+            <a:avLst>
+              <a:gd name="adj" fmla="val 50000"/>
+            </a:avLst>
+          </a:prstGeom>
+          <a:solidFill>
+            <a:schemeClr val="accent4"/>
+          </a:solidFill>
+          <a:ln w="12700">
+            <a:solidFill>
+              <a:schemeClr val="accent4"/>
+            </a:solidFill>
+            <a:prstDash val="solid"/>
+          </a:ln>
+        </p:spPr>
+      </p:sp>
+      <p:sp>
+        <p:nvSpPr>
+          <p:cNvPr id="19" name="Text 16"/>
+          <p:cNvSpPr txBox="1"/>
+          <p:nvPr/>
+        </p:nvSpPr>
+        <p:spPr>
+          <a:xfrm>
+            <a:off x="8101584" y="2359152"/>
+            <a:ext cx="859536" cy="329184"/>
+          </a:xfrm>
+          <a:prstGeom prst="rect">
+            <a:avLst/>
+          </a:prstGeom>
+          <a:noFill/>
+          <a:ln/>
+        </p:spPr>
+        <p:txBody>
+          <a:bodyPr wrap="square" lIns="0" tIns="0" rIns="0" bIns="0" rtlCol="0" anchor="ctr"/>
+          <a:lstStyle/>
+          <a:p>
+            <a:pPr algn="ctr" indent="0" marL="0">
+              <a:buNone/>
+            </a:pPr>
+            <a:r>
+              <a:rPr lang="en-US" sz="1100" b="1" dirty="0">
+                <a:solidFill>
+                  <a:schemeClr val="bg1"/>
+                </a:solidFill>
+              </a:rPr>
+              <a:t>Ransomware</a:t>
+            </a:r>
+            <a:endParaRPr lang="en-US" sz="1100" dirty="0"/>
+          </a:p>
+        </p:txBody>
+      </p:sp>
+      <p:sp>
+        <p:nvSpPr>
+          <p:cNvPr id="20" name="chip0-4"/>
+          <p:cNvSpPr/>
+          <p:nvPr/>
+        </p:nvSpPr>
+        <p:spPr>
+          <a:xfrm>
+            <a:off x="9034272" y="2359152"/>
+            <a:ext cx="724205" cy="329184"/>
+          </a:xfrm>
+          <a:prstGeom prst="roundRect">
+            <a:avLst>
+              <a:gd name="adj" fmla="val 50000"/>
+            </a:avLst>
+          </a:prstGeom>
+          <a:solidFill>
+            <a:schemeClr val="accent4"/>
+          </a:solidFill>
+          <a:ln w="12700">
+            <a:solidFill>
+              <a:schemeClr val="accent4"/>
+            </a:solidFill>
+            <a:prstDash val="solid"/>
+          </a:ln>
+        </p:spPr>
+      </p:sp>
+      <p:sp>
+        <p:nvSpPr>
+          <p:cNvPr id="21" name="Text 18"/>
+          <p:cNvSpPr txBox="1"/>
+          <p:nvPr/>
+        </p:nvSpPr>
+        <p:spPr>
+          <a:xfrm>
+            <a:off x="9034272" y="2359152"/>
+            <a:ext cx="724205" cy="329184"/>
+          </a:xfrm>
+          <a:prstGeom prst="rect">
+            <a:avLst/>
+          </a:prstGeom>
+          <a:noFill/>
+          <a:ln/>
+        </p:spPr>
+        <p:txBody>
+          <a:bodyPr wrap="square" lIns="0" tIns="0" rIns="0" bIns="0" rtlCol="0" anchor="ctr"/>
+          <a:lstStyle/>
+          <a:p>
+            <a:pPr algn="ctr" indent="0" marL="0">
+              <a:buNone/>
+            </a:pPr>
+            <a:r>
+              <a:rPr lang="en-US" sz="1100" b="1" dirty="0">
+                <a:solidFill>
+                  <a:schemeClr val="bg1"/>
+                </a:solidFill>
+              </a:rPr>
+              <a:t>Phishing</a:t>
+            </a:r>
+            <a:endParaRPr lang="en-US" sz="1100" dirty="0"/>
+          </a:p>
+        </p:txBody>
+      </p:sp>
+      <p:sp>
+        <p:nvSpPr>
+          <p:cNvPr id="22" name="chip0-5"/>
+          <p:cNvSpPr/>
+          <p:nvPr/>
+        </p:nvSpPr>
+        <p:spPr>
+          <a:xfrm>
+            <a:off x="9831629" y="2359152"/>
+            <a:ext cx="656539" cy="329184"/>
+          </a:xfrm>
+          <a:prstGeom prst="roundRect">
+            <a:avLst>
+              <a:gd name="adj" fmla="val 50000"/>
+            </a:avLst>
+          </a:prstGeom>
+          <a:solidFill>
+            <a:schemeClr val="accent4"/>
+          </a:solidFill>
+          <a:ln w="12700">
+            <a:solidFill>
+              <a:schemeClr val="accent4"/>
+            </a:solidFill>
+            <a:prstDash val="solid"/>
+          </a:ln>
+        </p:spPr>
+      </p:sp>
+      <p:sp>
+        <p:nvSpPr>
+          <p:cNvPr id="23" name="Text 20"/>
+          <p:cNvSpPr txBox="1"/>
+          <p:nvPr/>
+        </p:nvSpPr>
+        <p:spPr>
+          <a:xfrm>
+            <a:off x="9831629" y="2359152"/>
+            <a:ext cx="656539" cy="329184"/>
+          </a:xfrm>
+          <a:prstGeom prst="rect">
+            <a:avLst/>
+          </a:prstGeom>
+          <a:noFill/>
+          <a:ln/>
+        </p:spPr>
+        <p:txBody>
+          <a:bodyPr wrap="square" lIns="0" tIns="0" rIns="0" bIns="0" rtlCol="0" anchor="ctr"/>
+          <a:lstStyle/>
+          <a:p>
+            <a:pPr algn="ctr" indent="0" marL="0">
+              <a:buNone/>
+            </a:pPr>
+            <a:r>
+              <a:rPr lang="en-US" sz="1100" b="1" dirty="0">
+                <a:solidFill>
+                  <a:schemeClr val="bg1"/>
+                </a:solidFill>
+              </a:rPr>
+              <a:t>Darknet</a:t>
+            </a:r>
+            <a:endParaRPr lang="en-US" sz="1100" dirty="0"/>
+          </a:p>
+        </p:txBody>
+      </p:sp>
+      <p:sp>
+        <p:nvSpPr>
+          <p:cNvPr id="24" name="chip0-6"/>
+          <p:cNvSpPr/>
+          <p:nvPr/>
+        </p:nvSpPr>
+        <p:spPr>
+          <a:xfrm>
+            <a:off x="10561320" y="2359152"/>
+            <a:ext cx="791870" cy="329184"/>
+          </a:xfrm>
+          <a:prstGeom prst="roundRect">
+            <a:avLst>
+              <a:gd name="adj" fmla="val 50000"/>
+            </a:avLst>
+          </a:prstGeom>
+          <a:solidFill>
+            <a:schemeClr val="accent4"/>
+          </a:solidFill>
+          <a:ln w="12700">
+            <a:solidFill>
+              <a:schemeClr val="accent4"/>
+            </a:solidFill>
+            <a:prstDash val="solid"/>
+          </a:ln>
+        </p:spPr>
+      </p:sp>
+      <p:sp>
+        <p:nvSpPr>
+          <p:cNvPr id="25" name="Text 22"/>
+          <p:cNvSpPr txBox="1"/>
+          <p:nvPr/>
+        </p:nvSpPr>
+        <p:spPr>
+          <a:xfrm>
+            <a:off x="10561320" y="2359152"/>
+            <a:ext cx="791870" cy="329184"/>
+          </a:xfrm>
+          <a:prstGeom prst="rect">
+            <a:avLst/>
+          </a:prstGeom>
+          <a:noFill/>
+          <a:ln/>
+        </p:spPr>
+        <p:txBody>
+          <a:bodyPr wrap="square" lIns="0" tIns="0" rIns="0" bIns="0" rtlCol="0" anchor="ctr"/>
+          <a:lstStyle/>
+          <a:p>
+            <a:pPr algn="ctr" indent="0" marL="0">
+              <a:buNone/>
+            </a:pPr>
+            <a:r>
+              <a:rPr lang="en-US" sz="1100" b="1" dirty="0">
+                <a:solidFill>
+                  <a:schemeClr val="bg1"/>
+                </a:solidFill>
+              </a:rPr>
+              <a:t>Organised</a:t>
+            </a:r>
+            <a:endParaRPr lang="en-US" sz="1100" dirty="0"/>
+          </a:p>
+        </p:txBody>
+      </p:sp>
+      <p:sp>
+        <p:nvSpPr>
+          <p:cNvPr id="26" name="grp1-circle"/>
+          <p:cNvSpPr/>
+          <p:nvPr/>
+        </p:nvSpPr>
+        <p:spPr>
+          <a:xfrm>
+            <a:off x="4572000" y="3035808"/>
+            <a:ext cx="548640" cy="548640"/>
           </a:xfrm>
           <a:prstGeom prst="ellipse">
             <a:avLst/>
           </a:prstGeom>
           <a:solidFill>
-            <a:schemeClr val="accent4"/>
+            <a:schemeClr val="accent1"/>
           </a:solidFill>
           <a:ln w="12700">
             <a:solidFill>
-              <a:schemeClr val="accent4"/>
+              <a:schemeClr val="accent1"/>
             </a:solidFill>
             <a:prstDash val="solid"/>
           </a:ln>
@@ -3351,7 +3608,7 @@
       </p:sp>
       <p:pic>
         <p:nvPicPr>
-          <p:cNvPr id="14" name="pain1-icon" descr="preencoded.png">    </p:cNvPr>
+          <p:cNvPr id="27" name="grp1-icon" descr="preencoded.png">    </p:cNvPr>
           <p:cNvPicPr>
             <a:picLocks noChangeAspect="1"/>
           </p:cNvPicPr>
@@ -3365,8 +3622,8 @@
         </p:blipFill>
         <p:spPr>
           <a:xfrm>
-            <a:off x="5229454" y="3172054"/>
-            <a:ext cx="285293" cy="285293"/>
+            <a:off x="4714646" y="3178454"/>
+            <a:ext cx="263347" cy="263347"/>
           </a:xfrm>
           <a:prstGeom prst="rect">
             <a:avLst/>
@@ -3375,14 +3632,14 @@
       </p:pic>
       <p:sp>
         <p:nvSpPr>
-          <p:cNvPr id="15" name="Text 11"/>
-          <p:cNvSpPr txBox="1"/>
-          <p:nvPr/>
-        </p:nvSpPr>
-        <p:spPr>
-          <a:xfrm>
-            <a:off x="5897880" y="2944368"/>
-            <a:ext cx="5669280" cy="365760"/>
+          <p:cNvPr id="28" name="Text 24"/>
+          <p:cNvSpPr txBox="1"/>
+          <p:nvPr/>
+        </p:nvSpPr>
+        <p:spPr>
+          <a:xfrm>
+            <a:off x="5303520" y="2990088"/>
+            <a:ext cx="6309360" cy="347472"/>
           </a:xfrm>
           <a:prstGeom prst="rect">
             <a:avLst/>
@@ -3398,73 +3655,226 @@
               <a:buNone/>
             </a:pPr>
             <a:r>
-              <a:rPr lang="en-US" sz="1700" b="1" dirty="0">
+              <a:rPr lang="en-US" sz="1600" b="1" dirty="0">
                 <a:solidFill>
                   <a:schemeClr val="tx1"/>
                 </a:solidFill>
               </a:rPr>
-              <a:t>How the money hides</a:t>
-            </a:r>
-            <a:endParaRPr lang="en-US" sz="1700" dirty="0"/>
-          </a:p>
-        </p:txBody>
-      </p:sp>
-      <p:sp>
-        <p:nvSpPr>
-          <p:cNvPr id="16" name="Text 12"/>
-          <p:cNvSpPr txBox="1"/>
-          <p:nvPr/>
-        </p:nvSpPr>
-        <p:spPr>
-          <a:xfrm>
-            <a:off x="5897880" y="3328416"/>
-            <a:ext cx="5669280" cy="594360"/>
-          </a:xfrm>
-          <a:prstGeom prst="rect">
-            <a:avLst/>
-          </a:prstGeom>
-          <a:noFill/>
-          <a:ln/>
-        </p:spPr>
-        <p:txBody>
-          <a:bodyPr wrap="square" lIns="0" tIns="0" rIns="0" bIns="0" rtlCol="0" anchor="t"/>
-          <a:lstStyle/>
-          <a:p>
-            <a:pPr indent="0" marL="0">
-              <a:buNone/>
-            </a:pPr>
-            <a:r>
-              <a:rPr lang="en-US" sz="1400" dirty="0">
-                <a:solidFill>
-                  <a:schemeClr val="tx2"/>
-                </a:solidFill>
-              </a:rPr>
-              <a:t>Burner wallets and fast hops (layering) hide the trail across chains</a:t>
-            </a:r>
-            <a:endParaRPr lang="en-US" sz="1400" dirty="0"/>
-          </a:p>
-        </p:txBody>
-      </p:sp>
-      <p:sp>
-        <p:nvSpPr>
-          <p:cNvPr id="17" name="pain2-circle"/>
-          <p:cNvSpPr/>
-          <p:nvPr/>
-        </p:nvSpPr>
-        <p:spPr>
-          <a:xfrm>
-            <a:off x="5074920" y="4087368"/>
-            <a:ext cx="594360" cy="594360"/>
+              <a:t>Reported wallets are</a:t>
+            </a:r>
+            <a:endParaRPr lang="en-US" sz="1600" dirty="0"/>
+          </a:p>
+        </p:txBody>
+      </p:sp>
+      <p:sp>
+        <p:nvSpPr>
+          <p:cNvPr id="29" name="chip1-0"/>
+          <p:cNvSpPr/>
+          <p:nvPr/>
+        </p:nvSpPr>
+        <p:spPr>
+          <a:xfrm>
+            <a:off x="5303520" y="3429000"/>
+            <a:ext cx="1062533" cy="329184"/>
+          </a:xfrm>
+          <a:prstGeom prst="roundRect">
+            <a:avLst>
+              <a:gd name="adj" fmla="val 50000"/>
+            </a:avLst>
+          </a:prstGeom>
+          <a:solidFill>
+            <a:schemeClr val="accent1"/>
+          </a:solidFill>
+          <a:ln w="12700">
+            <a:solidFill>
+              <a:schemeClr val="accent1"/>
+            </a:solidFill>
+            <a:prstDash val="solid"/>
+          </a:ln>
+        </p:spPr>
+      </p:sp>
+      <p:sp>
+        <p:nvSpPr>
+          <p:cNvPr id="30" name="Text 26"/>
+          <p:cNvSpPr txBox="1"/>
+          <p:nvPr/>
+        </p:nvSpPr>
+        <p:spPr>
+          <a:xfrm>
+            <a:off x="5303520" y="3429000"/>
+            <a:ext cx="1062533" cy="329184"/>
+          </a:xfrm>
+          <a:prstGeom prst="rect">
+            <a:avLst/>
+          </a:prstGeom>
+          <a:noFill/>
+          <a:ln/>
+        </p:spPr>
+        <p:txBody>
+          <a:bodyPr wrap="square" lIns="0" tIns="0" rIns="0" bIns="0" rtlCol="0" anchor="ctr"/>
+          <a:lstStyle/>
+          <a:p>
+            <a:pPr algn="ctr" indent="0" marL="0">
+              <a:buNone/>
+            </a:pPr>
+            <a:r>
+              <a:rPr lang="en-US" sz="1100" b="1" dirty="0">
+                <a:solidFill>
+                  <a:schemeClr val="bg1"/>
+                </a:solidFill>
+              </a:rPr>
+              <a:t>Non-custodial</a:t>
+            </a:r>
+            <a:endParaRPr lang="en-US" sz="1100" dirty="0"/>
+          </a:p>
+        </p:txBody>
+      </p:sp>
+      <p:sp>
+        <p:nvSpPr>
+          <p:cNvPr id="31" name="chip1-1"/>
+          <p:cNvSpPr/>
+          <p:nvPr/>
+        </p:nvSpPr>
+        <p:spPr>
+          <a:xfrm>
+            <a:off x="6439205" y="3429000"/>
+            <a:ext cx="1333195" cy="329184"/>
+          </a:xfrm>
+          <a:prstGeom prst="roundRect">
+            <a:avLst>
+              <a:gd name="adj" fmla="val 50000"/>
+            </a:avLst>
+          </a:prstGeom>
+          <a:solidFill>
+            <a:schemeClr val="accent1"/>
+          </a:solidFill>
+          <a:ln w="12700">
+            <a:solidFill>
+              <a:schemeClr val="accent1"/>
+            </a:solidFill>
+            <a:prstDash val="solid"/>
+          </a:ln>
+        </p:spPr>
+      </p:sp>
+      <p:sp>
+        <p:nvSpPr>
+          <p:cNvPr id="32" name="Text 28"/>
+          <p:cNvSpPr txBox="1"/>
+          <p:nvPr/>
+        </p:nvSpPr>
+        <p:spPr>
+          <a:xfrm>
+            <a:off x="6439205" y="3429000"/>
+            <a:ext cx="1333195" cy="329184"/>
+          </a:xfrm>
+          <a:prstGeom prst="rect">
+            <a:avLst/>
+          </a:prstGeom>
+          <a:noFill/>
+          <a:ln/>
+        </p:spPr>
+        <p:txBody>
+          <a:bodyPr wrap="square" lIns="0" tIns="0" rIns="0" bIns="0" rtlCol="0" anchor="ctr"/>
+          <a:lstStyle/>
+          <a:p>
+            <a:pPr algn="ctr" indent="0" marL="0">
+              <a:buNone/>
+            </a:pPr>
+            <a:r>
+              <a:rPr lang="en-US" sz="1100" b="1" dirty="0">
+                <a:solidFill>
+                  <a:schemeClr val="bg1"/>
+                </a:solidFill>
+              </a:rPr>
+              <a:t>Temporary burners</a:t>
+            </a:r>
+            <a:endParaRPr lang="en-US" sz="1100" dirty="0"/>
+          </a:p>
+        </p:txBody>
+      </p:sp>
+      <p:sp>
+        <p:nvSpPr>
+          <p:cNvPr id="33" name="chip1-2"/>
+          <p:cNvSpPr/>
+          <p:nvPr/>
+        </p:nvSpPr>
+        <p:spPr>
+          <a:xfrm>
+            <a:off x="7845552" y="3429000"/>
+            <a:ext cx="1739189" cy="329184"/>
+          </a:xfrm>
+          <a:prstGeom prst="roundRect">
+            <a:avLst>
+              <a:gd name="adj" fmla="val 50000"/>
+            </a:avLst>
+          </a:prstGeom>
+          <a:solidFill>
+            <a:schemeClr val="accent1"/>
+          </a:solidFill>
+          <a:ln w="12700">
+            <a:solidFill>
+              <a:schemeClr val="accent1"/>
+            </a:solidFill>
+            <a:prstDash val="solid"/>
+          </a:ln>
+        </p:spPr>
+      </p:sp>
+      <p:sp>
+        <p:nvSpPr>
+          <p:cNvPr id="34" name="Text 30"/>
+          <p:cNvSpPr txBox="1"/>
+          <p:nvPr/>
+        </p:nvSpPr>
+        <p:spPr>
+          <a:xfrm>
+            <a:off x="7845552" y="3429000"/>
+            <a:ext cx="1739189" cy="329184"/>
+          </a:xfrm>
+          <a:prstGeom prst="rect">
+            <a:avLst/>
+          </a:prstGeom>
+          <a:noFill/>
+          <a:ln/>
+        </p:spPr>
+        <p:txBody>
+          <a:bodyPr wrap="square" lIns="0" tIns="0" rIns="0" bIns="0" rtlCol="0" anchor="ctr"/>
+          <a:lstStyle/>
+          <a:p>
+            <a:pPr algn="ctr" indent="0" marL="0">
+              <a:buNone/>
+            </a:pPr>
+            <a:r>
+              <a:rPr lang="en-US" sz="1100" b="1" dirty="0">
+                <a:solidFill>
+                  <a:schemeClr val="bg1"/>
+                </a:solidFill>
+              </a:rPr>
+              <a:t>Layering intermediaries</a:t>
+            </a:r>
+            <a:endParaRPr lang="en-US" sz="1100" dirty="0"/>
+          </a:p>
+        </p:txBody>
+      </p:sp>
+      <p:sp>
+        <p:nvSpPr>
+          <p:cNvPr id="35" name="grp2-circle"/>
+          <p:cNvSpPr/>
+          <p:nvPr/>
+        </p:nvSpPr>
+        <p:spPr>
+          <a:xfrm>
+            <a:off x="4572000" y="4105656"/>
+            <a:ext cx="548640" cy="548640"/>
           </a:xfrm>
           <a:prstGeom prst="ellipse">
             <a:avLst/>
           </a:prstGeom>
           <a:solidFill>
-            <a:schemeClr val="accent4"/>
+            <a:schemeClr val="accent2"/>
           </a:solidFill>
           <a:ln w="12700">
             <a:solidFill>
-              <a:schemeClr val="accent4"/>
+              <a:schemeClr val="accent2"/>
             </a:solidFill>
             <a:prstDash val="solid"/>
           </a:ln>
@@ -3472,7 +3882,7 @@
       </p:sp>
       <p:pic>
         <p:nvPicPr>
-          <p:cNvPr id="18" name="pain2-icon" descr="preencoded.png">    </p:cNvPr>
+          <p:cNvPr id="36" name="grp2-icon" descr="preencoded.png">    </p:cNvPr>
           <p:cNvPicPr>
             <a:picLocks noChangeAspect="1"/>
           </p:cNvPicPr>
@@ -3486,8 +3896,8 @@
         </p:blipFill>
         <p:spPr>
           <a:xfrm>
-            <a:off x="5229454" y="4241902"/>
-            <a:ext cx="285293" cy="285293"/>
+            <a:off x="4714646" y="4248302"/>
+            <a:ext cx="263347" cy="263347"/>
           </a:xfrm>
           <a:prstGeom prst="rect">
             <a:avLst/>
@@ -3496,14 +3906,14 @@
       </p:pic>
       <p:sp>
         <p:nvSpPr>
-          <p:cNvPr id="19" name="Text 14"/>
-          <p:cNvSpPr txBox="1"/>
-          <p:nvPr/>
-        </p:nvSpPr>
-        <p:spPr>
-          <a:xfrm>
-            <a:off x="5897880" y="4014216"/>
-            <a:ext cx="5669280" cy="365760"/>
+          <p:cNvPr id="37" name="Text 32"/>
+          <p:cNvSpPr txBox="1"/>
+          <p:nvPr/>
+        </p:nvSpPr>
+        <p:spPr>
+          <a:xfrm>
+            <a:off x="5303520" y="4059936"/>
+            <a:ext cx="6309360" cy="347472"/>
           </a:xfrm>
           <a:prstGeom prst="rect">
             <a:avLst/>
@@ -3519,73 +3929,352 @@
               <a:buNone/>
             </a:pPr>
             <a:r>
-              <a:rPr lang="en-US" sz="1700" b="1" dirty="0">
+              <a:rPr lang="en-US" sz="1600" b="1" dirty="0">
                 <a:solidFill>
                   <a:schemeClr val="tx1"/>
                 </a:solidFill>
               </a:rPr>
-              <a:t>Why investigators get stuck</a:t>
-            </a:r>
-            <a:endParaRPr lang="en-US" sz="1700" dirty="0"/>
-          </a:p>
-        </p:txBody>
-      </p:sp>
-      <p:sp>
-        <p:nvSpPr>
-          <p:cNvPr id="20" name="Text 15"/>
-          <p:cNvSpPr txBox="1"/>
-          <p:nvPr/>
-        </p:nvSpPr>
-        <p:spPr>
-          <a:xfrm>
-            <a:off x="5897880" y="4398264"/>
-            <a:ext cx="5669280" cy="594360"/>
-          </a:xfrm>
-          <a:prstGeom prst="rect">
-            <a:avLst/>
-          </a:prstGeom>
-          <a:noFill/>
-          <a:ln/>
-        </p:spPr>
-        <p:txBody>
-          <a:bodyPr wrap="square" lIns="0" tIns="0" rIns="0" bIns="0" rtlCol="0" anchor="t"/>
-          <a:lstStyle/>
-          <a:p>
-            <a:pPr indent="0" marL="0">
-              <a:buNone/>
-            </a:pPr>
-            <a:r>
-              <a:rPr lang="en-US" sz="1400" dirty="0">
-                <a:solidFill>
-                  <a:schemeClr val="tx2"/>
-                </a:solidFill>
-              </a:rPr>
-              <a:t>Only the exchange can freeze funds and reveal identity. Tracing to it needs rare skills, then manual research for its contact</a:t>
-            </a:r>
-            <a:endParaRPr lang="en-US" sz="1400" dirty="0"/>
-          </a:p>
-        </p:txBody>
-      </p:sp>
-      <p:sp>
-        <p:nvSpPr>
-          <p:cNvPr id="21" name="pain3-circle"/>
-          <p:cNvSpPr/>
-          <p:nvPr/>
-        </p:nvSpPr>
-        <p:spPr>
-          <a:xfrm>
-            <a:off x="5074920" y="5157216"/>
-            <a:ext cx="594360" cy="594360"/>
+              <a:t>Manual tracing breaks on</a:t>
+            </a:r>
+            <a:endParaRPr lang="en-US" sz="1600" dirty="0"/>
+          </a:p>
+        </p:txBody>
+      </p:sp>
+      <p:sp>
+        <p:nvSpPr>
+          <p:cNvPr id="38" name="chip2-0"/>
+          <p:cNvSpPr/>
+          <p:nvPr/>
+        </p:nvSpPr>
+        <p:spPr>
+          <a:xfrm>
+            <a:off x="5303520" y="4498848"/>
+            <a:ext cx="1603858" cy="329184"/>
+          </a:xfrm>
+          <a:prstGeom prst="roundRect">
+            <a:avLst>
+              <a:gd name="adj" fmla="val 50000"/>
+            </a:avLst>
+          </a:prstGeom>
+          <a:solidFill>
+            <a:schemeClr val="accent2"/>
+          </a:solidFill>
+          <a:ln w="12700">
+            <a:solidFill>
+              <a:schemeClr val="accent2"/>
+            </a:solidFill>
+            <a:prstDash val="solid"/>
+          </a:ln>
+        </p:spPr>
+      </p:sp>
+      <p:sp>
+        <p:nvSpPr>
+          <p:cNvPr id="39" name="Text 34"/>
+          <p:cNvSpPr txBox="1"/>
+          <p:nvPr/>
+        </p:nvSpPr>
+        <p:spPr>
+          <a:xfrm>
+            <a:off x="5303520" y="4498848"/>
+            <a:ext cx="1603858" cy="329184"/>
+          </a:xfrm>
+          <a:prstGeom prst="rect">
+            <a:avLst/>
+          </a:prstGeom>
+          <a:noFill/>
+          <a:ln/>
+        </p:spPr>
+        <p:txBody>
+          <a:bodyPr wrap="square" lIns="0" tIns="0" rIns="0" bIns="0" rtlCol="0" anchor="ctr"/>
+          <a:lstStyle/>
+          <a:p>
+            <a:pPr algn="ctr" indent="0" marL="0">
+              <a:buNone/>
+            </a:pPr>
+            <a:r>
+              <a:rPr lang="en-US" sz="1100" b="1" dirty="0">
+                <a:solidFill>
+                  <a:schemeClr val="bg1"/>
+                </a:solidFill>
+              </a:rPr>
+              <a:t>Multi-chain transfers</a:t>
+            </a:r>
+            <a:endParaRPr lang="en-US" sz="1100" dirty="0"/>
+          </a:p>
+        </p:txBody>
+      </p:sp>
+      <p:sp>
+        <p:nvSpPr>
+          <p:cNvPr id="40" name="chip2-1"/>
+          <p:cNvSpPr/>
+          <p:nvPr/>
+        </p:nvSpPr>
+        <p:spPr>
+          <a:xfrm>
+            <a:off x="6980530" y="4498848"/>
+            <a:ext cx="1130198" cy="329184"/>
+          </a:xfrm>
+          <a:prstGeom prst="roundRect">
+            <a:avLst>
+              <a:gd name="adj" fmla="val 50000"/>
+            </a:avLst>
+          </a:prstGeom>
+          <a:solidFill>
+            <a:schemeClr val="accent2"/>
+          </a:solidFill>
+          <a:ln w="12700">
+            <a:solidFill>
+              <a:schemeClr val="accent2"/>
+            </a:solidFill>
+            <a:prstDash val="solid"/>
+          </a:ln>
+        </p:spPr>
+      </p:sp>
+      <p:sp>
+        <p:nvSpPr>
+          <p:cNvPr id="41" name="Text 36"/>
+          <p:cNvSpPr txBox="1"/>
+          <p:nvPr/>
+        </p:nvSpPr>
+        <p:spPr>
+          <a:xfrm>
+            <a:off x="6980530" y="4498848"/>
+            <a:ext cx="1130198" cy="329184"/>
+          </a:xfrm>
+          <a:prstGeom prst="rect">
+            <a:avLst/>
+          </a:prstGeom>
+          <a:noFill/>
+          <a:ln/>
+        </p:spPr>
+        <p:txBody>
+          <a:bodyPr wrap="square" lIns="0" tIns="0" rIns="0" bIns="0" rtlCol="0" anchor="ctr"/>
+          <a:lstStyle/>
+          <a:p>
+            <a:pPr algn="ctr" indent="0" marL="0">
+              <a:buNone/>
+            </a:pPr>
+            <a:r>
+              <a:rPr lang="en-US" sz="1100" b="1" dirty="0">
+                <a:solidFill>
+                  <a:schemeClr val="bg1"/>
+                </a:solidFill>
+              </a:rPr>
+              <a:t>DeFi protocols</a:t>
+            </a:r>
+            <a:endParaRPr lang="en-US" sz="1100" dirty="0"/>
+          </a:p>
+        </p:txBody>
+      </p:sp>
+      <p:sp>
+        <p:nvSpPr>
+          <p:cNvPr id="42" name="chip2-2"/>
+          <p:cNvSpPr/>
+          <p:nvPr/>
+        </p:nvSpPr>
+        <p:spPr>
+          <a:xfrm>
+            <a:off x="8183880" y="4498848"/>
+            <a:ext cx="1333195" cy="329184"/>
+          </a:xfrm>
+          <a:prstGeom prst="roundRect">
+            <a:avLst>
+              <a:gd name="adj" fmla="val 50000"/>
+            </a:avLst>
+          </a:prstGeom>
+          <a:solidFill>
+            <a:schemeClr val="accent2"/>
+          </a:solidFill>
+          <a:ln w="12700">
+            <a:solidFill>
+              <a:schemeClr val="accent2"/>
+            </a:solidFill>
+            <a:prstDash val="solid"/>
+          </a:ln>
+        </p:spPr>
+      </p:sp>
+      <p:sp>
+        <p:nvSpPr>
+          <p:cNvPr id="43" name="Text 38"/>
+          <p:cNvSpPr txBox="1"/>
+          <p:nvPr/>
+        </p:nvSpPr>
+        <p:spPr>
+          <a:xfrm>
+            <a:off x="8183880" y="4498848"/>
+            <a:ext cx="1333195" cy="329184"/>
+          </a:xfrm>
+          <a:prstGeom prst="rect">
+            <a:avLst/>
+          </a:prstGeom>
+          <a:noFill/>
+          <a:ln/>
+        </p:spPr>
+        <p:txBody>
+          <a:bodyPr wrap="square" lIns="0" tIns="0" rIns="0" bIns="0" rtlCol="0" anchor="ctr"/>
+          <a:lstStyle/>
+          <a:p>
+            <a:pPr algn="ctr" indent="0" marL="0">
+              <a:buNone/>
+            </a:pPr>
+            <a:r>
+              <a:rPr lang="en-US" sz="1100" b="1" dirty="0">
+                <a:solidFill>
+                  <a:schemeClr val="bg1"/>
+                </a:solidFill>
+              </a:rPr>
+              <a:t>Mixers / tumblers</a:t>
+            </a:r>
+            <a:endParaRPr lang="en-US" sz="1100" dirty="0"/>
+          </a:p>
+        </p:txBody>
+      </p:sp>
+      <p:sp>
+        <p:nvSpPr>
+          <p:cNvPr id="44" name="chip2-3"/>
+          <p:cNvSpPr/>
+          <p:nvPr/>
+        </p:nvSpPr>
+        <p:spPr>
+          <a:xfrm>
+            <a:off x="9590227" y="4498848"/>
+            <a:ext cx="656539" cy="329184"/>
+          </a:xfrm>
+          <a:prstGeom prst="roundRect">
+            <a:avLst>
+              <a:gd name="adj" fmla="val 50000"/>
+            </a:avLst>
+          </a:prstGeom>
+          <a:solidFill>
+            <a:schemeClr val="accent2"/>
+          </a:solidFill>
+          <a:ln w="12700">
+            <a:solidFill>
+              <a:schemeClr val="accent2"/>
+            </a:solidFill>
+            <a:prstDash val="solid"/>
+          </a:ln>
+        </p:spPr>
+      </p:sp>
+      <p:sp>
+        <p:nvSpPr>
+          <p:cNvPr id="45" name="Text 40"/>
+          <p:cNvSpPr txBox="1"/>
+          <p:nvPr/>
+        </p:nvSpPr>
+        <p:spPr>
+          <a:xfrm>
+            <a:off x="9590227" y="4498848"/>
+            <a:ext cx="656539" cy="329184"/>
+          </a:xfrm>
+          <a:prstGeom prst="rect">
+            <a:avLst/>
+          </a:prstGeom>
+          <a:noFill/>
+          <a:ln/>
+        </p:spPr>
+        <p:txBody>
+          <a:bodyPr wrap="square" lIns="0" tIns="0" rIns="0" bIns="0" rtlCol="0" anchor="ctr"/>
+          <a:lstStyle/>
+          <a:p>
+            <a:pPr algn="ctr" indent="0" marL="0">
+              <a:buNone/>
+            </a:pPr>
+            <a:r>
+              <a:rPr lang="en-US" sz="1100" b="1" dirty="0">
+                <a:solidFill>
+                  <a:schemeClr val="bg1"/>
+                </a:solidFill>
+              </a:rPr>
+              <a:t>Bridges</a:t>
+            </a:r>
+            <a:endParaRPr lang="en-US" sz="1100" dirty="0"/>
+          </a:p>
+        </p:txBody>
+      </p:sp>
+      <p:sp>
+        <p:nvSpPr>
+          <p:cNvPr id="46" name="chip2-4"/>
+          <p:cNvSpPr/>
+          <p:nvPr/>
+        </p:nvSpPr>
+        <p:spPr>
+          <a:xfrm>
+            <a:off x="10319918" y="4498848"/>
+            <a:ext cx="1062533" cy="329184"/>
+          </a:xfrm>
+          <a:prstGeom prst="roundRect">
+            <a:avLst>
+              <a:gd name="adj" fmla="val 50000"/>
+            </a:avLst>
+          </a:prstGeom>
+          <a:solidFill>
+            <a:schemeClr val="accent2"/>
+          </a:solidFill>
+          <a:ln w="12700">
+            <a:solidFill>
+              <a:schemeClr val="accent2"/>
+            </a:solidFill>
+            <a:prstDash val="solid"/>
+          </a:ln>
+        </p:spPr>
+      </p:sp>
+      <p:sp>
+        <p:nvSpPr>
+          <p:cNvPr id="47" name="Text 42"/>
+          <p:cNvSpPr txBox="1"/>
+          <p:nvPr/>
+        </p:nvSpPr>
+        <p:spPr>
+          <a:xfrm>
+            <a:off x="10319918" y="4498848"/>
+            <a:ext cx="1062533" cy="329184"/>
+          </a:xfrm>
+          <a:prstGeom prst="rect">
+            <a:avLst/>
+          </a:prstGeom>
+          <a:noFill/>
+          <a:ln/>
+        </p:spPr>
+        <p:txBody>
+          <a:bodyPr wrap="square" lIns="0" tIns="0" rIns="0" bIns="0" rtlCol="0" anchor="ctr"/>
+          <a:lstStyle/>
+          <a:p>
+            <a:pPr algn="ctr" indent="0" marL="0">
+              <a:buNone/>
+            </a:pPr>
+            <a:r>
+              <a:rPr lang="en-US" sz="1100" b="1" dirty="0">
+                <a:solidFill>
+                  <a:schemeClr val="bg1"/>
+                </a:solidFill>
+              </a:rPr>
+              <a:t>Privacy tools</a:t>
+            </a:r>
+            <a:endParaRPr lang="en-US" sz="1100" dirty="0"/>
+          </a:p>
+        </p:txBody>
+      </p:sp>
+      <p:sp>
+        <p:nvSpPr>
+          <p:cNvPr id="48" name="grp3-circle"/>
+          <p:cNvSpPr/>
+          <p:nvPr/>
+        </p:nvSpPr>
+        <p:spPr>
+          <a:xfrm>
+            <a:off x="4572000" y="5175504"/>
+            <a:ext cx="548640" cy="548640"/>
           </a:xfrm>
           <a:prstGeom prst="ellipse">
             <a:avLst/>
           </a:prstGeom>
           <a:solidFill>
-            <a:schemeClr val="accent4"/>
+            <a:schemeClr val="accent5"/>
           </a:solidFill>
           <a:ln w="12700">
             <a:solidFill>
-              <a:schemeClr val="accent4"/>
+              <a:schemeClr val="accent5"/>
             </a:solidFill>
             <a:prstDash val="solid"/>
           </a:ln>
@@ -3593,7 +4282,7 @@
       </p:sp>
       <p:pic>
         <p:nvPicPr>
-          <p:cNvPr id="22" name="pain3-icon" descr="preencoded.png">    </p:cNvPr>
+          <p:cNvPr id="49" name="grp3-icon" descr="preencoded.png">    </p:cNvPr>
           <p:cNvPicPr>
             <a:picLocks noChangeAspect="1"/>
           </p:cNvPicPr>
@@ -3607,8 +4296,8 @@
         </p:blipFill>
         <p:spPr>
           <a:xfrm>
-            <a:off x="5229454" y="5311750"/>
-            <a:ext cx="285293" cy="285293"/>
+            <a:off x="4714646" y="5318150"/>
+            <a:ext cx="263347" cy="263347"/>
           </a:xfrm>
           <a:prstGeom prst="rect">
             <a:avLst/>
@@ -3617,14 +4306,14 @@
       </p:pic>
       <p:sp>
         <p:nvSpPr>
-          <p:cNvPr id="23" name="Text 17"/>
-          <p:cNvSpPr txBox="1"/>
-          <p:nvPr/>
-        </p:nvSpPr>
-        <p:spPr>
-          <a:xfrm>
-            <a:off x="5897880" y="5084064"/>
-            <a:ext cx="5669280" cy="365760"/>
+          <p:cNvPr id="50" name="Text 44"/>
+          <p:cNvSpPr txBox="1"/>
+          <p:nvPr/>
+        </p:nvSpPr>
+        <p:spPr>
+          <a:xfrm>
+            <a:off x="5303520" y="5129784"/>
+            <a:ext cx="6309360" cy="347472"/>
           </a:xfrm>
           <a:prstGeom prst="rect">
             <a:avLst/>
@@ -3640,50 +4329,266 @@
               <a:buNone/>
             </a:pPr>
             <a:r>
-              <a:rPr lang="en-US" sz="1700" b="1" dirty="0">
+              <a:rPr lang="en-US" sz="1600" b="1" dirty="0">
                 <a:solidFill>
                   <a:schemeClr val="tx1"/>
                 </a:solidFill>
               </a:rPr>
-              <a:t>Why it fails today</a:t>
-            </a:r>
-            <a:endParaRPr lang="en-US" sz="1700" dirty="0"/>
-          </a:p>
-        </p:txBody>
-      </p:sp>
-      <p:sp>
-        <p:nvSpPr>
-          <p:cNvPr id="24" name="Text 18"/>
-          <p:cNvSpPr txBox="1"/>
-          <p:nvPr/>
-        </p:nvSpPr>
-        <p:spPr>
-          <a:xfrm>
-            <a:off x="5897880" y="5468112"/>
-            <a:ext cx="5669280" cy="594360"/>
-          </a:xfrm>
-          <a:prstGeom prst="rect">
-            <a:avLst/>
-          </a:prstGeom>
-          <a:noFill/>
-          <a:ln/>
-        </p:spPr>
-        <p:txBody>
-          <a:bodyPr wrap="square" lIns="0" tIns="0" rIns="0" bIns="0" rtlCol="0" anchor="t"/>
-          <a:lstStyle/>
-          <a:p>
-            <a:pPr indent="0" marL="0">
-              <a:buNone/>
-            </a:pPr>
-            <a:r>
-              <a:rPr lang="en-US" sz="1400" dirty="0">
-                <a:solidFill>
-                  <a:schemeClr val="tx2"/>
-                </a:solidFill>
-              </a:rPr>
-              <a:t>Commercial tools are costly and don't automate the web research. By the time the request is sent, funds have moved</a:t>
-            </a:r>
-            <a:endParaRPr lang="en-US" sz="1400" dirty="0"/>
+              <a:t>Delay costs</a:t>
+            </a:r>
+            <a:endParaRPr lang="en-US" sz="1600" dirty="0"/>
+          </a:p>
+        </p:txBody>
+      </p:sp>
+      <p:sp>
+        <p:nvSpPr>
+          <p:cNvPr id="51" name="chip3-0"/>
+          <p:cNvSpPr/>
+          <p:nvPr/>
+        </p:nvSpPr>
+        <p:spPr>
+          <a:xfrm>
+            <a:off x="5303520" y="5568696"/>
+            <a:ext cx="1130198" cy="329184"/>
+          </a:xfrm>
+          <a:prstGeom prst="roundRect">
+            <a:avLst>
+              <a:gd name="adj" fmla="val 50000"/>
+            </a:avLst>
+          </a:prstGeom>
+          <a:solidFill>
+            <a:schemeClr val="accent5"/>
+          </a:solidFill>
+          <a:ln w="12700">
+            <a:solidFill>
+              <a:schemeClr val="accent5"/>
+            </a:solidFill>
+            <a:prstDash val="solid"/>
+          </a:ln>
+        </p:spPr>
+      </p:sp>
+      <p:sp>
+        <p:nvSpPr>
+          <p:cNvPr id="52" name="Text 46"/>
+          <p:cNvSpPr txBox="1"/>
+          <p:nvPr/>
+        </p:nvSpPr>
+        <p:spPr>
+          <a:xfrm>
+            <a:off x="5303520" y="5568696"/>
+            <a:ext cx="1130198" cy="329184"/>
+          </a:xfrm>
+          <a:prstGeom prst="rect">
+            <a:avLst/>
+          </a:prstGeom>
+          <a:noFill/>
+          <a:ln/>
+        </p:spPr>
+        <p:txBody>
+          <a:bodyPr wrap="square" lIns="0" tIns="0" rIns="0" bIns="0" rtlCol="0" anchor="ctr"/>
+          <a:lstStyle/>
+          <a:p>
+            <a:pPr algn="ctr" indent="0" marL="0">
+              <a:buNone/>
+            </a:pPr>
+            <a:r>
+              <a:rPr lang="en-US" sz="1100" b="1" dirty="0">
+                <a:solidFill>
+                  <a:schemeClr val="bg1"/>
+                </a:solidFill>
+              </a:rPr>
+              <a:t>Asset freezing</a:t>
+            </a:r>
+            <a:endParaRPr lang="en-US" sz="1100" dirty="0"/>
+          </a:p>
+        </p:txBody>
+      </p:sp>
+      <p:sp>
+        <p:nvSpPr>
+          <p:cNvPr id="53" name="chip3-1"/>
+          <p:cNvSpPr/>
+          <p:nvPr/>
+        </p:nvSpPr>
+        <p:spPr>
+          <a:xfrm>
+            <a:off x="6506870" y="5568696"/>
+            <a:ext cx="1603858" cy="329184"/>
+          </a:xfrm>
+          <a:prstGeom prst="roundRect">
+            <a:avLst>
+              <a:gd name="adj" fmla="val 50000"/>
+            </a:avLst>
+          </a:prstGeom>
+          <a:solidFill>
+            <a:schemeClr val="accent5"/>
+          </a:solidFill>
+          <a:ln w="12700">
+            <a:solidFill>
+              <a:schemeClr val="accent5"/>
+            </a:solidFill>
+            <a:prstDash val="solid"/>
+          </a:ln>
+        </p:spPr>
+      </p:sp>
+      <p:sp>
+        <p:nvSpPr>
+          <p:cNvPr id="54" name="Text 48"/>
+          <p:cNvSpPr txBox="1"/>
+          <p:nvPr/>
+        </p:nvSpPr>
+        <p:spPr>
+          <a:xfrm>
+            <a:off x="6506870" y="5568696"/>
+            <a:ext cx="1603858" cy="329184"/>
+          </a:xfrm>
+          <a:prstGeom prst="rect">
+            <a:avLst/>
+          </a:prstGeom>
+          <a:noFill/>
+          <a:ln/>
+        </p:spPr>
+        <p:txBody>
+          <a:bodyPr wrap="square" lIns="0" tIns="0" rIns="0" bIns="0" rtlCol="0" anchor="ctr"/>
+          <a:lstStyle/>
+          <a:p>
+            <a:pPr algn="ctr" indent="0" marL="0">
+              <a:buNone/>
+            </a:pPr>
+            <a:r>
+              <a:rPr lang="en-US" sz="1100" b="1" dirty="0">
+                <a:solidFill>
+                  <a:schemeClr val="bg1"/>
+                </a:solidFill>
+              </a:rPr>
+              <a:t>Evidence preservation</a:t>
+            </a:r>
+            <a:endParaRPr lang="en-US" sz="1100" dirty="0"/>
+          </a:p>
+        </p:txBody>
+      </p:sp>
+      <p:sp>
+        <p:nvSpPr>
+          <p:cNvPr id="55" name="chip3-2"/>
+          <p:cNvSpPr/>
+          <p:nvPr/>
+        </p:nvSpPr>
+        <p:spPr>
+          <a:xfrm>
+            <a:off x="8183880" y="5568696"/>
+            <a:ext cx="1333195" cy="329184"/>
+          </a:xfrm>
+          <a:prstGeom prst="roundRect">
+            <a:avLst>
+              <a:gd name="adj" fmla="val 50000"/>
+            </a:avLst>
+          </a:prstGeom>
+          <a:solidFill>
+            <a:schemeClr val="accent5"/>
+          </a:solidFill>
+          <a:ln w="12700">
+            <a:solidFill>
+              <a:schemeClr val="accent5"/>
+            </a:solidFill>
+            <a:prstDash val="solid"/>
+          </a:ln>
+        </p:spPr>
+      </p:sp>
+      <p:sp>
+        <p:nvSpPr>
+          <p:cNvPr id="56" name="Text 50"/>
+          <p:cNvSpPr txBox="1"/>
+          <p:nvPr/>
+        </p:nvSpPr>
+        <p:spPr>
+          <a:xfrm>
+            <a:off x="8183880" y="5568696"/>
+            <a:ext cx="1333195" cy="329184"/>
+          </a:xfrm>
+          <a:prstGeom prst="rect">
+            <a:avLst/>
+          </a:prstGeom>
+          <a:noFill/>
+          <a:ln/>
+        </p:spPr>
+        <p:txBody>
+          <a:bodyPr wrap="square" lIns="0" tIns="0" rIns="0" bIns="0" rtlCol="0" anchor="ctr"/>
+          <a:lstStyle/>
+          <a:p>
+            <a:pPr algn="ctr" indent="0" marL="0">
+              <a:buNone/>
+            </a:pPr>
+            <a:r>
+              <a:rPr lang="en-US" sz="1100" b="1" dirty="0">
+                <a:solidFill>
+                  <a:schemeClr val="bg1"/>
+                </a:solidFill>
+              </a:rPr>
+              <a:t>Fund-flow tracing</a:t>
+            </a:r>
+            <a:endParaRPr lang="en-US" sz="1100" dirty="0"/>
+          </a:p>
+        </p:txBody>
+      </p:sp>
+      <p:sp>
+        <p:nvSpPr>
+          <p:cNvPr id="57" name="chip3-3"/>
+          <p:cNvSpPr/>
+          <p:nvPr/>
+        </p:nvSpPr>
+        <p:spPr>
+          <a:xfrm>
+            <a:off x="9590227" y="5568696"/>
+            <a:ext cx="1197864" cy="329184"/>
+          </a:xfrm>
+          <a:prstGeom prst="roundRect">
+            <a:avLst>
+              <a:gd name="adj" fmla="val 50000"/>
+            </a:avLst>
+          </a:prstGeom>
+          <a:solidFill>
+            <a:schemeClr val="accent5"/>
+          </a:solidFill>
+          <a:ln w="12700">
+            <a:solidFill>
+              <a:schemeClr val="accent5"/>
+            </a:solidFill>
+            <a:prstDash val="solid"/>
+          </a:ln>
+        </p:spPr>
+      </p:sp>
+      <p:sp>
+        <p:nvSpPr>
+          <p:cNvPr id="58" name="Text 52"/>
+          <p:cNvSpPr txBox="1"/>
+          <p:nvPr/>
+        </p:nvSpPr>
+        <p:spPr>
+          <a:xfrm>
+            <a:off x="9590227" y="5568696"/>
+            <a:ext cx="1197864" cy="329184"/>
+          </a:xfrm>
+          <a:prstGeom prst="rect">
+            <a:avLst/>
+          </a:prstGeom>
+          <a:noFill/>
+          <a:ln/>
+        </p:spPr>
+        <p:txBody>
+          <a:bodyPr wrap="square" lIns="0" tIns="0" rIns="0" bIns="0" rtlCol="0" anchor="ctr"/>
+          <a:lstStyle/>
+          <a:p>
+            <a:pPr algn="ctr" indent="0" marL="0">
+              <a:buNone/>
+            </a:pPr>
+            <a:r>
+              <a:rPr lang="en-US" sz="1100" b="1" dirty="0">
+                <a:solidFill>
+                  <a:schemeClr val="bg1"/>
+                </a:solidFill>
+              </a:rPr>
+              <a:t>Victim recovery</a:t>
+            </a:r>
+            <a:endParaRPr lang="en-US" sz="1100" dirty="0"/>
           </a:p>
         </p:txBody>
       </p:sp>
@@ -3806,7 +4711,7 @@
         </p:nvSpPr>
         <p:spPr>
           <a:xfrm>
-            <a:off x="548640" y="1143000"/>
+            <a:off x="548640" y="1097280"/>
             <a:ext cx="11094415" cy="960120"/>
           </a:xfrm>
           <a:prstGeom prst="roundRect">
@@ -3833,7 +4738,7 @@
         </p:nvSpPr>
         <p:spPr>
           <a:xfrm>
-            <a:off x="914400" y="1143000"/>
+            <a:off x="914400" y="1097280"/>
             <a:ext cx="10362895" cy="960120"/>
           </a:xfrm>
           <a:prstGeom prst="rect">
@@ -3850,7 +4755,7 @@
               <a:buNone/>
             </a:pPr>
             <a:r>
-              <a:rPr lang="en-US" sz="2800" b="1" dirty="0">
+              <a:rPr lang="en-US" sz="2600" b="1" dirty="0">
                 <a:solidFill>
                   <a:schemeClr val="bg1"/>
                 </a:solidFill>
@@ -3864,7 +4769,7 @@
               <a:buNone/>
             </a:pPr>
             <a:r>
-              <a:rPr lang="en-US" sz="2800" b="1" dirty="0">
+              <a:rPr lang="en-US" sz="2600" b="1" dirty="0">
                 <a:solidFill>
                   <a:schemeClr val="accent1"/>
                 </a:solidFill>
@@ -3878,7 +4783,7 @@
               <a:buNone/>
             </a:pPr>
             <a:r>
-              <a:rPr lang="en-US" sz="2800" b="1" dirty="0">
+              <a:rPr lang="en-US" sz="2600" b="1" dirty="0">
                 <a:solidFill>
                   <a:schemeClr val="bg1"/>
                 </a:solidFill>
@@ -3886,9 +4791,9 @@
                 <a:ea typeface="Arial" pitchFamily="34" charset="-122"/>
                 <a:cs typeface="Arial" pitchFamily="34" charset="-120"/>
               </a:rPr>
-              <a:t>exchange, contact and evidence out</a:t>
-            </a:r>
-            <a:endParaRPr lang="en-US" sz="2800" dirty="0"/>
+              <a:t>nearest exchange, its contact and evidence out</a:t>
+            </a:r>
+            <a:endParaRPr lang="en-US" sz="2600" dirty="0"/>
           </a:p>
         </p:txBody>
       </p:sp>
@@ -3900,7 +4805,7 @@
         </p:nvSpPr>
         <p:spPr>
           <a:xfrm>
-            <a:off x="1548354" y="2788920"/>
+            <a:off x="1548354" y="2697480"/>
             <a:ext cx="9094988" cy="0"/>
           </a:xfrm>
           <a:prstGeom prst="line">
@@ -3923,7 +4828,7 @@
         </p:nvSpPr>
         <p:spPr>
           <a:xfrm>
-            <a:off x="1136874" y="2377440"/>
+            <a:off x="1136874" y="2286000"/>
             <a:ext cx="822960" cy="822960"/>
           </a:xfrm>
           <a:prstGeom prst="ellipse">
@@ -3956,7 +4861,7 @@
         </p:blipFill>
         <p:spPr>
           <a:xfrm>
-            <a:off x="1350843" y="2591410"/>
+            <a:off x="1350843" y="2499970"/>
             <a:ext cx="395021" cy="395021"/>
           </a:xfrm>
           <a:prstGeom prst="rect">
@@ -3972,12 +4877,12 @@
         </p:nvSpPr>
         <p:spPr>
           <a:xfrm>
-            <a:off x="548640" y="3383280"/>
-            <a:ext cx="1999427" cy="1965960"/>
+            <a:off x="548640" y="3291840"/>
+            <a:ext cx="1999427" cy="2103120"/>
           </a:xfrm>
           <a:prstGeom prst="roundRect">
             <a:avLst>
-              <a:gd name="adj" fmla="val 3721"/>
+              <a:gd name="adj" fmla="val 3659"/>
             </a:avLst>
           </a:prstGeom>
           <a:solidFill>
@@ -3999,7 +4904,7 @@
         </p:nvSpPr>
         <p:spPr>
           <a:xfrm>
-            <a:off x="731520" y="3520440"/>
+            <a:off x="731520" y="3429000"/>
             <a:ext cx="1633667" cy="411480"/>
           </a:xfrm>
           <a:prstGeom prst="rect">
@@ -4016,14 +4921,14 @@
               <a:buNone/>
             </a:pPr>
             <a:r>
-              <a:rPr lang="en-US" sz="1700" b="1" dirty="0">
+              <a:rPr lang="en-US" sz="1800" b="1" dirty="0">
                 <a:solidFill>
                   <a:schemeClr val="tx1"/>
                 </a:solidFill>
               </a:rPr>
-              <a:t>Report a wallet</a:t>
-            </a:r>
-            <a:endParaRPr lang="en-US" sz="1700" dirty="0"/>
+              <a:t>1. Ingest</a:t>
+            </a:r>
+            <a:endParaRPr lang="en-US" sz="1800" dirty="0"/>
           </a:p>
         </p:txBody>
       </p:sp>
@@ -4035,8 +4940,8 @@
         </p:nvSpPr>
         <p:spPr>
           <a:xfrm>
-            <a:off x="731520" y="3977640"/>
-            <a:ext cx="1633667" cy="914400"/>
+            <a:off x="731520" y="3886200"/>
+            <a:ext cx="1633667" cy="1005840"/>
           </a:xfrm>
           <a:prstGeom prst="rect">
             <a:avLst/>
@@ -4057,7 +4962,7 @@
                   <a:schemeClr val="tx2"/>
                 </a:solidFill>
               </a:rPr>
-              <a:t>Wallet address + chain, from dashboard or API</a:t>
+              <a:t>Wallets from NCRP / SAHYOG complaints, dashboard or API</a:t>
             </a:r>
             <a:endParaRPr lang="en-US" sz="1400" dirty="0"/>
           </a:p>
@@ -4071,7 +4976,7 @@
         </p:nvSpPr>
         <p:spPr>
           <a:xfrm>
-            <a:off x="3410621" y="2377440"/>
+            <a:off x="3410621" y="2286000"/>
             <a:ext cx="822960" cy="822960"/>
           </a:xfrm>
           <a:prstGeom prst="ellipse">
@@ -4104,7 +5009,7 @@
         </p:blipFill>
         <p:spPr>
           <a:xfrm>
-            <a:off x="3624590" y="2591410"/>
+            <a:off x="3624590" y="2499970"/>
             <a:ext cx="395021" cy="395021"/>
           </a:xfrm>
           <a:prstGeom prst="rect">
@@ -4120,12 +5025,12 @@
         </p:nvSpPr>
         <p:spPr>
           <a:xfrm>
-            <a:off x="2822387" y="3383280"/>
-            <a:ext cx="1999427" cy="1965960"/>
+            <a:off x="2822387" y="3291840"/>
+            <a:ext cx="1999427" cy="2103120"/>
           </a:xfrm>
           <a:prstGeom prst="roundRect">
             <a:avLst>
-              <a:gd name="adj" fmla="val 3721"/>
+              <a:gd name="adj" fmla="val 3659"/>
             </a:avLst>
           </a:prstGeom>
           <a:solidFill>
@@ -4147,7 +5052,7 @@
         </p:nvSpPr>
         <p:spPr>
           <a:xfrm>
-            <a:off x="3005267" y="3520440"/>
+            <a:off x="3005267" y="3429000"/>
             <a:ext cx="1633667" cy="411480"/>
           </a:xfrm>
           <a:prstGeom prst="rect">
@@ -4164,14 +5069,14 @@
               <a:buNone/>
             </a:pPr>
             <a:r>
-              <a:rPr lang="en-US" sz="1700" b="1" dirty="0">
+              <a:rPr lang="en-US" sz="1800" b="1" dirty="0">
                 <a:solidFill>
                   <a:schemeClr val="tx1"/>
                 </a:solidFill>
               </a:rPr>
-              <a:t>Trace the money</a:t>
-            </a:r>
-            <a:endParaRPr lang="en-US" sz="1700" dirty="0"/>
+              <a:t>2. Trace</a:t>
+            </a:r>
+            <a:endParaRPr lang="en-US" sz="1800" dirty="0"/>
           </a:p>
         </p:txBody>
       </p:sp>
@@ -4183,8 +5088,8 @@
         </p:nvSpPr>
         <p:spPr>
           <a:xfrm>
-            <a:off x="3005267" y="3977640"/>
-            <a:ext cx="1633667" cy="914400"/>
+            <a:off x="3005267" y="3886200"/>
+            <a:ext cx="1633667" cy="1005840"/>
           </a:xfrm>
           <a:prstGeom prst="rect">
             <a:avLst/>
@@ -4205,7 +5110,7 @@
                   <a:schemeClr val="tx2"/>
                 </a:solidFill>
               </a:rPr>
-              <a:t>Follow funds hop by hop; spot laundering patterns</a:t>
+              <a:t>Hop-by-hop transaction graph; layering patterns; cross-chain hops flagged</a:t>
             </a:r>
             <a:endParaRPr lang="en-US" sz="1400" dirty="0"/>
           </a:p>
@@ -4219,7 +5124,7 @@
         </p:nvSpPr>
         <p:spPr>
           <a:xfrm>
-            <a:off x="5684368" y="2377440"/>
+            <a:off x="5684368" y="2286000"/>
             <a:ext cx="822960" cy="822960"/>
           </a:xfrm>
           <a:prstGeom prst="ellipse">
@@ -4252,7 +5157,7 @@
         </p:blipFill>
         <p:spPr>
           <a:xfrm>
-            <a:off x="5898337" y="2591410"/>
+            <a:off x="5898337" y="2499970"/>
             <a:ext cx="395021" cy="395021"/>
           </a:xfrm>
           <a:prstGeom prst="rect">
@@ -4268,12 +5173,12 @@
         </p:nvSpPr>
         <p:spPr>
           <a:xfrm>
-            <a:off x="5096134" y="3383280"/>
-            <a:ext cx="1999427" cy="1965960"/>
+            <a:off x="5096134" y="3291840"/>
+            <a:ext cx="1999427" cy="2103120"/>
           </a:xfrm>
           <a:prstGeom prst="roundRect">
             <a:avLst>
-              <a:gd name="adj" fmla="val 3721"/>
+              <a:gd name="adj" fmla="val 3659"/>
             </a:avLst>
           </a:prstGeom>
           <a:solidFill>
@@ -4295,7 +5200,7 @@
         </p:nvSpPr>
         <p:spPr>
           <a:xfrm>
-            <a:off x="5279014" y="3520440"/>
+            <a:off x="5279014" y="3429000"/>
             <a:ext cx="1633667" cy="411480"/>
           </a:xfrm>
           <a:prstGeom prst="rect">
@@ -4312,14 +5217,14 @@
               <a:buNone/>
             </a:pPr>
             <a:r>
-              <a:rPr lang="en-US" sz="1700" b="1" dirty="0">
+              <a:rPr lang="en-US" sz="1800" b="1" dirty="0">
                 <a:solidFill>
                   <a:schemeClr val="tx1"/>
                 </a:solidFill>
               </a:rPr>
-              <a:t>Find the exchange</a:t>
-            </a:r>
-            <a:endParaRPr lang="en-US" sz="1700" dirty="0"/>
+              <a:t>3. Attribute</a:t>
+            </a:r>
+            <a:endParaRPr lang="en-US" sz="1800" dirty="0"/>
           </a:p>
         </p:txBody>
       </p:sp>
@@ -4331,8 +5236,8 @@
         </p:nvSpPr>
         <p:spPr>
           <a:xfrm>
-            <a:off x="5279014" y="3977640"/>
-            <a:ext cx="1633667" cy="914400"/>
+            <a:off x="5279014" y="3886200"/>
+            <a:ext cx="1633667" cy="1005840"/>
           </a:xfrm>
           <a:prstGeom prst="rect">
             <a:avLst/>
@@ -4353,7 +5258,7 @@
                   <a:schemeClr val="tx2"/>
                 </a:solidFill>
               </a:rPr>
-              <a:t>Match the exchange deposit address funds landed in</a:t>
+              <a:t>Exchange-wallet clustering finds the nearest VASP deposit address</a:t>
             </a:r>
             <a:endParaRPr lang="en-US" sz="1400" dirty="0"/>
           </a:p>
@@ -4367,7 +5272,7 @@
         </p:nvSpPr>
         <p:spPr>
           <a:xfrm>
-            <a:off x="7958115" y="2377440"/>
+            <a:off x="7958115" y="2286000"/>
             <a:ext cx="822960" cy="822960"/>
           </a:xfrm>
           <a:prstGeom prst="ellipse">
@@ -4400,7 +5305,7 @@
         </p:blipFill>
         <p:spPr>
           <a:xfrm>
-            <a:off x="8172084" y="2591410"/>
+            <a:off x="8172084" y="2499970"/>
             <a:ext cx="395021" cy="395021"/>
           </a:xfrm>
           <a:prstGeom prst="rect">
@@ -4416,12 +5321,12 @@
         </p:nvSpPr>
         <p:spPr>
           <a:xfrm>
-            <a:off x="7369881" y="3383280"/>
-            <a:ext cx="1999427" cy="1965960"/>
+            <a:off x="7369881" y="3291840"/>
+            <a:ext cx="1999427" cy="2103120"/>
           </a:xfrm>
           <a:prstGeom prst="roundRect">
             <a:avLst>
-              <a:gd name="adj" fmla="val 3721"/>
+              <a:gd name="adj" fmla="val 3659"/>
             </a:avLst>
           </a:prstGeom>
           <a:solidFill>
@@ -4443,7 +5348,7 @@
         </p:nvSpPr>
         <p:spPr>
           <a:xfrm>
-            <a:off x="7552761" y="3520440"/>
+            <a:off x="7552761" y="3429000"/>
             <a:ext cx="1633667" cy="411480"/>
           </a:xfrm>
           <a:prstGeom prst="rect">
@@ -4460,14 +5365,14 @@
               <a:buNone/>
             </a:pPr>
             <a:r>
-              <a:rPr lang="en-US" sz="1700" b="1" dirty="0">
+              <a:rPr lang="en-US" sz="1800" b="1" dirty="0">
                 <a:solidFill>
                   <a:schemeClr val="tx1"/>
                 </a:solidFill>
               </a:rPr>
-              <a:t>Research the web</a:t>
-            </a:r>
-            <a:endParaRPr lang="en-US" sz="1700" dirty="0"/>
+              <a:t>4. Enrich</a:t>
+            </a:r>
+            <a:endParaRPr lang="en-US" sz="1800" dirty="0"/>
           </a:p>
         </p:txBody>
       </p:sp>
@@ -4479,8 +5384,8 @@
         </p:nvSpPr>
         <p:spPr>
           <a:xfrm>
-            <a:off x="7552761" y="3977640"/>
-            <a:ext cx="1633667" cy="914400"/>
+            <a:off x="7552761" y="3886200"/>
+            <a:ext cx="1633667" cy="1005840"/>
           </a:xfrm>
           <a:prstGeom prst="rect">
             <a:avLst/>
@@ -4501,7 +5406,7 @@
                   <a:schemeClr val="tx2"/>
                 </a:solidFill>
               </a:rPr>
-              <a:t>Public scam reports, exchange's law-enforcement contact</a:t>
+              <a:t>Public scam reports + the VASP's law-enforcement contact</a:t>
             </a:r>
             <a:endParaRPr lang="en-US" sz="1400" dirty="0"/>
           </a:p>
@@ -4515,7 +5420,7 @@
         </p:nvSpPr>
         <p:spPr>
           <a:xfrm>
-            <a:off x="7552761" y="4937760"/>
+            <a:off x="7552761" y="4983480"/>
             <a:ext cx="1005840" cy="274320"/>
           </a:xfrm>
           <a:prstGeom prst="roundRect">
@@ -4542,7 +5447,7 @@
         </p:nvSpPr>
         <p:spPr>
           <a:xfrm>
-            <a:off x="7552761" y="4937760"/>
+            <a:off x="7552761" y="4983480"/>
             <a:ext cx="1005840" cy="274320"/>
           </a:xfrm>
           <a:prstGeom prst="rect">
@@ -4578,7 +5483,7 @@
         </p:nvSpPr>
         <p:spPr>
           <a:xfrm>
-            <a:off x="10231862" y="2377440"/>
+            <a:off x="10231862" y="2286000"/>
             <a:ext cx="822960" cy="822960"/>
           </a:xfrm>
           <a:prstGeom prst="ellipse">
@@ -4611,7 +5516,7 @@
         </p:blipFill>
         <p:spPr>
           <a:xfrm>
-            <a:off x="10445831" y="2591410"/>
+            <a:off x="10445831" y="2499970"/>
             <a:ext cx="395021" cy="395021"/>
           </a:xfrm>
           <a:prstGeom prst="rect">
@@ -4627,12 +5532,12 @@
         </p:nvSpPr>
         <p:spPr>
           <a:xfrm>
-            <a:off x="9643628" y="3383280"/>
-            <a:ext cx="1999427" cy="1965960"/>
+            <a:off x="9643628" y="3291840"/>
+            <a:ext cx="1999427" cy="2103120"/>
           </a:xfrm>
           <a:prstGeom prst="roundRect">
             <a:avLst>
-              <a:gd name="adj" fmla="val 3721"/>
+              <a:gd name="adj" fmla="val 3659"/>
             </a:avLst>
           </a:prstGeom>
           <a:solidFill>
@@ -4654,7 +5559,7 @@
         </p:nvSpPr>
         <p:spPr>
           <a:xfrm>
-            <a:off x="9826508" y="3520440"/>
+            <a:off x="9826508" y="3429000"/>
             <a:ext cx="1633667" cy="411480"/>
           </a:xfrm>
           <a:prstGeom prst="rect">
@@ -4671,14 +5576,14 @@
               <a:buNone/>
             </a:pPr>
             <a:r>
-              <a:rPr lang="en-US" sz="1700" b="1" dirty="0">
+              <a:rPr lang="en-US" sz="1800" b="1" dirty="0">
                 <a:solidFill>
                   <a:schemeClr val="tx1"/>
                 </a:solidFill>
               </a:rPr>
-              <a:t>Hand it over</a:t>
-            </a:r>
-            <a:endParaRPr lang="en-US" sz="1700" dirty="0"/>
+              <a:t>5. Act</a:t>
+            </a:r>
+            <a:endParaRPr lang="en-US" sz="1800" dirty="0"/>
           </a:p>
         </p:txBody>
       </p:sp>
@@ -4690,8 +5595,8 @@
         </p:nvSpPr>
         <p:spPr>
           <a:xfrm>
-            <a:off x="9826508" y="3977640"/>
-            <a:ext cx="1633667" cy="914400"/>
+            <a:off x="9826508" y="3886200"/>
+            <a:ext cx="1633667" cy="1005840"/>
           </a:xfrm>
           <a:prstGeom prst="rect">
             <a:avLst/>
@@ -4712,7 +5617,7 @@
                   <a:schemeClr val="tx2"/>
                 </a:solidFill>
               </a:rPr>
-              <a:t>Fund-flow graph, risk lead, contact, hashed evidence, draft freeze request</a:t>
+              <a:t>Risk category, alert, next steps, standard report, draft freeze request</a:t>
             </a:r>
             <a:endParaRPr lang="en-US" sz="1400" dirty="0"/>
           </a:p>
@@ -4726,7 +5631,7 @@
         </p:nvSpPr>
         <p:spPr>
           <a:xfrm>
-            <a:off x="9826508" y="4937760"/>
+            <a:off x="9826508" y="4983480"/>
             <a:ext cx="1005840" cy="274320"/>
           </a:xfrm>
           <a:prstGeom prst="roundRect">
@@ -4753,7 +5658,7 @@
         </p:nvSpPr>
         <p:spPr>
           <a:xfrm>
-            <a:off x="9826508" y="4937760"/>
+            <a:off x="9826508" y="4983480"/>
             <a:ext cx="1005840" cy="274320"/>
           </a:xfrm>
           <a:prstGeom prst="rect">
@@ -4871,7 +5776,7 @@
                   <a:schemeClr val="tx2"/>
                 </a:solidFill>
               </a:rPr>
-              <a:t>The risk score is a lead, not proof of guilt.</a:t>
+              <a:t>The risk category is a lead, not proof of guilt.</a:t>
             </a:r>
             <a:endParaRPr lang="en-US" sz="1500" dirty="0"/>
           </a:p>
@@ -5193,7 +6098,7 @@
                   <a:schemeClr val="tx2"/>
                 </a:solidFill>
               </a:rPr>
-              <a:t>Teams handling NCRP complaints and SAHYOG requests</a:t>
+              <a:t>Investigators handling NCRP complaints and SAHYOG requests</a:t>
             </a:r>
             <a:endParaRPr lang="en-US" sz="1400" dirty="0"/>
           </a:p>
@@ -5404,7 +6309,7 @@
                   <a:schemeClr val="tx2"/>
                 </a:solidFill>
               </a:rPr>
-              <a:t>Spot reported fraud flows landing on their platform</a:t>
+              <a:t>Faster, standard requests about reported fraud flows</a:t>
             </a:r>
             <a:endParaRPr lang="en-US" sz="1400" dirty="0"/>
           </a:p>
@@ -5693,7 +6598,7 @@
         <p:spPr>
           <a:xfrm>
             <a:off x="868680" y="4983480"/>
-            <a:ext cx="594360" cy="594360"/>
+            <a:ext cx="548640" cy="548640"/>
           </a:xfrm>
           <a:prstGeom prst="ellipse">
             <a:avLst/>
@@ -5725,8 +6630,8 @@
         </p:blipFill>
         <p:spPr>
           <a:xfrm>
-            <a:off x="1023214" y="5138014"/>
-            <a:ext cx="285293" cy="285293"/>
+            <a:off x="1011326" y="5126126"/>
+            <a:ext cx="263347" cy="263347"/>
           </a:xfrm>
           <a:prstGeom prst="rect">
             <a:avLst/>
@@ -5741,8 +6646,8 @@
         </p:nvSpPr>
         <p:spPr>
           <a:xfrm>
-            <a:off x="1645920" y="4937760"/>
-            <a:ext cx="2570378" cy="365760"/>
+            <a:off x="1554480" y="4919472"/>
+            <a:ext cx="1836344" cy="365760"/>
           </a:xfrm>
           <a:prstGeom prst="rect">
             <a:avLst/>
@@ -5758,14 +6663,14 @@
               <a:buNone/>
             </a:pPr>
             <a:r>
-              <a:rPr lang="en-US" sz="1600" b="1" dirty="0">
+              <a:rPr lang="en-US" sz="1500" b="1" dirty="0">
                 <a:solidFill>
                   <a:schemeClr val="bg1"/>
                 </a:solidFill>
               </a:rPr>
-              <a:t>Faster freezing</a:t>
-            </a:r>
-            <a:endParaRPr lang="en-US" sz="1600" dirty="0"/>
+              <a:t>Faster response</a:t>
+            </a:r>
+            <a:endParaRPr lang="en-US" sz="1500" dirty="0"/>
           </a:p>
         </p:txBody>
       </p:sp>
@@ -5777,8 +6682,8 @@
         </p:nvSpPr>
         <p:spPr>
           <a:xfrm>
-            <a:off x="1645920" y="5303520"/>
-            <a:ext cx="2570378" cy="365760"/>
+            <a:off x="1554480" y="5285232"/>
+            <a:ext cx="1836344" cy="502920"/>
           </a:xfrm>
           <a:prstGeom prst="rect">
             <a:avLst/>
@@ -5794,14 +6699,14 @@
               <a:buNone/>
             </a:pPr>
             <a:r>
-              <a:rPr lang="en-US" sz="1400" dirty="0">
+              <a:rPr lang="en-US" sz="1300" dirty="0">
                 <a:solidFill>
                   <a:schemeClr val="bg2"/>
                 </a:solidFill>
               </a:rPr>
-              <a:t>exchange and contact in one run</a:t>
-            </a:r>
-            <a:endParaRPr lang="en-US" sz="1400" dirty="0"/>
+              <a:t>exchange found in one run</a:t>
+            </a:r>
+            <a:endParaRPr lang="en-US" sz="1300" dirty="0"/>
           </a:p>
         </p:txBody>
       </p:sp>
@@ -5813,8 +6718,8 @@
         </p:nvSpPr>
         <p:spPr>
           <a:xfrm>
-            <a:off x="4353458" y="4983480"/>
-            <a:ext cx="594360" cy="594360"/>
+            <a:off x="3482264" y="4983480"/>
+            <a:ext cx="548640" cy="548640"/>
           </a:xfrm>
           <a:prstGeom prst="ellipse">
             <a:avLst/>
@@ -5846,8 +6751,8 @@
         </p:blipFill>
         <p:spPr>
           <a:xfrm>
-            <a:off x="4507992" y="5138014"/>
-            <a:ext cx="285293" cy="285293"/>
+            <a:off x="3624910" y="5126126"/>
+            <a:ext cx="263347" cy="263347"/>
           </a:xfrm>
           <a:prstGeom prst="rect">
             <a:avLst/>
@@ -5862,8 +6767,8 @@
         </p:nvSpPr>
         <p:spPr>
           <a:xfrm>
-            <a:off x="5130698" y="4937760"/>
-            <a:ext cx="2570378" cy="365760"/>
+            <a:off x="4168064" y="4919472"/>
+            <a:ext cx="1836344" cy="365760"/>
           </a:xfrm>
           <a:prstGeom prst="rect">
             <a:avLst/>
@@ -5879,14 +6784,14 @@
               <a:buNone/>
             </a:pPr>
             <a:r>
-              <a:rPr lang="en-US" sz="1600" b="1" dirty="0">
+              <a:rPr lang="en-US" sz="1500" b="1" dirty="0">
                 <a:solidFill>
                   <a:schemeClr val="bg1"/>
                 </a:solidFill>
               </a:rPr>
-              <a:t>Less reliance on rare experts</a:t>
-            </a:r>
-            <a:endParaRPr lang="en-US" sz="1600" dirty="0"/>
+              <a:t>More freezes</a:t>
+            </a:r>
+            <a:endParaRPr lang="en-US" sz="1500" dirty="0"/>
           </a:p>
         </p:txBody>
       </p:sp>
@@ -5898,8 +6803,8 @@
         </p:nvSpPr>
         <p:spPr>
           <a:xfrm>
-            <a:off x="5130698" y="5303520"/>
-            <a:ext cx="2570378" cy="365760"/>
+            <a:off x="4168064" y="5285232"/>
+            <a:ext cx="1836344" cy="502920"/>
           </a:xfrm>
           <a:prstGeom prst="rect">
             <a:avLst/>
@@ -5915,14 +6820,14 @@
               <a:buNone/>
             </a:pPr>
             <a:r>
-              <a:rPr lang="en-US" sz="1400" dirty="0">
+              <a:rPr lang="en-US" sz="1300" dirty="0">
                 <a:solidFill>
                   <a:schemeClr val="bg2"/>
                 </a:solidFill>
               </a:rPr>
-              <a:t>any trained officer can act</a:t>
-            </a:r>
-            <a:endParaRPr lang="en-US" sz="1400" dirty="0"/>
+              <a:t>request reaches the VASP sooner</a:t>
+            </a:r>
+            <a:endParaRPr lang="en-US" sz="1300" dirty="0"/>
           </a:p>
         </p:txBody>
       </p:sp>
@@ -5934,8 +6839,8 @@
         </p:nvSpPr>
         <p:spPr>
           <a:xfrm>
-            <a:off x="7838237" y="4983480"/>
-            <a:ext cx="594360" cy="594360"/>
+            <a:off x="6095848" y="4983480"/>
+            <a:ext cx="548640" cy="548640"/>
           </a:xfrm>
           <a:prstGeom prst="ellipse">
             <a:avLst/>
@@ -5967,8 +6872,8 @@
         </p:blipFill>
         <p:spPr>
           <a:xfrm>
-            <a:off x="7992770" y="5138014"/>
-            <a:ext cx="285293" cy="285293"/>
+            <a:off x="6238494" y="5126126"/>
+            <a:ext cx="263347" cy="263347"/>
           </a:xfrm>
           <a:prstGeom prst="rect">
             <a:avLst/>
@@ -5983,8 +6888,8 @@
         </p:nvSpPr>
         <p:spPr>
           <a:xfrm>
-            <a:off x="8615477" y="4937760"/>
-            <a:ext cx="2570378" cy="365760"/>
+            <a:off x="6781648" y="4919472"/>
+            <a:ext cx="1836344" cy="365760"/>
           </a:xfrm>
           <a:prstGeom prst="rect">
             <a:avLst/>
@@ -6000,14 +6905,14 @@
               <a:buNone/>
             </a:pPr>
             <a:r>
-              <a:rPr lang="en-US" sz="1600" b="1" dirty="0">
+              <a:rPr lang="en-US" sz="1500" b="1" dirty="0">
                 <a:solidFill>
                   <a:schemeClr val="bg1"/>
                 </a:solidFill>
               </a:rPr>
-              <a:t>Standardised evidence</a:t>
-            </a:r>
-            <a:endParaRPr lang="en-US" sz="1600" dirty="0"/>
+              <a:t>VASP coordination</a:t>
+            </a:r>
+            <a:endParaRPr lang="en-US" sz="1500" dirty="0"/>
           </a:p>
         </p:txBody>
       </p:sp>
@@ -6019,8 +6924,8 @@
         </p:nvSpPr>
         <p:spPr>
           <a:xfrm>
-            <a:off x="8615477" y="5303520"/>
-            <a:ext cx="2570378" cy="365760"/>
+            <a:off x="6781648" y="5285232"/>
+            <a:ext cx="1836344" cy="502920"/>
           </a:xfrm>
           <a:prstGeom prst="rect">
             <a:avLst/>
@@ -6036,14 +6941,135 @@
               <a:buNone/>
             </a:pPr>
             <a:r>
-              <a:rPr lang="en-US" sz="1400" dirty="0">
+              <a:rPr lang="en-US" sz="1300" dirty="0">
                 <a:solidFill>
                   <a:schemeClr val="bg2"/>
                 </a:solidFill>
               </a:rPr>
-              <a:t>same report, hashed snapshots</a:t>
-            </a:r>
-            <a:endParaRPr lang="en-US" sz="1400" dirty="0"/>
+              <a:t>right contact, standard format</a:t>
+            </a:r>
+            <a:endParaRPr lang="en-US" sz="1300" dirty="0"/>
+          </a:p>
+        </p:txBody>
+      </p:sp>
+      <p:sp>
+        <p:nvSpPr>
+          <p:cNvPr id="38" name="val3-circle"/>
+          <p:cNvSpPr/>
+          <p:nvPr/>
+        </p:nvSpPr>
+        <p:spPr>
+          <a:xfrm>
+            <a:off x="8709431" y="4983480"/>
+            <a:ext cx="548640" cy="548640"/>
+          </a:xfrm>
+          <a:prstGeom prst="ellipse">
+            <a:avLst/>
+          </a:prstGeom>
+          <a:solidFill>
+            <a:schemeClr val="accent1"/>
+          </a:solidFill>
+          <a:ln w="12700">
+            <a:solidFill>
+              <a:schemeClr val="accent1"/>
+            </a:solidFill>
+            <a:prstDash val="solid"/>
+          </a:ln>
+        </p:spPr>
+      </p:sp>
+      <p:pic>
+        <p:nvPicPr>
+          <p:cNvPr id="39" name="val3-icon" descr="preencoded.png">    </p:cNvPr>
+          <p:cNvPicPr>
+            <a:picLocks noChangeAspect="1"/>
+          </p:cNvPicPr>
+          <p:nvPr/>
+        </p:nvPicPr>
+        <p:blipFill>
+          <a:blip r:embed="rId7"/>
+          <a:stretch>
+            <a:fillRect/>
+          </a:stretch>
+        </p:blipFill>
+        <p:spPr>
+          <a:xfrm>
+            <a:off x="8852078" y="5126126"/>
+            <a:ext cx="263347" cy="263347"/>
+          </a:xfrm>
+          <a:prstGeom prst="rect">
+            <a:avLst/>
+          </a:prstGeom>
+        </p:spPr>
+      </p:pic>
+      <p:sp>
+        <p:nvSpPr>
+          <p:cNvPr id="40" name="Text 31"/>
+          <p:cNvSpPr txBox="1"/>
+          <p:nvPr/>
+        </p:nvSpPr>
+        <p:spPr>
+          <a:xfrm>
+            <a:off x="9395231" y="4919472"/>
+            <a:ext cx="1836344" cy="365760"/>
+          </a:xfrm>
+          <a:prstGeom prst="rect">
+            <a:avLst/>
+          </a:prstGeom>
+          <a:noFill/>
+          <a:ln/>
+        </p:spPr>
+        <p:txBody>
+          <a:bodyPr wrap="square" lIns="0" tIns="0" rIns="0" bIns="0" rtlCol="0" anchor="t"/>
+          <a:lstStyle/>
+          <a:p>
+            <a:pPr indent="0" marL="0">
+              <a:buNone/>
+            </a:pPr>
+            <a:r>
+              <a:rPr lang="en-US" sz="1500" b="1" dirty="0">
+                <a:solidFill>
+                  <a:schemeClr val="bg1"/>
+                </a:solidFill>
+              </a:rPr>
+              <a:t>Stronger evidence</a:t>
+            </a:r>
+            <a:endParaRPr lang="en-US" sz="1500" dirty="0"/>
+          </a:p>
+        </p:txBody>
+      </p:sp>
+      <p:sp>
+        <p:nvSpPr>
+          <p:cNvPr id="41" name="Text 32"/>
+          <p:cNvSpPr txBox="1"/>
+          <p:nvPr/>
+        </p:nvSpPr>
+        <p:spPr>
+          <a:xfrm>
+            <a:off x="9395231" y="5285232"/>
+            <a:ext cx="1836344" cy="502920"/>
+          </a:xfrm>
+          <a:prstGeom prst="rect">
+            <a:avLst/>
+          </a:prstGeom>
+          <a:noFill/>
+          <a:ln/>
+        </p:spPr>
+        <p:txBody>
+          <a:bodyPr wrap="square" lIns="0" tIns="0" rIns="0" bIns="0" rtlCol="0" anchor="t"/>
+          <a:lstStyle/>
+          <a:p>
+            <a:pPr indent="0" marL="0">
+              <a:buNone/>
+            </a:pPr>
+            <a:r>
+              <a:rPr lang="en-US" sz="1300" dirty="0">
+                <a:solidFill>
+                  <a:schemeClr val="bg2"/>
+                </a:solidFill>
+              </a:rPr>
+              <a:t>timestamped, hashed snapshots</a:t>
+            </a:r>
+            <a:endParaRPr lang="en-US" sz="1300" dirty="0"/>
           </a:p>
         </p:txBody>
       </p:sp>
@@ -6166,12 +7192,12 @@
         </p:nvSpPr>
         <p:spPr>
           <a:xfrm>
-            <a:off x="548640" y="2377440"/>
-            <a:ext cx="1554480" cy="1188720"/>
+            <a:off x="548640" y="2331720"/>
+            <a:ext cx="1600200" cy="1280160"/>
           </a:xfrm>
           <a:prstGeom prst="roundRect">
             <a:avLst>
-              <a:gd name="adj" fmla="val 6154"/>
+              <a:gd name="adj" fmla="val 5714"/>
             </a:avLst>
           </a:prstGeom>
           <a:solidFill>
@@ -6193,8 +7219,8 @@
         </p:nvSpPr>
         <p:spPr>
           <a:xfrm>
-            <a:off x="658368" y="2432304"/>
-            <a:ext cx="1335024" cy="1078992"/>
+            <a:off x="658368" y="2386584"/>
+            <a:ext cx="1380744" cy="1170432"/>
           </a:xfrm>
           <a:prstGeom prst="rect">
             <a:avLst/>
@@ -6229,7 +7255,7 @@
                   <a:schemeClr val="bg1"/>
                 </a:solidFill>
               </a:rPr>
-              <a:t>Dashboard</a:t>
+              <a:t>NCRP / SAHYOG feed</a:t>
             </a:r>
             <a:endParaRPr lang="en-US" sz="1400" dirty="0"/>
           </a:p>
@@ -6243,7 +7269,7 @@
                   <a:schemeClr val="bg1"/>
                 </a:solidFill>
               </a:rPr>
-              <a:t>REST API</a:t>
+              <a:t>Dashboard  |  API</a:t>
             </a:r>
             <a:endParaRPr lang="en-US" sz="1400" dirty="0"/>
           </a:p>
@@ -6257,8 +7283,8 @@
         </p:nvSpPr>
         <p:spPr>
           <a:xfrm>
-            <a:off x="2103120" y="2971800"/>
-            <a:ext cx="320040" cy="0"/>
+            <a:off x="2148840" y="2971800"/>
+            <a:ext cx="274320" cy="0"/>
           </a:xfrm>
           <a:prstGeom prst="line">
             <a:avLst/>
@@ -6281,12 +7307,12 @@
         </p:nvSpPr>
         <p:spPr>
           <a:xfrm>
-            <a:off x="2423160" y="2377440"/>
-            <a:ext cx="1920240" cy="1188720"/>
+            <a:off x="2423160" y="2331720"/>
+            <a:ext cx="1920240" cy="1280160"/>
           </a:xfrm>
           <a:prstGeom prst="roundRect">
             <a:avLst>
-              <a:gd name="adj" fmla="val 6154"/>
+              <a:gd name="adj" fmla="val 5714"/>
             </a:avLst>
           </a:prstGeom>
           <a:solidFill>
@@ -6308,8 +7334,8 @@
         </p:nvSpPr>
         <p:spPr>
           <a:xfrm>
-            <a:off x="2532888" y="2432304"/>
-            <a:ext cx="1700784" cy="1078992"/>
+            <a:off x="2532888" y="2386584"/>
+            <a:ext cx="1700784" cy="1170432"/>
           </a:xfrm>
           <a:prstGeom prst="rect">
             <a:avLst/>
@@ -6469,7 +7495,7 @@
                   <a:schemeClr val="bg1"/>
                 </a:solidFill>
               </a:rPr>
-              <a:t>Transaction graph, laundering patterns, exchange deposit match</a:t>
+              <a:t>Multi-chain transaction graph, exchange-wallet clustering, laundering patterns</a:t>
             </a:r>
             <a:endParaRPr lang="en-US" sz="1400" dirty="0"/>
           </a:p>
@@ -6874,11 +7900,11 @@
         <p:spPr>
           <a:xfrm>
             <a:off x="8458200" y="2514600"/>
-            <a:ext cx="1508760" cy="1051560"/>
+            <a:ext cx="1508760" cy="1097280"/>
           </a:xfrm>
           <a:prstGeom prst="roundRect">
             <a:avLst>
-              <a:gd name="adj" fmla="val 6957"/>
+              <a:gd name="adj" fmla="val 6667"/>
             </a:avLst>
           </a:prstGeom>
           <a:solidFill>
@@ -6901,7 +7927,7 @@
         <p:spPr>
           <a:xfrm>
             <a:off x="8567928" y="2569464"/>
-            <a:ext cx="1289304" cy="941832"/>
+            <a:ext cx="1289304" cy="987552"/>
           </a:xfrm>
           <a:prstGeom prst="rect">
             <a:avLst/>
@@ -6936,7 +7962,7 @@
                   <a:schemeClr val="bg1"/>
                 </a:solidFill>
               </a:rPr>
-              <a:t>Rules now, ML later</a:t>
+              <a:t>Rules now, ML typologies next</a:t>
             </a:r>
             <a:endParaRPr lang="en-US" sz="1400" dirty="0"/>
           </a:p>
@@ -6950,7 +7976,7 @@
         </p:nvSpPr>
         <p:spPr>
           <a:xfrm>
-            <a:off x="9966960" y="3044952"/>
+            <a:off x="9966960" y="3063240"/>
             <a:ext cx="274320" cy="0"/>
           </a:xfrm>
           <a:prstGeom prst="line">
@@ -6974,12 +8000,12 @@
         </p:nvSpPr>
         <p:spPr>
           <a:xfrm>
-            <a:off x="10241280" y="2377440"/>
-            <a:ext cx="1399032" cy="1325880"/>
+            <a:off x="10241280" y="2331720"/>
+            <a:ext cx="1399032" cy="1463040"/>
           </a:xfrm>
           <a:prstGeom prst="roundRect">
             <a:avLst>
-              <a:gd name="adj" fmla="val 5517"/>
+              <a:gd name="adj" fmla="val 5229"/>
             </a:avLst>
           </a:prstGeom>
           <a:solidFill>
@@ -7001,8 +8027,8 @@
         </p:nvSpPr>
         <p:spPr>
           <a:xfrm>
-            <a:off x="10351008" y="2432304"/>
-            <a:ext cx="1179576" cy="1216152"/>
+            <a:off x="10351008" y="2386584"/>
+            <a:ext cx="1179576" cy="1353312"/>
           </a:xfrm>
           <a:prstGeom prst="rect">
             <a:avLst/>
@@ -7023,7 +8049,7 @@
                   <a:schemeClr val="bg1"/>
                 </a:solidFill>
               </a:rPr>
-              <a:t>Investigator report</a:t>
+              <a:t>Outputs</a:t>
             </a:r>
             <a:endParaRPr lang="en-US" sz="1400" dirty="0"/>
           </a:p>
@@ -7037,7 +8063,7 @@
                   <a:schemeClr val="bg1"/>
                 </a:solidFill>
               </a:rPr>
-              <a:t>Graph, contact, evidence, PDF</a:t>
+              <a:t>Dashboard, alerts, standard report, LEA APIs</a:t>
             </a:r>
             <a:endParaRPr lang="en-US" sz="1400" dirty="0"/>
           </a:p>
@@ -7073,7 +8099,7 @@
                   <a:schemeClr val="accent5"/>
                 </a:solidFill>
               </a:rPr>
-              <a:t>Blockchain APIs (Etherscan, TronGrid) feed the on-chain engine; the open web (scam-report sites, exchange sites) feeds TinyFish.</a:t>
+              <a:t>Blockchain explorer / node APIs feed the on-chain engine. The open web (scam-report sites, exchange sites) feeds TinyFish.</a:t>
             </a:r>
             <a:endParaRPr lang="en-US" sz="1300" dirty="0"/>
           </a:p>
@@ -7160,7 +8186,7 @@
         <p:spPr>
           <a:xfrm>
             <a:off x="1371600" y="5833872"/>
-            <a:ext cx="1563624" cy="329184"/>
+            <a:ext cx="1444752" cy="329184"/>
           </a:xfrm>
           <a:prstGeom prst="roundRect">
             <a:avLst>
@@ -7187,7 +8213,7 @@
         <p:spPr>
           <a:xfrm>
             <a:off x="1371600" y="5833872"/>
-            <a:ext cx="1563624" cy="329184"/>
+            <a:ext cx="1444752" cy="329184"/>
           </a:xfrm>
           <a:prstGeom prst="rect">
             <a:avLst/>
@@ -7222,8 +8248,8 @@
         </p:nvSpPr>
         <p:spPr>
           <a:xfrm>
-            <a:off x="3044952" y="5833872"/>
-            <a:ext cx="1252728" cy="329184"/>
+            <a:off x="2907792" y="5833872"/>
+            <a:ext cx="1152144" cy="329184"/>
           </a:xfrm>
           <a:prstGeom prst="roundRect">
             <a:avLst>
@@ -7249,8 +8275,8 @@
         </p:nvSpPr>
         <p:spPr>
           <a:xfrm>
-            <a:off x="3044952" y="5833872"/>
-            <a:ext cx="1252728" cy="329184"/>
+            <a:off x="2907792" y="5833872"/>
+            <a:ext cx="1152144" cy="329184"/>
           </a:xfrm>
           <a:prstGeom prst="rect">
             <a:avLst/>
@@ -7285,8 +8311,8 @@
         </p:nvSpPr>
         <p:spPr>
           <a:xfrm>
-            <a:off x="4407408" y="5833872"/>
-            <a:ext cx="1097280" cy="329184"/>
+            <a:off x="4151376" y="5833872"/>
+            <a:ext cx="1005840" cy="329184"/>
           </a:xfrm>
           <a:prstGeom prst="roundRect">
             <a:avLst>
@@ -7312,8 +8338,8 @@
         </p:nvSpPr>
         <p:spPr>
           <a:xfrm>
-            <a:off x="4407408" y="5833872"/>
-            <a:ext cx="1097280" cy="329184"/>
+            <a:off x="4151376" y="5833872"/>
+            <a:ext cx="1005840" cy="329184"/>
           </a:xfrm>
           <a:prstGeom prst="rect">
             <a:avLst/>
@@ -7348,8 +8374,8 @@
         </p:nvSpPr>
         <p:spPr>
           <a:xfrm>
-            <a:off x="5614416" y="5833872"/>
-            <a:ext cx="1408176" cy="329184"/>
+            <a:off x="5248656" y="5833872"/>
+            <a:ext cx="1298448" cy="329184"/>
           </a:xfrm>
           <a:prstGeom prst="roundRect">
             <a:avLst>
@@ -7375,8 +8401,8 @@
         </p:nvSpPr>
         <p:spPr>
           <a:xfrm>
-            <a:off x="5614416" y="5833872"/>
-            <a:ext cx="1408176" cy="329184"/>
+            <a:off x="5248656" y="5833872"/>
+            <a:ext cx="1298448" cy="329184"/>
           </a:xfrm>
           <a:prstGeom prst="rect">
             <a:avLst/>
@@ -7411,8 +8437,8 @@
         </p:nvSpPr>
         <p:spPr>
           <a:xfrm>
-            <a:off x="7132320" y="5833872"/>
-            <a:ext cx="1719072" cy="329184"/>
+            <a:off x="6638544" y="5833872"/>
+            <a:ext cx="1371600" cy="329184"/>
           </a:xfrm>
           <a:prstGeom prst="roundRect">
             <a:avLst>
@@ -7438,8 +8464,8 @@
         </p:nvSpPr>
         <p:spPr>
           <a:xfrm>
-            <a:off x="7132320" y="5833872"/>
-            <a:ext cx="1719072" cy="329184"/>
+            <a:off x="6638544" y="5833872"/>
+            <a:ext cx="1371600" cy="329184"/>
           </a:xfrm>
           <a:prstGeom prst="rect">
             <a:avLst/>
@@ -7460,7 +8486,7 @@
                   <a:schemeClr val="bg1"/>
                 </a:solidFill>
               </a:rPr>
-              <a:t>React + graph view</a:t>
+              <a:t>React dashboard</a:t>
             </a:r>
             <a:endParaRPr lang="en-US" sz="1200" dirty="0"/>
           </a:p>
@@ -7474,8 +8500,8 @@
         </p:nvSpPr>
         <p:spPr>
           <a:xfrm>
-            <a:off x="8961120" y="5833872"/>
-            <a:ext cx="1175004" cy="329184"/>
+            <a:off x="8101584" y="5833872"/>
+            <a:ext cx="1591056" cy="329184"/>
           </a:xfrm>
           <a:prstGeom prst="roundRect">
             <a:avLst>
@@ -7501,8 +8527,8 @@
         </p:nvSpPr>
         <p:spPr>
           <a:xfrm>
-            <a:off x="8961120" y="5833872"/>
-            <a:ext cx="1175004" cy="329184"/>
+            <a:off x="8101584" y="5833872"/>
+            <a:ext cx="1591056" cy="329184"/>
           </a:xfrm>
           <a:prstGeom prst="rect">
             <a:avLst/>
@@ -7523,7 +8549,7 @@
                   <a:schemeClr val="bg1"/>
                 </a:solidFill>
               </a:rPr>
-              <a:t>PDF reports</a:t>
+              <a:t>PDF / JSON reports</a:t>
             </a:r>
             <a:endParaRPr lang="en-US" sz="1200" dirty="0"/>
           </a:p>
@@ -7537,8 +8563,8 @@
         </p:nvSpPr>
         <p:spPr>
           <a:xfrm>
-            <a:off x="10245852" y="5833872"/>
-            <a:ext cx="1252728" cy="329184"/>
+            <a:off x="9784080" y="5833872"/>
+            <a:ext cx="1152144" cy="329184"/>
           </a:xfrm>
           <a:prstGeom prst="roundRect">
             <a:avLst>
@@ -7564,8 +8590,8 @@
         </p:nvSpPr>
         <p:spPr>
           <a:xfrm>
-            <a:off x="10245852" y="5833872"/>
-            <a:ext cx="1252728" cy="329184"/>
+            <a:off x="9784080" y="5833872"/>
+            <a:ext cx="1152144" cy="329184"/>
           </a:xfrm>
           <a:prstGeom prst="rect">
             <a:avLst/>
@@ -8729,7 +9755,7 @@
                   <a:schemeClr val="accent1"/>
                 </a:solidFill>
               </a:rPr>
-              <a:t>BUILDABLE IN 24 HOURS</a:t>
+              <a:t>MVP: BUILDABLE IN 24 HOURS</a:t>
             </a:r>
             <a:endParaRPr lang="en-US" sz="1300" dirty="0"/>
           </a:p>
@@ -8984,7 +10010,7 @@
                   <a:schemeClr val="bg1"/>
                 </a:solidFill>
               </a:rPr>
-              <a:t>Trace to a known exchange</a:t>
+              <a:t>Trace to the nearest exchange</a:t>
             </a:r>
             <a:endParaRPr lang="en-US" sz="1400" dirty="0"/>
           </a:p>
@@ -9069,7 +10095,7 @@
                   <a:schemeClr val="bg1"/>
                 </a:solidFill>
               </a:rPr>
-              <a:t>TinyFish: wallet mentions + exchange contact</a:t>
+              <a:t>TinyFish: wallet reports + VASP contact</a:t>
             </a:r>
             <a:endParaRPr lang="en-US" sz="1400" dirty="0"/>
           </a:p>
@@ -9154,7 +10180,7 @@
                   <a:schemeClr val="bg1"/>
                 </a:solidFill>
               </a:rPr>
-              <a:t>One-page investigator report</a:t>
+              <a:t>Risk category + standard report</a:t>
             </a:r>
             <a:endParaRPr lang="en-US" sz="1400" dirty="0"/>
           </a:p>
@@ -9169,7 +10195,7 @@
         <p:spPr>
           <a:xfrm>
             <a:off x="822960" y="4846320"/>
-            <a:ext cx="3154680" cy="914400"/>
+            <a:ext cx="3154680" cy="1097280"/>
           </a:xfrm>
           <a:prstGeom prst="rect">
             <a:avLst/>
@@ -9190,7 +10216,7 @@
                   <a:schemeClr val="bg2"/>
                 </a:solidFill>
               </a:rPr>
-              <a:t>Roadmap: more chains, cross-chain bridges, ML scoring, NCRP/SAHYOG integration</a:t>
+              <a:t>Next: Bitcoin + BSC, bridge / cross-chain tracing, ML typologies, NCRP and SAHYOG integration, own indexer at scale</a:t>
             </a:r>
             <a:endParaRPr lang="en-US" sz="1300" dirty="0"/>
           </a:p>
@@ -9290,7 +10316,7 @@
         <p:spPr>
           <a:xfrm>
             <a:off x="5166360" y="1691640"/>
-            <a:ext cx="2560320" cy="685800"/>
+            <a:ext cx="2560320" cy="640080"/>
           </a:xfrm>
           <a:prstGeom prst="rect">
             <a:avLst/>
@@ -9311,7 +10337,7 @@
                   <a:schemeClr val="tx1"/>
                 </a:solidFill>
               </a:rPr>
-              <a:t>New exchange or chain = one config entry, no new scraper</a:t>
+              <a:t>New chain or exchange = one config entry, no new scraper</a:t>
             </a:r>
             <a:endParaRPr lang="en-US" sz="1400" dirty="0"/>
           </a:p>
@@ -9325,7 +10351,7 @@
         </p:nvSpPr>
         <p:spPr>
           <a:xfrm>
-            <a:off x="4480560" y="2606040"/>
+            <a:off x="4480560" y="2560320"/>
             <a:ext cx="502920" cy="502920"/>
           </a:xfrm>
           <a:prstGeom prst="ellipse">
@@ -9358,7 +10384,7 @@
         </p:blipFill>
         <p:spPr>
           <a:xfrm>
-            <a:off x="4611319" y="2736799"/>
+            <a:off x="4611319" y="2691079"/>
             <a:ext cx="241402" cy="241402"/>
           </a:xfrm>
           <a:prstGeom prst="rect">
@@ -9374,8 +10400,8 @@
         </p:nvSpPr>
         <p:spPr>
           <a:xfrm>
-            <a:off x="5166360" y="2560320"/>
-            <a:ext cx="2560320" cy="685800"/>
+            <a:off x="5166360" y="2514600"/>
+            <a:ext cx="2560320" cy="640080"/>
           </a:xfrm>
           <a:prstGeom prst="rect">
             <a:avLst/>
@@ -9410,7 +10436,7 @@
         </p:nvSpPr>
         <p:spPr>
           <a:xfrm>
-            <a:off x="4480560" y="3474720"/>
+            <a:off x="4480560" y="3383280"/>
             <a:ext cx="502920" cy="502920"/>
           </a:xfrm>
           <a:prstGeom prst="ellipse">
@@ -9443,7 +10469,7 @@
         </p:blipFill>
         <p:spPr>
           <a:xfrm>
-            <a:off x="4611319" y="3605479"/>
+            <a:off x="4611319" y="3514039"/>
             <a:ext cx="241402" cy="241402"/>
           </a:xfrm>
           <a:prstGeom prst="rect">
@@ -9459,8 +10485,8 @@
         </p:nvSpPr>
         <p:spPr>
           <a:xfrm>
-            <a:off x="5166360" y="3429000"/>
-            <a:ext cx="2560320" cy="685800"/>
+            <a:off x="5166360" y="3337560"/>
+            <a:ext cx="2560320" cy="640080"/>
           </a:xfrm>
           <a:prstGeom prst="rect">
             <a:avLst/>
@@ -9481,7 +10507,7 @@
                   <a:schemeClr val="tx1"/>
                 </a:solidFill>
               </a:rPr>
-              <a:t>Exchange contacts cached and reused across cases</a:t>
+              <a:t>VASP contacts cached and reused across cases</a:t>
             </a:r>
             <a:endParaRPr lang="en-US" sz="1400" dirty="0"/>
           </a:p>
@@ -9489,14 +10515,99 @@
       </p:sp>
       <p:sp>
         <p:nvSpPr>
-          <p:cNvPr id="31" name="Text 21"/>
-          <p:cNvSpPr txBox="1"/>
-          <p:nvPr/>
-        </p:nvSpPr>
-        <p:spPr>
-          <a:xfrm>
-            <a:off x="4480560" y="4434840"/>
-            <a:ext cx="3246120" cy="685800"/>
+          <p:cNvPr id="31" name="scl3-circle"/>
+          <p:cNvSpPr/>
+          <p:nvPr/>
+        </p:nvSpPr>
+        <p:spPr>
+          <a:xfrm>
+            <a:off x="4480560" y="4206240"/>
+            <a:ext cx="502920" cy="502920"/>
+          </a:xfrm>
+          <a:prstGeom prst="ellipse">
+            <a:avLst/>
+          </a:prstGeom>
+          <a:solidFill>
+            <a:schemeClr val="accent2"/>
+          </a:solidFill>
+          <a:ln w="12700">
+            <a:solidFill>
+              <a:schemeClr val="accent2"/>
+            </a:solidFill>
+            <a:prstDash val="solid"/>
+          </a:ln>
+        </p:spPr>
+      </p:sp>
+      <p:pic>
+        <p:nvPicPr>
+          <p:cNvPr id="32" name="scl3-icon" descr="preencoded.png">    </p:cNvPr>
+          <p:cNvPicPr>
+            <a:picLocks noChangeAspect="1"/>
+          </p:cNvPicPr>
+          <p:nvPr/>
+        </p:nvPicPr>
+        <p:blipFill>
+          <a:blip r:embed="rId9"/>
+          <a:stretch>
+            <a:fillRect/>
+          </a:stretch>
+        </p:blipFill>
+        <p:spPr>
+          <a:xfrm>
+            <a:off x="4611319" y="4336999"/>
+            <a:ext cx="241402" cy="241402"/>
+          </a:xfrm>
+          <a:prstGeom prst="rect">
+            <a:avLst/>
+          </a:prstGeom>
+        </p:spPr>
+      </p:pic>
+      <p:sp>
+        <p:nvSpPr>
+          <p:cNvPr id="33" name="Text 22"/>
+          <p:cNvSpPr txBox="1"/>
+          <p:nvPr/>
+        </p:nvSpPr>
+        <p:spPr>
+          <a:xfrm>
+            <a:off x="5166360" y="4160520"/>
+            <a:ext cx="2560320" cy="640080"/>
+          </a:xfrm>
+          <a:prstGeom prst="rect">
+            <a:avLst/>
+          </a:prstGeom>
+          <a:noFill/>
+          <a:ln/>
+        </p:spPr>
+        <p:txBody>
+          <a:bodyPr wrap="square" lIns="0" tIns="0" rIns="0" bIns="0" rtlCol="0" anchor="ctr"/>
+          <a:lstStyle/>
+          <a:p>
+            <a:pPr indent="0" marL="0">
+              <a:buNone/>
+            </a:pPr>
+            <a:r>
+              <a:rPr lang="en-US" sz="1400" dirty="0">
+                <a:solidFill>
+                  <a:schemeClr val="tx1"/>
+                </a:solidFill>
+              </a:rPr>
+              <a:t>REST API for NCRP / SAHYOG and other LEA systems</a:t>
+            </a:r>
+            <a:endParaRPr lang="en-US" sz="1400" dirty="0"/>
+          </a:p>
+        </p:txBody>
+      </p:sp>
+      <p:sp>
+        <p:nvSpPr>
+          <p:cNvPr id="34" name="Text 23"/>
+          <p:cNvSpPr txBox="1"/>
+          <p:nvPr/>
+        </p:nvSpPr>
+        <p:spPr>
+          <a:xfrm>
+            <a:off x="4480560" y="5120640"/>
+            <a:ext cx="3246120" cy="731520"/>
           </a:xfrm>
           <a:prstGeom prst="rect">
             <a:avLst/>
@@ -9517,7 +10628,7 @@
                   <a:schemeClr val="accent3"/>
                 </a:solidFill>
               </a:rPr>
-              <a:t>Feasible now: existing blockchain APIs + TinyFish, no custom indexer</a:t>
+              <a:t>Feasible now: existing blockchain APIs + TinyFish, no custom indexer for the MVP</a:t>
             </a:r>
             <a:endParaRPr lang="en-US" sz="1400" dirty="0"/>
           </a:p>
@@ -9525,7 +10636,7 @@
       </p:sp>
       <p:sp>
         <p:nvSpPr>
-          <p:cNvPr id="32" name="Text 22"/>
+          <p:cNvPr id="35" name="Text 24"/>
           <p:cNvSpPr txBox="1"/>
           <p:nvPr/>
         </p:nvSpPr>
@@ -9561,7 +10672,7 @@
       </p:sp>
       <p:sp>
         <p:nvSpPr>
-          <p:cNvPr id="33" name="risk0"/>
+          <p:cNvPr id="36" name="risk0"/>
           <p:cNvSpPr/>
           <p:nvPr/>
         </p:nvSpPr>
@@ -9588,7 +10699,7 @@
       </p:sp>
       <p:sp>
         <p:nvSpPr>
-          <p:cNvPr id="34" name="Text 24"/>
+          <p:cNvPr id="37" name="Text 26"/>
           <p:cNvSpPr txBox="1"/>
           <p:nvPr/>
         </p:nvSpPr>
@@ -9624,7 +10735,7 @@
       </p:sp>
       <p:sp>
         <p:nvSpPr>
-          <p:cNvPr id="35" name="Text 25"/>
+          <p:cNvPr id="38" name="Text 27"/>
           <p:cNvSpPr txBox="1"/>
           <p:nvPr/>
         </p:nvSpPr>
@@ -9660,7 +10771,7 @@
       </p:sp>
       <p:sp>
         <p:nvSpPr>
-          <p:cNvPr id="36" name="risk1"/>
+          <p:cNvPr id="39" name="risk1"/>
           <p:cNvSpPr/>
           <p:nvPr/>
         </p:nvSpPr>
@@ -9687,7 +10798,7 @@
       </p:sp>
       <p:sp>
         <p:nvSpPr>
-          <p:cNvPr id="37" name="Text 27"/>
+          <p:cNvPr id="40" name="Text 29"/>
           <p:cNvSpPr txBox="1"/>
           <p:nvPr/>
         </p:nvSpPr>
@@ -9723,7 +10834,7 @@
       </p:sp>
       <p:sp>
         <p:nvSpPr>
-          <p:cNvPr id="38" name="Text 28"/>
+          <p:cNvPr id="41" name="Text 30"/>
           <p:cNvSpPr txBox="1"/>
           <p:nvPr/>
         </p:nvSpPr>
@@ -9759,7 +10870,7 @@
       </p:sp>
       <p:sp>
         <p:nvSpPr>
-          <p:cNvPr id="39" name="risk2"/>
+          <p:cNvPr id="42" name="risk2"/>
           <p:cNvSpPr/>
           <p:nvPr/>
         </p:nvSpPr>
@@ -9786,7 +10897,7 @@
       </p:sp>
       <p:sp>
         <p:nvSpPr>
-          <p:cNvPr id="40" name="Text 30"/>
+          <p:cNvPr id="43" name="Text 32"/>
           <p:cNvSpPr txBox="1"/>
           <p:nvPr/>
         </p:nvSpPr>
@@ -9814,7 +10925,7 @@
                   <a:schemeClr val="accent4"/>
                 </a:solidFill>
               </a:rPr>
-              <a:t>False positives</a:t>
+              <a:t>Mixers and privacy tools</a:t>
             </a:r>
             <a:endParaRPr lang="en-US" sz="1400" dirty="0"/>
           </a:p>
@@ -9822,7 +10933,7 @@
       </p:sp>
       <p:sp>
         <p:nvSpPr>
-          <p:cNvPr id="41" name="Text 31"/>
+          <p:cNvPr id="44" name="Text 33"/>
           <p:cNvSpPr txBox="1"/>
           <p:nvPr/>
         </p:nvSpPr>
@@ -9850,7 +10961,7 @@
                   <a:schemeClr val="tx2"/>
                 </a:solidFill>
               </a:rPr>
-              <a:t>Human review; score explained point by point</a:t>
+              <a:t>Flag where the trail breaks; expert review</a:t>
             </a:r>
             <a:endParaRPr lang="en-US" sz="1300" dirty="0"/>
           </a:p>
@@ -9858,7 +10969,7 @@
       </p:sp>
       <p:sp>
         <p:nvSpPr>
-          <p:cNvPr id="42" name="risk3"/>
+          <p:cNvPr id="45" name="risk3"/>
           <p:cNvSpPr/>
           <p:nvPr/>
         </p:nvSpPr>
@@ -9885,7 +10996,7 @@
       </p:sp>
       <p:sp>
         <p:nvSpPr>
-          <p:cNvPr id="43" name="Text 33"/>
+          <p:cNvPr id="46" name="Text 35"/>
           <p:cNvSpPr txBox="1"/>
           <p:nvPr/>
         </p:nvSpPr>
@@ -9913,7 +11024,7 @@
                   <a:schemeClr val="accent4"/>
                 </a:solidFill>
               </a:rPr>
-              <a:t>Legal limits</a:t>
+              <a:t>False positives</a:t>
             </a:r>
             <a:endParaRPr lang="en-US" sz="1400" dirty="0"/>
           </a:p>
@@ -9921,7 +11032,7 @@
       </p:sp>
       <p:sp>
         <p:nvSpPr>
-          <p:cNvPr id="44" name="Text 34"/>
+          <p:cNvPr id="47" name="Text 36"/>
           <p:cNvSpPr txBox="1"/>
           <p:nvPr/>
         </p:nvSpPr>
@@ -9949,7 +11060,7 @@
                   <a:schemeClr val="tx2"/>
                 </a:solidFill>
               </a:rPr>
-              <a:t>Authorised use, audit log, agents never log in</a:t>
+              <a:t>Human review; score explained point by point</a:t>
             </a:r>
             <a:endParaRPr lang="en-US" sz="1300" dirty="0"/>
           </a:p>
@@ -10417,7 +11528,7 @@
                   <a:schemeClr val="bg1"/>
                 </a:solidFill>
               </a:rPr>
-              <a:t>USDT in self-custody wallets</a:t>
+              <a:t>Self-custody USDT</a:t>
             </a:r>
             <a:endParaRPr lang="en-US" sz="1500" dirty="0"/>
           </a:p>

</xml_diff>

<commit_message>
Revise 9-slide deck: remove attribution overclaims, clarify TinyFish roles and MVP scope
Co-Authored-By: Claude Opus 5.5 <noreply@anthropic.com>
Claude-Session: https://claude.ai/code/session_01RiioRpvzPREAo253VWx5eZ
</commit_message>
<xml_diff>
--- a/docs/pitch/ChainSight_Round1_9slides.pptx
+++ b/docs/pitch/ChainSight_Round1_9slides.pptx
@@ -115,43 +115,43 @@
   <p:extLst>
     <p:ext uri="{521415D9-36F7-43E2-AB2F-B90AF26B5E84}">
       <p14:sectionLst xmlns:p14="http://schemas.microsoft.com/office/powerpoint/2010/main">
-        <p14:section name="Team Details" id="{6e4cd788-1c80-71c2-1c13-7e262ac037df}">
+        <p14:section name="Team Details" id="{455f73c0-a68d-0d5e-983b-b805d4efc2d3}">
           <p14:sldIdLst>
             <p14:sldId id="256"/>
           </p14:sldIdLst>
         </p14:section>
-        <p14:section name="Problem" id="{9996a751-3f9d-9e7b-ce78-890478f3ebc9}">
+        <p14:section name="Problem" id="{7b6ec578-3b7e-0c3f-1593-f9915ccf63df}">
           <p14:sldIdLst>
             <p14:sldId id="257"/>
           </p14:sldIdLst>
         </p14:section>
-        <p14:section name="Solution" id="{319ba565-1335-3e64-188d-a25f0200a6fe}">
+        <p14:section name="Solution" id="{c54650f8-a67d-8ce5-1b0c-0859751311e5}">
           <p14:sldIdLst>
             <p14:sldId id="258"/>
           </p14:sldIdLst>
         </p14:section>
-        <p14:section name="Users" id="{45e605ed-5ee1-7b34-49d7-98b9cf29d33e}">
+        <p14:section name="Users" id="{25f23637-ea91-2591-87d2-9ee536bc8941}">
           <p14:sldIdLst>
             <p14:sldId id="259"/>
           </p14:sldIdLst>
         </p14:section>
-        <p14:section name="Architecture" id="{eeac9a9c-5bc7-c862-5650-7e6c33122dea}">
+        <p14:section name="Architecture" id="{165dc66f-9d2b-a85c-4b56-b4b5954079be}">
           <p14:sldIdLst>
             <p14:sldId id="260"/>
           </p14:sldIdLst>
         </p14:section>
-        <p14:section name="TinyFish" id="{52d7420b-3be8-c7b5-4f5d-4ef99fecb17e}">
+        <p14:section name="TinyFish" id="{fd0c91b5-2842-991d-9c34-8e60e86d56c1}">
           <p14:sldIdLst>
             <p14:sldId id="261"/>
           </p14:sldIdLst>
         </p14:section>
-        <p14:section name="Scale" id="{0b7506f0-c0a8-3758-e63c-f9891a141a39}">
+        <p14:section name="Scale" id="{904f9064-2c35-d53b-cf90-f651fe8bd853}">
           <p14:sldIdLst>
             <p14:sldId id="262"/>
             <p14:sldId id="263"/>
           </p14:sldIdLst>
         </p14:section>
-        <p14:section name="Prototype" id="{b1893a3f-9013-a539-d6c9-af75ba47696b}">
+        <p14:section name="Prototype" id="{17ad1eea-f221-7290-8b3f-81d676d9e01b}">
           <p14:sldIdLst>
             <p14:sldId id="264"/>
           </p14:sldIdLst>
@@ -2054,7 +2054,7 @@
                   <a:schemeClr val="bg2"/>
                 </a:solidFill>
               </a:rPr>
-              <a:t>Real-time crypto fraud attribution: wallet in, exchange, contact and evidence out</a:t>
+              <a:t>Confidence-rated fund-flow leads to likely exchange-associated addresses, for investigator verification</a:t>
             </a:r>
             <a:endParaRPr lang="en-US" sz="2200" dirty="0"/>
           </a:p>
@@ -2875,7 +2875,7 @@
                   <a:schemeClr val="accent1"/>
                 </a:solidFill>
               </a:rPr>
-              <a:t>Victims report the scammer's wallet. Investigators can't quickly tell which exchange (VASP) holds the money, so it moves on before it can be frozen.</a:t>
+              <a:t>Victims report the scammer's wallet. Investigators can't quickly see which exchange (VASP) the funds may have reached, so money moves on before a request goes out.</a:t>
             </a:r>
             <a:endParaRPr lang="en-US" sz="1800" dirty="0"/>
           </a:p>
@@ -4712,11 +4712,11 @@
         <p:spPr>
           <a:xfrm>
             <a:off x="548640" y="1097280"/>
-            <a:ext cx="11094415" cy="960120"/>
+            <a:ext cx="11094415" cy="777240"/>
           </a:xfrm>
           <a:prstGeom prst="roundRect">
             <a:avLst>
-              <a:gd name="adj" fmla="val 7619"/>
+              <a:gd name="adj" fmla="val 9412"/>
             </a:avLst>
           </a:prstGeom>
           <a:solidFill>
@@ -4739,7 +4739,7 @@
         <p:spPr>
           <a:xfrm>
             <a:off x="914400" y="1097280"/>
-            <a:ext cx="10362895" cy="960120"/>
+            <a:ext cx="10362895" cy="777240"/>
           </a:xfrm>
           <a:prstGeom prst="rect">
             <a:avLst/>
@@ -4755,7 +4755,7 @@
               <a:buNone/>
             </a:pPr>
             <a:r>
-              <a:rPr lang="en-US" sz="2600" b="1" dirty="0">
+              <a:rPr lang="en-US" sz="2400" b="1" dirty="0">
                 <a:solidFill>
                   <a:schemeClr val="bg1"/>
                 </a:solidFill>
@@ -4769,7 +4769,7 @@
               <a:buNone/>
             </a:pPr>
             <a:r>
-              <a:rPr lang="en-US" sz="2600" b="1" dirty="0">
+              <a:rPr lang="en-US" sz="2400" b="1" dirty="0">
                 <a:solidFill>
                   <a:schemeClr val="accent1"/>
                 </a:solidFill>
@@ -4783,7 +4783,7 @@
               <a:buNone/>
             </a:pPr>
             <a:r>
-              <a:rPr lang="en-US" sz="2600" b="1" dirty="0">
+              <a:rPr lang="en-US" sz="2400" b="1" dirty="0">
                 <a:solidFill>
                   <a:schemeClr val="bg1"/>
                 </a:solidFill>
@@ -4791,9 +4791,9 @@
                 <a:ea typeface="Arial" pitchFamily="34" charset="-122"/>
                 <a:cs typeface="Arial" pitchFamily="34" charset="-120"/>
               </a:rPr>
-              <a:t>nearest exchange, its contact and evidence out</a:t>
-            </a:r>
-            <a:endParaRPr lang="en-US" sz="2600" dirty="0"/>
+              <a:t>confidence-rated, source-linked leads out</a:t>
+            </a:r>
+            <a:endParaRPr lang="en-US" sz="2400" dirty="0"/>
           </a:p>
         </p:txBody>
       </p:sp>
@@ -4805,7 +4805,7 @@
         </p:nvSpPr>
         <p:spPr>
           <a:xfrm>
-            <a:off x="1548354" y="2697480"/>
+            <a:off x="1548354" y="2395728"/>
             <a:ext cx="9094988" cy="0"/>
           </a:xfrm>
           <a:prstGeom prst="line">
@@ -4828,8 +4828,8 @@
         </p:nvSpPr>
         <p:spPr>
           <a:xfrm>
-            <a:off x="1136874" y="2286000"/>
-            <a:ext cx="822960" cy="822960"/>
+            <a:off x="1182594" y="2029968"/>
+            <a:ext cx="731520" cy="731520"/>
           </a:xfrm>
           <a:prstGeom prst="ellipse">
             <a:avLst/>
@@ -4861,8 +4861,8 @@
         </p:blipFill>
         <p:spPr>
           <a:xfrm>
-            <a:off x="1350843" y="2499970"/>
-            <a:ext cx="395021" cy="395021"/>
+            <a:off x="1372789" y="2220163"/>
+            <a:ext cx="351130" cy="351130"/>
           </a:xfrm>
           <a:prstGeom prst="rect">
             <a:avLst/>
@@ -4877,12 +4877,12 @@
         </p:nvSpPr>
         <p:spPr>
           <a:xfrm>
-            <a:off x="548640" y="3291840"/>
-            <a:ext cx="1999427" cy="2103120"/>
+            <a:off x="548640" y="2926080"/>
+            <a:ext cx="1999427" cy="1783080"/>
           </a:xfrm>
           <a:prstGeom prst="roundRect">
             <a:avLst>
-              <a:gd name="adj" fmla="val 3659"/>
+              <a:gd name="adj" fmla="val 4103"/>
             </a:avLst>
           </a:prstGeom>
           <a:solidFill>
@@ -4904,8 +4904,8 @@
         </p:nvSpPr>
         <p:spPr>
           <a:xfrm>
-            <a:off x="731520" y="3429000"/>
-            <a:ext cx="1633667" cy="411480"/>
+            <a:off x="731520" y="3035808"/>
+            <a:ext cx="1633667" cy="384048"/>
           </a:xfrm>
           <a:prstGeom prst="rect">
             <a:avLst/>
@@ -4940,8 +4940,8 @@
         </p:nvSpPr>
         <p:spPr>
           <a:xfrm>
-            <a:off x="731520" y="3886200"/>
-            <a:ext cx="1633667" cy="1005840"/>
+            <a:off x="731520" y="3456432"/>
+            <a:ext cx="1633667" cy="822960"/>
           </a:xfrm>
           <a:prstGeom prst="rect">
             <a:avLst/>
@@ -4962,7 +4962,7 @@
                   <a:schemeClr val="tx2"/>
                 </a:solidFill>
               </a:rPr>
-              <a:t>Wallets from NCRP / SAHYOG complaints, dashboard or API</a:t>
+              <a:t>Reported wallet via dashboard or API</a:t>
             </a:r>
             <a:endParaRPr lang="en-US" sz="1400" dirty="0"/>
           </a:p>
@@ -4976,8 +4976,8 @@
         </p:nvSpPr>
         <p:spPr>
           <a:xfrm>
-            <a:off x="3410621" y="2286000"/>
-            <a:ext cx="822960" cy="822960"/>
+            <a:off x="3456341" y="2029968"/>
+            <a:ext cx="731520" cy="731520"/>
           </a:xfrm>
           <a:prstGeom prst="ellipse">
             <a:avLst/>
@@ -5009,8 +5009,8 @@
         </p:blipFill>
         <p:spPr>
           <a:xfrm>
-            <a:off x="3624590" y="2499970"/>
-            <a:ext cx="395021" cy="395021"/>
+            <a:off x="3646536" y="2220163"/>
+            <a:ext cx="351130" cy="351130"/>
           </a:xfrm>
           <a:prstGeom prst="rect">
             <a:avLst/>
@@ -5025,12 +5025,12 @@
         </p:nvSpPr>
         <p:spPr>
           <a:xfrm>
-            <a:off x="2822387" y="3291840"/>
-            <a:ext cx="1999427" cy="2103120"/>
+            <a:off x="2822387" y="2926080"/>
+            <a:ext cx="1999427" cy="1783080"/>
           </a:xfrm>
           <a:prstGeom prst="roundRect">
             <a:avLst>
-              <a:gd name="adj" fmla="val 3659"/>
+              <a:gd name="adj" fmla="val 4103"/>
             </a:avLst>
           </a:prstGeom>
           <a:solidFill>
@@ -5052,8 +5052,8 @@
         </p:nvSpPr>
         <p:spPr>
           <a:xfrm>
-            <a:off x="3005267" y="3429000"/>
-            <a:ext cx="1633667" cy="411480"/>
+            <a:off x="3005267" y="3035808"/>
+            <a:ext cx="1633667" cy="384048"/>
           </a:xfrm>
           <a:prstGeom prst="rect">
             <a:avLst/>
@@ -5088,8 +5088,8 @@
         </p:nvSpPr>
         <p:spPr>
           <a:xfrm>
-            <a:off x="3005267" y="3886200"/>
-            <a:ext cx="1633667" cy="1005840"/>
+            <a:off x="3005267" y="3456432"/>
+            <a:ext cx="1633667" cy="822960"/>
           </a:xfrm>
           <a:prstGeom prst="rect">
             <a:avLst/>
@@ -5110,7 +5110,7 @@
                   <a:schemeClr val="tx2"/>
                 </a:solidFill>
               </a:rPr>
-              <a:t>Hop-by-hop transaction graph; layering patterns; cross-chain hops flagged</a:t>
+              <a:t>Hop-by-hop transaction graph; layering patterns</a:t>
             </a:r>
             <a:endParaRPr lang="en-US" sz="1400" dirty="0"/>
           </a:p>
@@ -5124,8 +5124,8 @@
         </p:nvSpPr>
         <p:spPr>
           <a:xfrm>
-            <a:off x="5684368" y="2286000"/>
-            <a:ext cx="822960" cy="822960"/>
+            <a:off x="5730088" y="2029968"/>
+            <a:ext cx="731520" cy="731520"/>
           </a:xfrm>
           <a:prstGeom prst="ellipse">
             <a:avLst/>
@@ -5157,8 +5157,8 @@
         </p:blipFill>
         <p:spPr>
           <a:xfrm>
-            <a:off x="5898337" y="2499970"/>
-            <a:ext cx="395021" cy="395021"/>
+            <a:off x="5920283" y="2220163"/>
+            <a:ext cx="351130" cy="351130"/>
           </a:xfrm>
           <a:prstGeom prst="rect">
             <a:avLst/>
@@ -5173,12 +5173,12 @@
         </p:nvSpPr>
         <p:spPr>
           <a:xfrm>
-            <a:off x="5096134" y="3291840"/>
-            <a:ext cx="1999427" cy="2103120"/>
+            <a:off x="5096134" y="2926080"/>
+            <a:ext cx="1999427" cy="1783080"/>
           </a:xfrm>
           <a:prstGeom prst="roundRect">
             <a:avLst>
-              <a:gd name="adj" fmla="val 3659"/>
+              <a:gd name="adj" fmla="val 4103"/>
             </a:avLst>
           </a:prstGeom>
           <a:solidFill>
@@ -5200,8 +5200,8 @@
         </p:nvSpPr>
         <p:spPr>
           <a:xfrm>
-            <a:off x="5279014" y="3429000"/>
-            <a:ext cx="1633667" cy="411480"/>
+            <a:off x="5279014" y="3035808"/>
+            <a:ext cx="1633667" cy="384048"/>
           </a:xfrm>
           <a:prstGeom prst="rect">
             <a:avLst/>
@@ -5222,7 +5222,7 @@
                   <a:schemeClr val="tx1"/>
                 </a:solidFill>
               </a:rPr>
-              <a:t>3. Attribute</a:t>
+              <a:t>3. Flag</a:t>
             </a:r>
             <a:endParaRPr lang="en-US" sz="1800" dirty="0"/>
           </a:p>
@@ -5236,8 +5236,8 @@
         </p:nvSpPr>
         <p:spPr>
           <a:xfrm>
-            <a:off x="5279014" y="3886200"/>
-            <a:ext cx="1633667" cy="1005840"/>
+            <a:off x="5279014" y="3456432"/>
+            <a:ext cx="1633667" cy="822960"/>
           </a:xfrm>
           <a:prstGeom prst="rect">
             <a:avLst/>
@@ -5258,7 +5258,7 @@
                   <a:schemeClr val="tx2"/>
                 </a:solidFill>
               </a:rPr>
-              <a:t>Exchange-wallet clustering finds the nearest VASP deposit address</a:t>
+              <a:t>Likely exchange-associated addresses, each confidence-rated</a:t>
             </a:r>
             <a:endParaRPr lang="en-US" sz="1400" dirty="0"/>
           </a:p>
@@ -5272,8 +5272,8 @@
         </p:nvSpPr>
         <p:spPr>
           <a:xfrm>
-            <a:off x="7958115" y="2286000"/>
-            <a:ext cx="822960" cy="822960"/>
+            <a:off x="8003835" y="2029968"/>
+            <a:ext cx="731520" cy="731520"/>
           </a:xfrm>
           <a:prstGeom prst="ellipse">
             <a:avLst/>
@@ -5305,8 +5305,8 @@
         </p:blipFill>
         <p:spPr>
           <a:xfrm>
-            <a:off x="8172084" y="2499970"/>
-            <a:ext cx="395021" cy="395021"/>
+            <a:off x="8194030" y="2220163"/>
+            <a:ext cx="351130" cy="351130"/>
           </a:xfrm>
           <a:prstGeom prst="rect">
             <a:avLst/>
@@ -5321,12 +5321,12 @@
         </p:nvSpPr>
         <p:spPr>
           <a:xfrm>
-            <a:off x="7369881" y="3291840"/>
-            <a:ext cx="1999427" cy="2103120"/>
+            <a:off x="7369881" y="2926080"/>
+            <a:ext cx="1999427" cy="1783080"/>
           </a:xfrm>
           <a:prstGeom prst="roundRect">
             <a:avLst>
-              <a:gd name="adj" fmla="val 3659"/>
+              <a:gd name="adj" fmla="val 4103"/>
             </a:avLst>
           </a:prstGeom>
           <a:solidFill>
@@ -5348,8 +5348,8 @@
         </p:nvSpPr>
         <p:spPr>
           <a:xfrm>
-            <a:off x="7552761" y="3429000"/>
-            <a:ext cx="1633667" cy="411480"/>
+            <a:off x="7552761" y="3035808"/>
+            <a:ext cx="1633667" cy="384048"/>
           </a:xfrm>
           <a:prstGeom prst="rect">
             <a:avLst/>
@@ -5370,7 +5370,7 @@
                   <a:schemeClr val="tx1"/>
                 </a:solidFill>
               </a:rPr>
-              <a:t>4. Enrich</a:t>
+              <a:t>4. Research</a:t>
             </a:r>
             <a:endParaRPr lang="en-US" sz="1800" dirty="0"/>
           </a:p>
@@ -5384,8 +5384,8 @@
         </p:nvSpPr>
         <p:spPr>
           <a:xfrm>
-            <a:off x="7552761" y="3886200"/>
-            <a:ext cx="1633667" cy="1005840"/>
+            <a:off x="7552761" y="3456432"/>
+            <a:ext cx="1633667" cy="822960"/>
           </a:xfrm>
           <a:prstGeom prst="rect">
             <a:avLst/>
@@ -5406,7 +5406,7 @@
                   <a:schemeClr val="tx2"/>
                 </a:solidFill>
               </a:rPr>
-              <a:t>Public scam reports + the VASP's law-enforcement contact</a:t>
+              <a:t>Public scam reports + the exchange's official process</a:t>
             </a:r>
             <a:endParaRPr lang="en-US" sz="1400" dirty="0"/>
           </a:p>
@@ -5420,7 +5420,7 @@
         </p:nvSpPr>
         <p:spPr>
           <a:xfrm>
-            <a:off x="7552761" y="4983480"/>
+            <a:off x="7552761" y="4315968"/>
             <a:ext cx="1005840" cy="274320"/>
           </a:xfrm>
           <a:prstGeom prst="roundRect">
@@ -5447,7 +5447,7 @@
         </p:nvSpPr>
         <p:spPr>
           <a:xfrm>
-            <a:off x="7552761" y="4983480"/>
+            <a:off x="7552761" y="4315968"/>
             <a:ext cx="1005840" cy="274320"/>
           </a:xfrm>
           <a:prstGeom prst="rect">
@@ -5483,8 +5483,8 @@
         </p:nvSpPr>
         <p:spPr>
           <a:xfrm>
-            <a:off x="10231862" y="2286000"/>
-            <a:ext cx="822960" cy="822960"/>
+            <a:off x="10277582" y="2029968"/>
+            <a:ext cx="731520" cy="731520"/>
           </a:xfrm>
           <a:prstGeom prst="ellipse">
             <a:avLst/>
@@ -5516,8 +5516,8 @@
         </p:blipFill>
         <p:spPr>
           <a:xfrm>
-            <a:off x="10445831" y="2499970"/>
-            <a:ext cx="395021" cy="395021"/>
+            <a:off x="10467777" y="2220163"/>
+            <a:ext cx="351130" cy="351130"/>
           </a:xfrm>
           <a:prstGeom prst="rect">
             <a:avLst/>
@@ -5532,12 +5532,12 @@
         </p:nvSpPr>
         <p:spPr>
           <a:xfrm>
-            <a:off x="9643628" y="3291840"/>
-            <a:ext cx="1999427" cy="2103120"/>
+            <a:off x="9643628" y="2926080"/>
+            <a:ext cx="1999427" cy="1783080"/>
           </a:xfrm>
           <a:prstGeom prst="roundRect">
             <a:avLst>
-              <a:gd name="adj" fmla="val 3659"/>
+              <a:gd name="adj" fmla="val 4103"/>
             </a:avLst>
           </a:prstGeom>
           <a:solidFill>
@@ -5559,8 +5559,8 @@
         </p:nvSpPr>
         <p:spPr>
           <a:xfrm>
-            <a:off x="9826508" y="3429000"/>
-            <a:ext cx="1633667" cy="411480"/>
+            <a:off x="9826508" y="3035808"/>
+            <a:ext cx="1633667" cy="384048"/>
           </a:xfrm>
           <a:prstGeom prst="rect">
             <a:avLst/>
@@ -5581,7 +5581,7 @@
                   <a:schemeClr val="tx1"/>
                 </a:solidFill>
               </a:rPr>
-              <a:t>5. Act</a:t>
+              <a:t>5. Report</a:t>
             </a:r>
             <a:endParaRPr lang="en-US" sz="1800" dirty="0"/>
           </a:p>
@@ -5595,8 +5595,8 @@
         </p:nvSpPr>
         <p:spPr>
           <a:xfrm>
-            <a:off x="9826508" y="3886200"/>
-            <a:ext cx="1633667" cy="1005840"/>
+            <a:off x="9826508" y="3456432"/>
+            <a:ext cx="1633667" cy="822960"/>
           </a:xfrm>
           <a:prstGeom prst="rect">
             <a:avLst/>
@@ -5617,7 +5617,7 @@
                   <a:schemeClr val="tx2"/>
                 </a:solidFill>
               </a:rPr>
-              <a:t>Risk category, alert, next steps, standard report, draft freeze request</a:t>
+              <a:t>Leads, sources and evidence for the officer to verify</a:t>
             </a:r>
             <a:endParaRPr lang="en-US" sz="1400" dirty="0"/>
           </a:p>
@@ -5631,7 +5631,7 @@
         </p:nvSpPr>
         <p:spPr>
           <a:xfrm>
-            <a:off x="9826508" y="4983480"/>
+            <a:off x="9826508" y="4315968"/>
             <a:ext cx="1005840" cy="274320"/>
           </a:xfrm>
           <a:prstGeom prst="roundRect">
@@ -5658,7 +5658,7 @@
         </p:nvSpPr>
         <p:spPr>
           <a:xfrm>
-            <a:off x="9826508" y="4983480"/>
+            <a:off x="9826508" y="4315968"/>
             <a:ext cx="1005840" cy="274320"/>
           </a:xfrm>
           <a:prstGeom prst="rect">
@@ -5688,97 +5688,100 @@
       </p:sp>
       <p:sp>
         <p:nvSpPr>
-          <p:cNvPr id="35" name="review-circle"/>
-          <p:cNvSpPr/>
-          <p:nvPr/>
-        </p:nvSpPr>
-        <p:spPr>
-          <a:xfrm>
-            <a:off x="548640" y="5605272"/>
-            <a:ext cx="502920" cy="502920"/>
-          </a:xfrm>
-          <a:prstGeom prst="ellipse">
-            <a:avLst/>
-          </a:prstGeom>
-          <a:solidFill>
-            <a:schemeClr val="accent5"/>
+          <p:cNvPr id="35" name="novelty"/>
+          <p:cNvSpPr/>
+          <p:nvPr/>
+        </p:nvSpPr>
+        <p:spPr>
+          <a:xfrm>
+            <a:off x="548640" y="4892040"/>
+            <a:ext cx="11094415" cy="1325880"/>
+          </a:xfrm>
+          <a:prstGeom prst="roundRect">
+            <a:avLst>
+              <a:gd name="adj" fmla="val 5517"/>
+            </a:avLst>
+          </a:prstGeom>
+          <a:solidFill>
+            <a:schemeClr val="tx1"/>
           </a:solidFill>
           <a:ln w="12700">
             <a:solidFill>
-              <a:schemeClr val="accent5"/>
+              <a:schemeClr val="tx1"/>
             </a:solidFill>
             <a:prstDash val="solid"/>
           </a:ln>
         </p:spPr>
       </p:sp>
-      <p:pic>
-        <p:nvPicPr>
-          <p:cNvPr id="36" name="review-icon" descr="preencoded.png">    </p:cNvPr>
-          <p:cNvPicPr>
-            <a:picLocks noChangeAspect="1"/>
-          </p:cNvPicPr>
-          <p:nvPr/>
-        </p:nvPicPr>
-        <p:blipFill>
-          <a:blip r:embed="rId6"/>
-          <a:stretch>
-            <a:fillRect/>
-          </a:stretch>
-        </p:blipFill>
-        <p:spPr>
-          <a:xfrm>
-            <a:off x="679399" y="5736031"/>
-            <a:ext cx="241402" cy="241402"/>
-          </a:xfrm>
-          <a:prstGeom prst="rect">
-            <a:avLst/>
-          </a:prstGeom>
-        </p:spPr>
-      </p:pic>
-      <p:sp>
-        <p:nvSpPr>
-          <p:cNvPr id="37" name="Text 29"/>
-          <p:cNvSpPr txBox="1"/>
-          <p:nvPr/>
-        </p:nvSpPr>
-        <p:spPr>
-          <a:xfrm>
-            <a:off x="1234440" y="5605272"/>
-            <a:ext cx="10058400" cy="502920"/>
-          </a:xfrm>
-          <a:prstGeom prst="rect">
-            <a:avLst/>
-          </a:prstGeom>
-          <a:noFill/>
-          <a:ln/>
-        </p:spPr>
-        <p:txBody>
-          <a:bodyPr wrap="square" lIns="0" tIns="0" rIns="0" bIns="0" rtlCol="0" anchor="ctr"/>
+      <p:sp>
+        <p:nvSpPr>
+          <p:cNvPr id="36" name="Text 29"/>
+          <p:cNvSpPr txBox="1"/>
+          <p:nvPr/>
+        </p:nvSpPr>
+        <p:spPr>
+          <a:xfrm>
+            <a:off x="868680" y="5001768"/>
+            <a:ext cx="5486400" cy="274320"/>
+          </a:xfrm>
+          <a:prstGeom prst="rect">
+            <a:avLst/>
+          </a:prstGeom>
+          <a:noFill/>
+          <a:ln/>
+        </p:spPr>
+        <p:txBody>
+          <a:bodyPr wrap="square" lIns="0" tIns="0" rIns="0" bIns="0" rtlCol="0" anchor="t"/>
           <a:lstStyle/>
           <a:p>
             <a:pPr indent="0" marL="0">
               <a:buNone/>
             </a:pPr>
             <a:r>
-              <a:rPr lang="en-US" sz="1500" b="1" dirty="0">
-                <a:solidFill>
-                  <a:schemeClr val="tx1"/>
-                </a:solidFill>
-              </a:rPr>
-              <a:t>A human investigator always decides. </a:t>
-            </a:r>
+              <a:rPr lang="en-US" sz="1200" b="1" spc="200" kern="0" dirty="0">
+                <a:solidFill>
+                  <a:schemeClr val="accent1"/>
+                </a:solidFill>
+              </a:rPr>
+              <a:t>WHAT MAKES CHAINSIGHT DIFFERENT</a:t>
+            </a:r>
+            <a:endParaRPr lang="en-US" sz="1200" dirty="0"/>
+          </a:p>
+        </p:txBody>
+      </p:sp>
+      <p:sp>
+        <p:nvSpPr>
+          <p:cNvPr id="37" name="Text 30"/>
+          <p:cNvSpPr txBox="1"/>
+          <p:nvPr/>
+        </p:nvSpPr>
+        <p:spPr>
+          <a:xfrm>
+            <a:off x="868680" y="5303520"/>
+            <a:ext cx="10454335" cy="868680"/>
+          </a:xfrm>
+          <a:prstGeom prst="rect">
+            <a:avLst/>
+          </a:prstGeom>
+          <a:noFill/>
+          <a:ln/>
+        </p:spPr>
+        <p:txBody>
+          <a:bodyPr wrap="square" lIns="0" tIns="0" rIns="0" bIns="0" rtlCol="0" anchor="t"/>
+          <a:lstStyle/>
+          <a:p>
             <a:pPr indent="0" marL="0">
               <a:buNone/>
             </a:pPr>
             <a:r>
-              <a:rPr lang="en-US" sz="1500" dirty="0">
-                <a:solidFill>
-                  <a:schemeClr val="tx2"/>
-                </a:solidFill>
-              </a:rPr>
-              <a:t>The risk category is a lead, not proof of guilt.</a:t>
-            </a:r>
-            <a:endParaRPr lang="en-US" sz="1500" dirty="0"/>
+              <a:rPr lang="en-US" sz="1400" dirty="0">
+                <a:solidFill>
+                  <a:schemeClr val="bg1"/>
+                </a:solidFill>
+              </a:rPr>
+              <a:t>On-chain fund-flow analysis + TinyFish-powered discovery of public scam intelligence and official exchange law-enforcement procedures, in one source-linked investigation report. Built for investigator verification and evidence traceability: risk scores are leads, never proof.</a:t>
+            </a:r>
+            <a:endParaRPr lang="en-US" sz="1400" dirty="0"/>
           </a:p>
         </p:txBody>
       </p:sp>
@@ -7255,7 +7258,7 @@
                   <a:schemeClr val="bg1"/>
                 </a:solidFill>
               </a:rPr>
-              <a:t>NCRP / SAHYOG feed</a:t>
+              <a:t>Dashboard  |  API</a:t>
             </a:r>
             <a:endParaRPr lang="en-US" sz="1400" dirty="0"/>
           </a:p>
@@ -7269,7 +7272,7 @@
                   <a:schemeClr val="bg1"/>
                 </a:solidFill>
               </a:rPr>
-              <a:t>Dashboard  |  API</a:t>
+              <a:t>NCRP / SAHYOG (future)</a:t>
             </a:r>
             <a:endParaRPr lang="en-US" sz="1400" dirty="0"/>
           </a:p>
@@ -7481,7 +7484,7 @@
                   <a:schemeClr val="bg1"/>
                 </a:solidFill>
               </a:rPr>
-              <a:t>On-chain engine</a:t>
+              <a:t>Blockchain engine: tracing</a:t>
             </a:r>
             <a:endParaRPr lang="en-US" sz="1400" dirty="0"/>
           </a:p>
@@ -7495,7 +7498,7 @@
                   <a:schemeClr val="bg1"/>
                 </a:solidFill>
               </a:rPr>
-              <a:t>Multi-chain transaction graph, exchange-wallet clustering, laundering patterns</a:t>
+              <a:t>Transaction graph, laundering patterns, exchange-address matching with confidence</a:t>
             </a:r>
             <a:endParaRPr lang="en-US" sz="1400" dirty="0"/>
           </a:p>
@@ -7585,7 +7588,7 @@
                   <a:schemeClr val="bg1"/>
                 </a:solidFill>
               </a:rPr>
-              <a:t>Off-chain intelligence (TinyFish)</a:t>
+              <a:t>TinyFish: off-chain web research</a:t>
             </a:r>
             <a:endParaRPr lang="en-US" sz="1500" dirty="0"/>
           </a:p>
@@ -8063,7 +8066,7 @@
                   <a:schemeClr val="bg1"/>
                 </a:solidFill>
               </a:rPr>
-              <a:t>Dashboard, alerts, standard report, LEA APIs</a:t>
+              <a:t>Dashboard, alerts, source-linked report</a:t>
             </a:r>
             <a:endParaRPr lang="en-US" sz="1400" dirty="0"/>
           </a:p>
@@ -8759,7 +8762,7 @@
                   <a:schemeClr val="accent2"/>
                 </a:solidFill>
               </a:rPr>
-              <a:t>TinyFish does every step that needs the open web, where no API exists</a:t>
+              <a:t>The blockchain engine traces transactions. TinyFish does the off-chain web research.</a:t>
             </a:r>
             <a:endParaRPr lang="en-US" sz="1800" dirty="0"/>
           </a:p>
@@ -8979,7 +8982,7 @@
                   <a:schemeClr val="tx1"/>
                 </a:solidFill>
               </a:rPr>
-              <a:t>Finds the wallet on scam-report sites, forums and social pages</a:t>
+              <a:t>Discover public scam reports about the wallet and the exchange's official pages</a:t>
             </a:r>
             <a:endParaRPr lang="en-US" sz="1400" dirty="0"/>
           </a:p>
@@ -9015,7 +9018,7 @@
                   <a:schemeClr val="tx2"/>
                 </a:solidFill>
               </a:rPr>
-              <a:t>Structured live results, not a list of links to scrape</a:t>
+              <a:t>Structured live results with URLs</a:t>
             </a:r>
             <a:endParaRPr lang="en-US" sz="1400" dirty="0"/>
           </a:p>
@@ -9163,7 +9166,7 @@
                   <a:schemeClr val="tx1"/>
                 </a:solidFill>
               </a:rPr>
-              <a:t>Reads each page; confirms the address is really there; reads exchange policy pages</a:t>
+              <a:t>Retrieve and extract the content of those URLs; confirm the wallet appears; log URL + time</a:t>
             </a:r>
             <a:endParaRPr lang="en-US" sz="1400" dirty="0"/>
           </a:p>
@@ -9199,7 +9202,7 @@
                   <a:schemeClr val="tx2"/>
                 </a:solidFill>
               </a:rPr>
-              <a:t>Clean text from any page, JS-rendered or not</a:t>
+              <a:t>Clean text or JSON from any page</a:t>
             </a:r>
             <a:endParaRPr lang="en-US" sz="1400" dirty="0"/>
           </a:p>
@@ -9347,7 +9350,7 @@
                   <a:schemeClr val="tx1"/>
                 </a:solidFill>
               </a:rPr>
-              <a:t>Navigates the exchange's site to its law-enforcement request process and contact</a:t>
+              <a:t>Navigate the exchange's official site to its law-enforcement reporting process, where publicly accessible</a:t>
             </a:r>
             <a:endParaRPr lang="en-US" sz="1400" dirty="0"/>
           </a:p>
@@ -9383,7 +9386,7 @@
                   <a:schemeClr val="tx2"/>
                 </a:solidFill>
               </a:rPr>
-              <a:t>Multi-step, different on every site; returns structured JSON</a:t>
+              <a:t>Multi-step goal on any site; structured JSON; never logs in</a:t>
             </a:r>
             <a:endParaRPr lang="en-US" sz="1400" dirty="0"/>
           </a:p>
@@ -9755,7 +9758,7 @@
                   <a:schemeClr val="accent1"/>
                 </a:solidFill>
               </a:rPr>
-              <a:t>MVP: BUILDABLE IN 24 HOURS</a:t>
+              <a:t>24H MVP: ONE WORKING FLOW</a:t>
             </a:r>
             <a:endParaRPr lang="en-US" sz="1300" dirty="0"/>
           </a:p>
@@ -9840,7 +9843,7 @@
                   <a:schemeClr val="bg1"/>
                 </a:solidFill>
               </a:rPr>
-              <a:t>Two chains: Tron + Ethereum</a:t>
+              <a:t>One reported wallet → one report</a:t>
             </a:r>
             <a:endParaRPr lang="en-US" sz="1400" dirty="0"/>
           </a:p>
@@ -9925,7 +9928,7 @@
                   <a:schemeClr val="bg1"/>
                 </a:solidFill>
               </a:rPr>
-              <a:t>One flow: single reported wallet</a:t>
+              <a:t>Tron, with live APIs where feasible</a:t>
             </a:r>
             <a:endParaRPr lang="en-US" sz="1400" dirty="0"/>
           </a:p>
@@ -10010,7 +10013,7 @@
                   <a:schemeClr val="bg1"/>
                 </a:solidFill>
               </a:rPr>
-              <a:t>Trace to the nearest exchange</a:t>
+              <a:t>Tested on known public wallets</a:t>
             </a:r>
             <a:endParaRPr lang="en-US" sz="1400" dirty="0"/>
           </a:p>
@@ -10095,7 +10098,7 @@
                   <a:schemeClr val="bg1"/>
                 </a:solidFill>
               </a:rPr>
-              <a:t>TinyFish: wallet reports + VASP contact</a:t>
+              <a:t>TinyFish on 1–2 exchanges</a:t>
             </a:r>
             <a:endParaRPr lang="en-US" sz="1400" dirty="0"/>
           </a:p>
@@ -10180,7 +10183,7 @@
                   <a:schemeClr val="bg1"/>
                 </a:solidFill>
               </a:rPr>
-              <a:t>Risk category + standard report</a:t>
+              <a:t>Leads labelled with confidence</a:t>
             </a:r>
             <a:endParaRPr lang="en-US" sz="1400" dirty="0"/>
           </a:p>
@@ -10216,7 +10219,7 @@
                   <a:schemeClr val="bg2"/>
                 </a:solidFill>
               </a:rPr>
-              <a:t>Next: Bitcoin + BSC, bridge / cross-chain tracing, ML typologies, NCRP and SAHYOG integration, own indexer at scale</a:t>
+              <a:t>Stretch: Ethereum, deeper tracing. Later: more chains, cross-chain, ML, NCRP / SAHYOG integration (with authorised access)</a:t>
             </a:r>
             <a:endParaRPr lang="en-US" sz="1300" dirty="0"/>
           </a:p>
@@ -10592,7 +10595,7 @@
                   <a:schemeClr val="tx1"/>
                 </a:solidFill>
               </a:rPr>
-              <a:t>REST API for NCRP / SAHYOG and other LEA systems</a:t>
+              <a:t>REST API ready for future NCRP / SAHYOG integration, once authorised</a:t>
             </a:r>
             <a:endParaRPr lang="en-US" sz="1400" dirty="0"/>
           </a:p>
@@ -10727,7 +10730,7 @@
                   <a:schemeClr val="accent4"/>
                 </a:solidFill>
               </a:rPr>
-              <a:t>Agent fails on an odd site</a:t>
+              <a:t>Attribution is uncertain</a:t>
             </a:r>
             <a:endParaRPr lang="en-US" sz="1400" dirty="0"/>
           </a:p>
@@ -10763,7 +10766,7 @@
                   <a:schemeClr val="tx2"/>
                 </a:solidFill>
               </a:rPr>
-              <a:t>Retries, then manual-review flag</a:t>
+              <a:t>Confidence levels; not proof the exchange holds funds</a:t>
             </a:r>
             <a:endParaRPr lang="en-US" sz="1300" dirty="0"/>
           </a:p>
@@ -10826,7 +10829,7 @@
                   <a:schemeClr val="accent4"/>
                 </a:solidFill>
               </a:rPr>
-              <a:t>Exchange labels incomplete</a:t>
+              <a:t>Agent fails on an odd site</a:t>
             </a:r>
             <a:endParaRPr lang="en-US" sz="1400" dirty="0"/>
           </a:p>
@@ -10862,7 +10865,7 @@
                   <a:schemeClr val="tx2"/>
                 </a:solidFill>
               </a:rPr>
-              <a:t>Infer deposit addresses from sweep behaviour</a:t>
+              <a:t>Retries, then manual-review flag</a:t>
             </a:r>
             <a:endParaRPr lang="en-US" sz="1300" dirty="0"/>
           </a:p>
@@ -11207,7 +11210,7 @@
                   <a:schemeClr val="tx2"/>
                 </a:solidFill>
               </a:rPr>
-              <a:t>A real public case shows the payoff: once the right company is found and asked, scam funds get frozen</a:t>
+              <a:t>A real-world precedent for coordinated tracing and freezing (not a ChainSight result)</a:t>
             </a:r>
             <a:endParaRPr lang="en-US" sz="1700" dirty="0"/>
           </a:p>
@@ -11852,7 +11855,7 @@
                   <a:schemeClr val="tx1"/>
                 </a:solidFill>
               </a:rPr>
-              <a:t>What ChainSight automates for an Indian cyber cell, in the same flow</a:t>
+              <a:t>Where ChainSight could help an Indian cyber cell in a similar case</a:t>
             </a:r>
             <a:endParaRPr lang="en-US" sz="1700" dirty="0"/>
           </a:p>
@@ -11937,7 +11940,7 @@
                   <a:schemeClr val="tx1"/>
                 </a:solidFill>
               </a:rPr>
-              <a:t>Officer enters the reported wallet from the NCRP complaint</a:t>
+              <a:t>Officer enters the reported wallet from the complaint</a:t>
             </a:r>
             <a:endParaRPr lang="en-US" sz="1400" dirty="0"/>
           </a:p>
@@ -12022,7 +12025,7 @@
                   <a:schemeClr val="tx1"/>
                 </a:solidFill>
               </a:rPr>
-              <a:t>Funds traced to an exchange deposit address</a:t>
+              <a:t>Leads to likely exchange-linked addresses, confidence-rated</a:t>
             </a:r>
             <a:endParaRPr lang="en-US" sz="1400" dirty="0"/>
           </a:p>
@@ -12107,7 +12110,7 @@
                   <a:schemeClr val="tx1"/>
                 </a:solidFill>
               </a:rPr>
-              <a:t>TinyFish finds public reports and the exchange's request process</a:t>
+              <a:t>TinyFish finds public reports and the official request process</a:t>
             </a:r>
             <a:endParaRPr lang="en-US" sz="1400" dirty="0"/>
           </a:p>
@@ -12192,7 +12195,7 @@
                   <a:schemeClr val="tx1"/>
                 </a:solidFill>
               </a:rPr>
-              <a:t>Officer reviews and sends the pre-filled freeze request</a:t>
+              <a:t>Officer verifies, then requests via the exchange's process</a:t>
             </a:r>
             <a:endParaRPr lang="en-US" sz="1400" dirty="0"/>
           </a:p>
@@ -12228,7 +12231,7 @@
                   <a:schemeClr val="tx2"/>
                 </a:solidFill>
               </a:rPr>
-              <a:t>Goal: an investigator-ready request in minutes instead of days of manual tracing and research (to be measured in the build).</a:t>
+              <a:t>Aim: cut manual research time. We will measure it in the build, not assume it.</a:t>
             </a:r>
             <a:endParaRPr lang="en-US" sz="1300" dirty="0"/>
           </a:p>
@@ -12347,138 +12350,14 @@
       </p:sp>
       <p:sp>
         <p:nvSpPr>
-          <p:cNvPr id="3" name="Text 1"/>
-          <p:cNvSpPr txBox="1"/>
-          <p:nvPr/>
-        </p:nvSpPr>
-        <p:spPr>
-          <a:xfrm>
-            <a:off x="548640" y="1005840"/>
-            <a:ext cx="8229600" cy="320040"/>
-          </a:xfrm>
-          <a:prstGeom prst="rect">
-            <a:avLst/>
-          </a:prstGeom>
-          <a:noFill/>
-          <a:ln/>
-        </p:spPr>
-        <p:txBody>
-          <a:bodyPr wrap="square" lIns="0" tIns="0" rIns="0" bIns="0" rtlCol="0" anchor="t"/>
-          <a:lstStyle/>
-          <a:p>
-            <a:pPr indent="0" marL="0">
-              <a:buNone/>
-            </a:pPr>
-            <a:r>
-              <a:rPr lang="en-US" sz="1300" i="1" dirty="0">
-                <a:solidFill>
-                  <a:schemeClr val="accent5"/>
-                </a:solidFill>
-              </a:rPr>
-              <a:t>Figma-style mockup of the investigator report (illustrative data)</a:t>
-            </a:r>
-            <a:endParaRPr lang="en-US" sz="1300" dirty="0"/>
-          </a:p>
-        </p:txBody>
-      </p:sp>
-      <p:sp>
-        <p:nvSpPr>
-          <p:cNvPr id="4" name="mk-frame"/>
-          <p:cNvSpPr/>
-          <p:nvPr/>
-        </p:nvSpPr>
-        <p:spPr>
-          <a:xfrm>
-            <a:off x="548640" y="1463040"/>
-            <a:ext cx="7863840" cy="4800600"/>
-          </a:xfrm>
-          <a:prstGeom prst="roundRect">
-            <a:avLst>
-              <a:gd name="adj" fmla="val 1524"/>
-            </a:avLst>
-          </a:prstGeom>
-          <a:solidFill>
-            <a:schemeClr val="bg1"/>
-          </a:solidFill>
-          <a:ln w="19050">
-            <a:solidFill>
-              <a:srgbClr val="EEF2F7"/>
-            </a:solidFill>
-            <a:prstDash val="solid"/>
-          </a:ln>
-        </p:spPr>
-      </p:sp>
-      <p:sp>
-        <p:nvSpPr>
-          <p:cNvPr id="5" name="mk-bar"/>
-          <p:cNvSpPr/>
-          <p:nvPr/>
-        </p:nvSpPr>
-        <p:spPr>
-          <a:xfrm>
-            <a:off x="548640" y="1463040"/>
-            <a:ext cx="7863840" cy="457200"/>
-          </a:xfrm>
-          <a:prstGeom prst="rect">
-            <a:avLst/>
-          </a:prstGeom>
-          <a:solidFill>
-            <a:schemeClr val="tx1"/>
-          </a:solidFill>
-          <a:ln w="12700">
-            <a:solidFill>
-              <a:schemeClr val="tx1"/>
-            </a:solidFill>
-            <a:prstDash val="solid"/>
-          </a:ln>
-        </p:spPr>
-      </p:sp>
-      <p:sp>
-        <p:nvSpPr>
-          <p:cNvPr id="6" name="Text 4"/>
-          <p:cNvSpPr txBox="1"/>
-          <p:nvPr/>
-        </p:nvSpPr>
-        <p:spPr>
-          <a:xfrm>
-            <a:off x="777240" y="1463040"/>
-            <a:ext cx="5029200" cy="457200"/>
-          </a:xfrm>
-          <a:prstGeom prst="rect">
-            <a:avLst/>
-          </a:prstGeom>
-          <a:noFill/>
-          <a:ln/>
-        </p:spPr>
-        <p:txBody>
-          <a:bodyPr wrap="square" lIns="0" tIns="0" rIns="0" bIns="0" rtlCol="0" anchor="ctr"/>
-          <a:lstStyle/>
-          <a:p>
-            <a:pPr indent="0" marL="0">
-              <a:buNone/>
-            </a:pPr>
-            <a:r>
-              <a:rPr lang="en-US" sz="1200" b="1" dirty="0">
-                <a:solidFill>
-                  <a:schemeClr val="bg1"/>
-                </a:solidFill>
-              </a:rPr>
-              <a:t>ChainSight   Case NCRP-2025-0412   |   Tron</a:t>
-            </a:r>
-            <a:endParaRPr lang="en-US" sz="1200" dirty="0"/>
-          </a:p>
-        </p:txBody>
-      </p:sp>
-      <p:sp>
-        <p:nvSpPr>
-          <p:cNvPr id="7" name="mk-dl"/>
-          <p:cNvSpPr/>
-          <p:nvPr/>
-        </p:nvSpPr>
-        <p:spPr>
-          <a:xfrm>
-            <a:off x="6720840" y="1554480"/>
-            <a:ext cx="1508760" cy="274320"/>
+          <p:cNvPr id="3" name="mk-label"/>
+          <p:cNvSpPr/>
+          <p:nvPr/>
+        </p:nvSpPr>
+        <p:spPr>
+          <a:xfrm>
+            <a:off x="548640" y="1024128"/>
+            <a:ext cx="6035040" cy="329184"/>
           </a:xfrm>
           <a:prstGeom prst="roundRect">
             <a:avLst>
@@ -12486,11 +12365,11 @@
             </a:avLst>
           </a:prstGeom>
           <a:solidFill>
-            <a:schemeClr val="accent1"/>
+            <a:schemeClr val="accent4"/>
           </a:solidFill>
           <a:ln w="12700">
             <a:solidFill>
-              <a:schemeClr val="accent1"/>
+              <a:schemeClr val="accent4"/>
             </a:solidFill>
             <a:prstDash val="solid"/>
           </a:ln>
@@ -12498,14 +12377,14 @@
       </p:sp>
       <p:sp>
         <p:nvSpPr>
-          <p:cNvPr id="8" name="Text 6"/>
-          <p:cNvSpPr txBox="1"/>
-          <p:nvPr/>
-        </p:nvSpPr>
-        <p:spPr>
-          <a:xfrm>
-            <a:off x="6720840" y="1554480"/>
-            <a:ext cx="1508760" cy="274320"/>
+          <p:cNvPr id="4" name="Text 2"/>
+          <p:cNvSpPr txBox="1"/>
+          <p:nvPr/>
+        </p:nvSpPr>
+        <p:spPr>
+          <a:xfrm>
+            <a:off x="548640" y="1024128"/>
+            <a:ext cx="6035040" cy="329184"/>
           </a:xfrm>
           <a:prstGeom prst="rect">
             <a:avLst/>
@@ -12521,39 +12400,64 @@
               <a:buNone/>
             </a:pPr>
             <a:r>
-              <a:rPr lang="en-US" sz="1100" b="1" dirty="0">
+              <a:rPr lang="en-US" sz="1200" b="1" dirty="0">
                 <a:solidFill>
                   <a:schemeClr val="bg1"/>
                 </a:solidFill>
               </a:rPr>
-              <a:t>Download report</a:t>
-            </a:r>
-            <a:endParaRPr lang="en-US" sz="1100" dirty="0"/>
-          </a:p>
-        </p:txBody>
-      </p:sp>
-      <p:sp>
-        <p:nvSpPr>
-          <p:cNvPr id="9" name="mk-k0"/>
-          <p:cNvSpPr/>
-          <p:nvPr/>
-        </p:nvSpPr>
-        <p:spPr>
-          <a:xfrm>
-            <a:off x="777240" y="2103120"/>
-            <a:ext cx="1748790" cy="777240"/>
+              <a:t>ILLUSTRATIVE MOCKUP: SAMPLE DATA, NOT A REAL INVESTIGATION RESULT</a:t>
+            </a:r>
+            <a:endParaRPr lang="en-US" sz="1200" dirty="0"/>
+          </a:p>
+        </p:txBody>
+      </p:sp>
+      <p:sp>
+        <p:nvSpPr>
+          <p:cNvPr id="5" name="mk-frame"/>
+          <p:cNvSpPr/>
+          <p:nvPr/>
+        </p:nvSpPr>
+        <p:spPr>
+          <a:xfrm>
+            <a:off x="548640" y="1508760"/>
+            <a:ext cx="7863840" cy="4754880"/>
           </a:xfrm>
           <a:prstGeom prst="roundRect">
             <a:avLst>
-              <a:gd name="adj" fmla="val 9412"/>
+              <a:gd name="adj" fmla="val 1538"/>
             </a:avLst>
           </a:prstGeom>
           <a:solidFill>
-            <a:schemeClr val="bg2"/>
+            <a:schemeClr val="bg1"/>
+          </a:solidFill>
+          <a:ln w="19050">
+            <a:solidFill>
+              <a:srgbClr val="EEF2F7"/>
+            </a:solidFill>
+            <a:prstDash val="solid"/>
+          </a:ln>
+        </p:spPr>
+      </p:sp>
+      <p:sp>
+        <p:nvSpPr>
+          <p:cNvPr id="6" name="mk-bar"/>
+          <p:cNvSpPr/>
+          <p:nvPr/>
+        </p:nvSpPr>
+        <p:spPr>
+          <a:xfrm>
+            <a:off x="548640" y="1508760"/>
+            <a:ext cx="7863840" cy="457200"/>
+          </a:xfrm>
+          <a:prstGeom prst="rect">
+            <a:avLst/>
+          </a:prstGeom>
+          <a:solidFill>
+            <a:schemeClr val="tx1"/>
           </a:solidFill>
           <a:ln w="12700">
             <a:solidFill>
-              <a:schemeClr val="bg2"/>
+              <a:schemeClr val="tx1"/>
             </a:solidFill>
             <a:prstDash val="solid"/>
           </a:ln>
@@ -12561,98 +12465,62 @@
       </p:sp>
       <p:sp>
         <p:nvSpPr>
-          <p:cNvPr id="10" name="Text 8"/>
-          <p:cNvSpPr txBox="1"/>
-          <p:nvPr/>
-        </p:nvSpPr>
-        <p:spPr>
-          <a:xfrm>
-            <a:off x="914400" y="2176272"/>
-            <a:ext cx="1474470" cy="228600"/>
-          </a:xfrm>
-          <a:prstGeom prst="rect">
-            <a:avLst/>
-          </a:prstGeom>
-          <a:noFill/>
-          <a:ln/>
-        </p:spPr>
-        <p:txBody>
-          <a:bodyPr wrap="square" lIns="0" tIns="0" rIns="0" bIns="0" rtlCol="0" anchor="t"/>
+          <p:cNvPr id="7" name="Text 5"/>
+          <p:cNvSpPr txBox="1"/>
+          <p:nvPr/>
+        </p:nvSpPr>
+        <p:spPr>
+          <a:xfrm>
+            <a:off x="777240" y="1508760"/>
+            <a:ext cx="5029200" cy="457200"/>
+          </a:xfrm>
+          <a:prstGeom prst="rect">
+            <a:avLst/>
+          </a:prstGeom>
+          <a:noFill/>
+          <a:ln/>
+        </p:spPr>
+        <p:txBody>
+          <a:bodyPr wrap="square" lIns="0" tIns="0" rIns="0" bIns="0" rtlCol="0" anchor="ctr"/>
           <a:lstStyle/>
           <a:p>
             <a:pPr indent="0" marL="0">
               <a:buNone/>
             </a:pPr>
             <a:r>
-              <a:rPr lang="en-US" sz="1000" b="1" dirty="0">
-                <a:solidFill>
-                  <a:schemeClr val="accent5"/>
-                </a:solidFill>
-              </a:rPr>
-              <a:t>RISK LEAD</a:t>
-            </a:r>
-            <a:endParaRPr lang="en-US" sz="1000" dirty="0"/>
-          </a:p>
-        </p:txBody>
-      </p:sp>
-      <p:sp>
-        <p:nvSpPr>
-          <p:cNvPr id="11" name="Text 9"/>
-          <p:cNvSpPr txBox="1"/>
-          <p:nvPr/>
-        </p:nvSpPr>
-        <p:spPr>
-          <a:xfrm>
-            <a:off x="914400" y="2423160"/>
-            <a:ext cx="1474470" cy="365760"/>
-          </a:xfrm>
-          <a:prstGeom prst="rect">
-            <a:avLst/>
-          </a:prstGeom>
-          <a:noFill/>
-          <a:ln/>
-        </p:spPr>
-        <p:txBody>
-          <a:bodyPr wrap="square" lIns="0" tIns="0" rIns="0" bIns="0" rtlCol="0" anchor="t"/>
-          <a:lstStyle/>
-          <a:p>
-            <a:pPr indent="0" marL="0">
-              <a:buNone/>
-            </a:pPr>
-            <a:r>
-              <a:rPr lang="en-US" sz="1400" b="1" dirty="0">
-                <a:solidFill>
-                  <a:schemeClr val="accent4"/>
-                </a:solidFill>
-              </a:rPr>
-              <a:t>High  82/100</a:t>
-            </a:r>
-            <a:endParaRPr lang="en-US" sz="1400" dirty="0"/>
-          </a:p>
-        </p:txBody>
-      </p:sp>
-      <p:sp>
-        <p:nvSpPr>
-          <p:cNvPr id="12" name="mk-k1"/>
-          <p:cNvSpPr/>
-          <p:nvPr/>
-        </p:nvSpPr>
-        <p:spPr>
-          <a:xfrm>
-            <a:off x="2663190" y="2103120"/>
-            <a:ext cx="1748790" cy="777240"/>
+              <a:rPr lang="en-US" sz="1200" b="1" dirty="0">
+                <a:solidFill>
+                  <a:schemeClr val="bg1"/>
+                </a:solidFill>
+              </a:rPr>
+              <a:t>ChainSight   Case DEMO-001   |   Tron</a:t>
+            </a:r>
+            <a:endParaRPr lang="en-US" sz="1200" dirty="0"/>
+          </a:p>
+        </p:txBody>
+      </p:sp>
+      <p:sp>
+        <p:nvSpPr>
+          <p:cNvPr id="8" name="mk-dl"/>
+          <p:cNvSpPr/>
+          <p:nvPr/>
+        </p:nvSpPr>
+        <p:spPr>
+          <a:xfrm>
+            <a:off x="6903720" y="1600200"/>
+            <a:ext cx="1325880" cy="274320"/>
           </a:xfrm>
           <a:prstGeom prst="roundRect">
             <a:avLst>
-              <a:gd name="adj" fmla="val 9412"/>
+              <a:gd name="adj" fmla="val 50000"/>
             </a:avLst>
           </a:prstGeom>
           <a:solidFill>
-            <a:schemeClr val="bg2"/>
+            <a:schemeClr val="accent1"/>
           </a:solidFill>
           <a:ln w="12700">
             <a:solidFill>
-              <a:schemeClr val="bg2"/>
+              <a:schemeClr val="accent1"/>
             </a:solidFill>
             <a:prstDash val="solid"/>
           </a:ln>
@@ -12660,90 +12528,54 @@
       </p:sp>
       <p:sp>
         <p:nvSpPr>
-          <p:cNvPr id="13" name="Text 11"/>
-          <p:cNvSpPr txBox="1"/>
-          <p:nvPr/>
-        </p:nvSpPr>
-        <p:spPr>
-          <a:xfrm>
-            <a:off x="2800350" y="2176272"/>
-            <a:ext cx="1474470" cy="228600"/>
-          </a:xfrm>
-          <a:prstGeom prst="rect">
-            <a:avLst/>
-          </a:prstGeom>
-          <a:noFill/>
-          <a:ln/>
-        </p:spPr>
-        <p:txBody>
-          <a:bodyPr wrap="square" lIns="0" tIns="0" rIns="0" bIns="0" rtlCol="0" anchor="t"/>
-          <a:lstStyle/>
-          <a:p>
-            <a:pPr indent="0" marL="0">
-              <a:buNone/>
-            </a:pPr>
-            <a:r>
-              <a:rPr lang="en-US" sz="1000" b="1" dirty="0">
-                <a:solidFill>
-                  <a:schemeClr val="accent5"/>
-                </a:solidFill>
-              </a:rPr>
-              <a:t>EXCHANGE, 3 HOPS</a:t>
-            </a:r>
-            <a:endParaRPr lang="en-US" sz="1000" dirty="0"/>
-          </a:p>
-        </p:txBody>
-      </p:sp>
-      <p:sp>
-        <p:nvSpPr>
-          <p:cNvPr id="14" name="Text 12"/>
-          <p:cNvSpPr txBox="1"/>
-          <p:nvPr/>
-        </p:nvSpPr>
-        <p:spPr>
-          <a:xfrm>
-            <a:off x="2800350" y="2423160"/>
-            <a:ext cx="1474470" cy="365760"/>
-          </a:xfrm>
-          <a:prstGeom prst="rect">
-            <a:avLst/>
-          </a:prstGeom>
-          <a:noFill/>
-          <a:ln/>
-        </p:spPr>
-        <p:txBody>
-          <a:bodyPr wrap="square" lIns="0" tIns="0" rIns="0" bIns="0" rtlCol="0" anchor="t"/>
-          <a:lstStyle/>
-          <a:p>
-            <a:pPr indent="0" marL="0">
-              <a:buNone/>
-            </a:pPr>
-            <a:r>
-              <a:rPr lang="en-US" sz="1400" b="1" dirty="0">
-                <a:solidFill>
-                  <a:schemeClr val="tx1"/>
-                </a:solidFill>
-              </a:rPr>
-              <a:t>Exchange X</a:t>
-            </a:r>
-            <a:endParaRPr lang="en-US" sz="1400" dirty="0"/>
-          </a:p>
-        </p:txBody>
-      </p:sp>
-      <p:sp>
-        <p:nvSpPr>
-          <p:cNvPr id="15" name="mk-k2"/>
-          <p:cNvSpPr/>
-          <p:nvPr/>
-        </p:nvSpPr>
-        <p:spPr>
-          <a:xfrm>
-            <a:off x="4549140" y="2103120"/>
-            <a:ext cx="1748790" cy="777240"/>
+          <p:cNvPr id="9" name="Text 7"/>
+          <p:cNvSpPr txBox="1"/>
+          <p:nvPr/>
+        </p:nvSpPr>
+        <p:spPr>
+          <a:xfrm>
+            <a:off x="6903720" y="1600200"/>
+            <a:ext cx="1325880" cy="274320"/>
+          </a:xfrm>
+          <a:prstGeom prst="rect">
+            <a:avLst/>
+          </a:prstGeom>
+          <a:noFill/>
+          <a:ln/>
+        </p:spPr>
+        <p:txBody>
+          <a:bodyPr wrap="square" lIns="0" tIns="0" rIns="0" bIns="0" rtlCol="0" anchor="ctr"/>
+          <a:lstStyle/>
+          <a:p>
+            <a:pPr algn="ctr" indent="0" marL="0">
+              <a:buNone/>
+            </a:pPr>
+            <a:r>
+              <a:rPr lang="en-US" sz="1100" b="1" dirty="0">
+                <a:solidFill>
+                  <a:schemeClr val="bg1"/>
+                </a:solidFill>
+              </a:rPr>
+              <a:t>Export report</a:t>
+            </a:r>
+            <a:endParaRPr lang="en-US" sz="1100" dirty="0"/>
+          </a:p>
+        </p:txBody>
+      </p:sp>
+      <p:sp>
+        <p:nvSpPr>
+          <p:cNvPr id="10" name="mk-k0"/>
+          <p:cNvSpPr/>
+          <p:nvPr/>
+        </p:nvSpPr>
+        <p:spPr>
+          <a:xfrm>
+            <a:off x="777240" y="2103120"/>
+            <a:ext cx="1748790" cy="731520"/>
           </a:xfrm>
           <a:prstGeom prst="roundRect">
             <a:avLst>
-              <a:gd name="adj" fmla="val 9412"/>
+              <a:gd name="adj" fmla="val 10000"/>
             </a:avLst>
           </a:prstGeom>
           <a:solidFill>
@@ -12759,14 +12591,14 @@
       </p:sp>
       <p:sp>
         <p:nvSpPr>
-          <p:cNvPr id="16" name="Text 14"/>
-          <p:cNvSpPr txBox="1"/>
-          <p:nvPr/>
-        </p:nvSpPr>
-        <p:spPr>
-          <a:xfrm>
-            <a:off x="4686300" y="2176272"/>
-            <a:ext cx="1474470" cy="228600"/>
+          <p:cNvPr id="11" name="Text 9"/>
+          <p:cNvSpPr txBox="1"/>
+          <p:nvPr/>
+        </p:nvSpPr>
+        <p:spPr>
+          <a:xfrm>
+            <a:off x="886968" y="2167128"/>
+            <a:ext cx="1529334" cy="228600"/>
           </a:xfrm>
           <a:prstGeom prst="rect">
             <a:avLst/>
@@ -12782,27 +12614,27 @@
               <a:buNone/>
             </a:pPr>
             <a:r>
-              <a:rPr lang="en-US" sz="1000" b="1" dirty="0">
+              <a:rPr lang="en-US" sz="900" b="1" dirty="0">
                 <a:solidFill>
                   <a:schemeClr val="accent5"/>
                 </a:solidFill>
               </a:rPr>
-              <a:t>FREEZE TARGET</a:t>
-            </a:r>
-            <a:endParaRPr lang="en-US" sz="1000" dirty="0"/>
-          </a:p>
-        </p:txBody>
-      </p:sp>
-      <p:sp>
-        <p:nvSpPr>
-          <p:cNvPr id="17" name="Text 15"/>
-          <p:cNvSpPr txBox="1"/>
-          <p:nvPr/>
-        </p:nvSpPr>
-        <p:spPr>
-          <a:xfrm>
-            <a:off x="4686300" y="2423160"/>
-            <a:ext cx="1474470" cy="365760"/>
+              <a:t>LEAD CONFIDENCE</a:t>
+            </a:r>
+            <a:endParaRPr lang="en-US" sz="900" dirty="0"/>
+          </a:p>
+        </p:txBody>
+      </p:sp>
+      <p:sp>
+        <p:nvSpPr>
+          <p:cNvPr id="12" name="Text 10"/>
+          <p:cNvSpPr txBox="1"/>
+          <p:nvPr/>
+        </p:nvSpPr>
+        <p:spPr>
+          <a:xfrm>
+            <a:off x="886968" y="2404872"/>
+            <a:ext cx="1529334" cy="347472"/>
           </a:xfrm>
           <a:prstGeom prst="rect">
             <a:avLst/>
@@ -12823,7 +12655,7 @@
                   <a:schemeClr val="accent1"/>
                 </a:solidFill>
               </a:rPr>
-              <a:t>Deposit TQ7…9F2</a:t>
+              <a:t>Medium</a:t>
             </a:r>
             <a:endParaRPr lang="en-US" sz="1400" dirty="0"/>
           </a:p>
@@ -12831,18 +12663,18 @@
       </p:sp>
       <p:sp>
         <p:nvSpPr>
-          <p:cNvPr id="18" name="mk-k3"/>
-          <p:cNvSpPr/>
-          <p:nvPr/>
-        </p:nvSpPr>
-        <p:spPr>
-          <a:xfrm>
-            <a:off x="6435090" y="2103120"/>
-            <a:ext cx="1748790" cy="777240"/>
+          <p:cNvPr id="13" name="mk-k1"/>
+          <p:cNvSpPr/>
+          <p:nvPr/>
+        </p:nvSpPr>
+        <p:spPr>
+          <a:xfrm>
+            <a:off x="2663190" y="2103120"/>
+            <a:ext cx="1748790" cy="731520"/>
           </a:xfrm>
           <a:prstGeom prst="roundRect">
             <a:avLst>
-              <a:gd name="adj" fmla="val 9412"/>
+              <a:gd name="adj" fmla="val 10000"/>
             </a:avLst>
           </a:prstGeom>
           <a:solidFill>
@@ -12858,14 +12690,14 @@
       </p:sp>
       <p:sp>
         <p:nvSpPr>
-          <p:cNvPr id="19" name="Text 17"/>
-          <p:cNvSpPr txBox="1"/>
-          <p:nvPr/>
-        </p:nvSpPr>
-        <p:spPr>
-          <a:xfrm>
-            <a:off x="6572250" y="2176272"/>
-            <a:ext cx="1474470" cy="228600"/>
+          <p:cNvPr id="14" name="Text 12"/>
+          <p:cNvSpPr txBox="1"/>
+          <p:nvPr/>
+        </p:nvSpPr>
+        <p:spPr>
+          <a:xfrm>
+            <a:off x="2772918" y="2167128"/>
+            <a:ext cx="1529334" cy="228600"/>
           </a:xfrm>
           <a:prstGeom prst="rect">
             <a:avLst/>
@@ -12881,27 +12713,27 @@
               <a:buNone/>
             </a:pPr>
             <a:r>
-              <a:rPr lang="en-US" sz="1000" b="1" dirty="0">
+              <a:rPr lang="en-US" sz="900" b="1" dirty="0">
                 <a:solidFill>
                   <a:schemeClr val="accent5"/>
                 </a:solidFill>
               </a:rPr>
-              <a:t>EVIDENCE</a:t>
-            </a:r>
-            <a:endParaRPr lang="en-US" sz="1000" dirty="0"/>
-          </a:p>
-        </p:txBody>
-      </p:sp>
-      <p:sp>
-        <p:nvSpPr>
-          <p:cNvPr id="20" name="Text 18"/>
-          <p:cNvSpPr txBox="1"/>
-          <p:nvPr/>
-        </p:nvSpPr>
-        <p:spPr>
-          <a:xfrm>
-            <a:off x="6572250" y="2423160"/>
-            <a:ext cx="1474470" cy="365760"/>
+              <a:t>LIKELY EXCHANGE-LINKED</a:t>
+            </a:r>
+            <a:endParaRPr lang="en-US" sz="900" dirty="0"/>
+          </a:p>
+        </p:txBody>
+      </p:sp>
+      <p:sp>
+        <p:nvSpPr>
+          <p:cNvPr id="15" name="Text 13"/>
+          <p:cNvSpPr txBox="1"/>
+          <p:nvPr/>
+        </p:nvSpPr>
+        <p:spPr>
+          <a:xfrm>
+            <a:off x="2772918" y="2404872"/>
+            <a:ext cx="1529334" cy="347472"/>
           </a:xfrm>
           <a:prstGeom prst="rect">
             <a:avLst/>
@@ -12919,10 +12751,10 @@
             <a:r>
               <a:rPr lang="en-US" sz="1400" b="1" dirty="0">
                 <a:solidFill>
-                  <a:schemeClr val="accent3"/>
-                </a:solidFill>
-              </a:rPr>
-              <a:t>6 pages hashed</a:t>
+                  <a:schemeClr val="tx1"/>
+                </a:solidFill>
+              </a:rPr>
+              <a:t>Exchange X</a:t>
             </a:r>
             <a:endParaRPr lang="en-US" sz="1400" dirty="0"/>
           </a:p>
@@ -12930,21 +12762,219 @@
       </p:sp>
       <p:sp>
         <p:nvSpPr>
-          <p:cNvPr id="21" name="mk-graph"/>
-          <p:cNvSpPr/>
-          <p:nvPr/>
-        </p:nvSpPr>
-        <p:spPr>
-          <a:xfrm>
-            <a:off x="777240" y="3063240"/>
-            <a:ext cx="4206240" cy="1828800"/>
+          <p:cNvPr id="16" name="mk-k2"/>
+          <p:cNvSpPr/>
+          <p:nvPr/>
+        </p:nvSpPr>
+        <p:spPr>
+          <a:xfrm>
+            <a:off x="4549140" y="2103120"/>
+            <a:ext cx="1748790" cy="731520"/>
           </a:xfrm>
           <a:prstGeom prst="roundRect">
             <a:avLst>
-              <a:gd name="adj" fmla="val 4000"/>
+              <a:gd name="adj" fmla="val 10000"/>
             </a:avLst>
           </a:prstGeom>
           <a:solidFill>
+            <a:schemeClr val="bg2"/>
+          </a:solidFill>
+          <a:ln w="12700">
+            <a:solidFill>
+              <a:schemeClr val="bg2"/>
+            </a:solidFill>
+            <a:prstDash val="solid"/>
+          </a:ln>
+        </p:spPr>
+      </p:sp>
+      <p:sp>
+        <p:nvSpPr>
+          <p:cNvPr id="17" name="Text 15"/>
+          <p:cNvSpPr txBox="1"/>
+          <p:nvPr/>
+        </p:nvSpPr>
+        <p:spPr>
+          <a:xfrm>
+            <a:off x="4658868" y="2167128"/>
+            <a:ext cx="1529334" cy="228600"/>
+          </a:xfrm>
+          <a:prstGeom prst="rect">
+            <a:avLst/>
+          </a:prstGeom>
+          <a:noFill/>
+          <a:ln/>
+        </p:spPr>
+        <p:txBody>
+          <a:bodyPr wrap="square" lIns="0" tIns="0" rIns="0" bIns="0" rtlCol="0" anchor="t"/>
+          <a:lstStyle/>
+          <a:p>
+            <a:pPr indent="0" marL="0">
+              <a:buNone/>
+            </a:pPr>
+            <a:r>
+              <a:rPr lang="en-US" sz="900" b="1" dirty="0">
+                <a:solidFill>
+                  <a:schemeClr val="accent5"/>
+                </a:solidFill>
+              </a:rPr>
+              <a:t>OBSERVED TXS</a:t>
+            </a:r>
+            <a:endParaRPr lang="en-US" sz="900" dirty="0"/>
+          </a:p>
+        </p:txBody>
+      </p:sp>
+      <p:sp>
+        <p:nvSpPr>
+          <p:cNvPr id="18" name="Text 16"/>
+          <p:cNvSpPr txBox="1"/>
+          <p:nvPr/>
+        </p:nvSpPr>
+        <p:spPr>
+          <a:xfrm>
+            <a:off x="4658868" y="2404872"/>
+            <a:ext cx="1529334" cy="347472"/>
+          </a:xfrm>
+          <a:prstGeom prst="rect">
+            <a:avLst/>
+          </a:prstGeom>
+          <a:noFill/>
+          <a:ln/>
+        </p:spPr>
+        <p:txBody>
+          <a:bodyPr wrap="square" lIns="0" tIns="0" rIns="0" bIns="0" rtlCol="0" anchor="t"/>
+          <a:lstStyle/>
+          <a:p>
+            <a:pPr indent="0" marL="0">
+              <a:buNone/>
+            </a:pPr>
+            <a:r>
+              <a:rPr lang="en-US" sz="1400" b="1" dirty="0">
+                <a:solidFill>
+                  <a:schemeClr val="tx1"/>
+                </a:solidFill>
+              </a:rPr>
+              <a:t>3 tx hashes</a:t>
+            </a:r>
+            <a:endParaRPr lang="en-US" sz="1400" dirty="0"/>
+          </a:p>
+        </p:txBody>
+      </p:sp>
+      <p:sp>
+        <p:nvSpPr>
+          <p:cNvPr id="19" name="mk-k3"/>
+          <p:cNvSpPr/>
+          <p:nvPr/>
+        </p:nvSpPr>
+        <p:spPr>
+          <a:xfrm>
+            <a:off x="6435090" y="2103120"/>
+            <a:ext cx="1748790" cy="731520"/>
+          </a:xfrm>
+          <a:prstGeom prst="roundRect">
+            <a:avLst>
+              <a:gd name="adj" fmla="val 10000"/>
+            </a:avLst>
+          </a:prstGeom>
+          <a:solidFill>
+            <a:schemeClr val="bg2"/>
+          </a:solidFill>
+          <a:ln w="12700">
+            <a:solidFill>
+              <a:schemeClr val="bg2"/>
+            </a:solidFill>
+            <a:prstDash val="solid"/>
+          </a:ln>
+        </p:spPr>
+      </p:sp>
+      <p:sp>
+        <p:nvSpPr>
+          <p:cNvPr id="20" name="Text 18"/>
+          <p:cNvSpPr txBox="1"/>
+          <p:nvPr/>
+        </p:nvSpPr>
+        <p:spPr>
+          <a:xfrm>
+            <a:off x="6544818" y="2167128"/>
+            <a:ext cx="1529334" cy="228600"/>
+          </a:xfrm>
+          <a:prstGeom prst="rect">
+            <a:avLst/>
+          </a:prstGeom>
+          <a:noFill/>
+          <a:ln/>
+        </p:spPr>
+        <p:txBody>
+          <a:bodyPr wrap="square" lIns="0" tIns="0" rIns="0" bIns="0" rtlCol="0" anchor="t"/>
+          <a:lstStyle/>
+          <a:p>
+            <a:pPr indent="0" marL="0">
+              <a:buNone/>
+            </a:pPr>
+            <a:r>
+              <a:rPr lang="en-US" sz="900" b="1" dirty="0">
+                <a:solidFill>
+                  <a:schemeClr val="accent5"/>
+                </a:solidFill>
+              </a:rPr>
+              <a:t>SOURCES</a:t>
+            </a:r>
+            <a:endParaRPr lang="en-US" sz="900" dirty="0"/>
+          </a:p>
+        </p:txBody>
+      </p:sp>
+      <p:sp>
+        <p:nvSpPr>
+          <p:cNvPr id="21" name="Text 19"/>
+          <p:cNvSpPr txBox="1"/>
+          <p:nvPr/>
+        </p:nvSpPr>
+        <p:spPr>
+          <a:xfrm>
+            <a:off x="6544818" y="2404872"/>
+            <a:ext cx="1529334" cy="347472"/>
+          </a:xfrm>
+          <a:prstGeom prst="rect">
+            <a:avLst/>
+          </a:prstGeom>
+          <a:noFill/>
+          <a:ln/>
+        </p:spPr>
+        <p:txBody>
+          <a:bodyPr wrap="square" lIns="0" tIns="0" rIns="0" bIns="0" rtlCol="0" anchor="t"/>
+          <a:lstStyle/>
+          <a:p>
+            <a:pPr indent="0" marL="0">
+              <a:buNone/>
+            </a:pPr>
+            <a:r>
+              <a:rPr lang="en-US" sz="1400" b="1" dirty="0">
+                <a:solidFill>
+                  <a:schemeClr val="accent3"/>
+                </a:solidFill>
+              </a:rPr>
+              <a:t>4 URLs, timed</a:t>
+            </a:r>
+            <a:endParaRPr lang="en-US" sz="1400" dirty="0"/>
+          </a:p>
+        </p:txBody>
+      </p:sp>
+      <p:sp>
+        <p:nvSpPr>
+          <p:cNvPr id="22" name="mk-graph"/>
+          <p:cNvSpPr/>
+          <p:nvPr/>
+        </p:nvSpPr>
+        <p:spPr>
+          <a:xfrm>
+            <a:off x="777240" y="2971800"/>
+            <a:ext cx="4206240" cy="1600200"/>
+          </a:xfrm>
+          <a:prstGeom prst="roundRect">
+            <a:avLst>
+              <a:gd name="adj" fmla="val 4571"/>
+            </a:avLst>
+          </a:prstGeom>
+          <a:solidFill>
             <a:schemeClr val="tx1"/>
           </a:solidFill>
           <a:ln w="12700">
@@ -12957,13 +12987,13 @@
       </p:sp>
       <p:sp>
         <p:nvSpPr>
-          <p:cNvPr id="22" name="Text 20"/>
-          <p:cNvSpPr txBox="1"/>
-          <p:nvPr/>
-        </p:nvSpPr>
-        <p:spPr>
-          <a:xfrm>
-            <a:off x="914400" y="3136392"/>
+          <p:cNvPr id="23" name="Text 21"/>
+          <p:cNvSpPr txBox="1"/>
+          <p:nvPr/>
+        </p:nvSpPr>
+        <p:spPr>
+          <a:xfrm>
+            <a:off x="914400" y="3044952"/>
             <a:ext cx="1828800" cy="274320"/>
           </a:xfrm>
           <a:prstGeom prst="rect">
@@ -12993,13 +13023,13 @@
       </p:sp>
       <p:sp>
         <p:nvSpPr>
-          <p:cNvPr id="23" name="mk-e0"/>
-          <p:cNvSpPr/>
-          <p:nvPr/>
-        </p:nvSpPr>
-        <p:spPr>
-          <a:xfrm>
-            <a:off x="1207008" y="4270248"/>
+          <p:cNvPr id="24" name="mk-e0"/>
+          <p:cNvSpPr/>
+          <p:nvPr/>
+        </p:nvSpPr>
+        <p:spPr>
+          <a:xfrm>
+            <a:off x="1207008" y="3995928"/>
             <a:ext cx="822960" cy="0"/>
           </a:xfrm>
           <a:prstGeom prst="line">
@@ -13016,14 +13046,14 @@
       </p:sp>
       <p:sp>
         <p:nvSpPr>
-          <p:cNvPr id="24" name="mk-e1"/>
+          <p:cNvPr id="25" name="mk-e1"/>
           <p:cNvSpPr/>
           <p:nvPr/>
         </p:nvSpPr>
         <p:spPr>
           <a:xfrm flipV="1">
-            <a:off x="2029968" y="3813048"/>
-            <a:ext cx="822960" cy="457200"/>
+            <a:off x="2029968" y="3630168"/>
+            <a:ext cx="822960" cy="365760"/>
           </a:xfrm>
           <a:prstGeom prst="line">
             <a:avLst/>
@@ -13039,14 +13069,14 @@
       </p:sp>
       <p:sp>
         <p:nvSpPr>
-          <p:cNvPr id="25" name="mk-e2"/>
-          <p:cNvSpPr/>
-          <p:nvPr/>
-        </p:nvSpPr>
-        <p:spPr>
-          <a:xfrm>
-            <a:off x="2029968" y="4270248"/>
-            <a:ext cx="822960" cy="457200"/>
+          <p:cNvPr id="26" name="mk-e2"/>
+          <p:cNvSpPr/>
+          <p:nvPr/>
+        </p:nvSpPr>
+        <p:spPr>
+          <a:xfrm>
+            <a:off x="2029968" y="3995928"/>
+            <a:ext cx="822960" cy="365760"/>
           </a:xfrm>
           <a:prstGeom prst="line">
             <a:avLst/>
@@ -13062,13 +13092,13 @@
       </p:sp>
       <p:sp>
         <p:nvSpPr>
-          <p:cNvPr id="26" name="mk-e3"/>
-          <p:cNvSpPr/>
-          <p:nvPr/>
-        </p:nvSpPr>
-        <p:spPr>
-          <a:xfrm>
-            <a:off x="2852928" y="3813048"/>
+          <p:cNvPr id="27" name="mk-e3"/>
+          <p:cNvSpPr/>
+          <p:nvPr/>
+        </p:nvSpPr>
+        <p:spPr>
+          <a:xfrm>
+            <a:off x="2852928" y="3630168"/>
             <a:ext cx="822960" cy="0"/>
           </a:xfrm>
           <a:prstGeom prst="line">
@@ -13085,13 +13115,13 @@
       </p:sp>
       <p:sp>
         <p:nvSpPr>
-          <p:cNvPr id="27" name="mk-e4"/>
-          <p:cNvSpPr/>
-          <p:nvPr/>
-        </p:nvSpPr>
-        <p:spPr>
-          <a:xfrm>
-            <a:off x="3675888" y="3813048"/>
+          <p:cNvPr id="28" name="mk-e4"/>
+          <p:cNvSpPr/>
+          <p:nvPr/>
+        </p:nvSpPr>
+        <p:spPr>
+          <a:xfrm>
+            <a:off x="3675888" y="3630168"/>
             <a:ext cx="822960" cy="0"/>
           </a:xfrm>
           <a:prstGeom prst="line">
@@ -13102,42 +13132,42 @@
             <a:solidFill>
               <a:schemeClr val="accent1"/>
             </a:solidFill>
+            <a:prstDash val="dash"/>
+          </a:ln>
+        </p:spPr>
+      </p:sp>
+      <p:sp>
+        <p:nvSpPr>
+          <p:cNvPr id="29" name="mk-e5"/>
+          <p:cNvSpPr/>
+          <p:nvPr/>
+        </p:nvSpPr>
+        <p:spPr>
+          <a:xfrm>
+            <a:off x="2852928" y="4361688"/>
+            <a:ext cx="822960" cy="0"/>
+          </a:xfrm>
+          <a:prstGeom prst="line">
+            <a:avLst/>
+          </a:prstGeom>
+          <a:noFill/>
+          <a:ln w="19050">
+            <a:solidFill>
+              <a:schemeClr val="accent5"/>
+            </a:solidFill>
             <a:prstDash val="solid"/>
           </a:ln>
         </p:spPr>
       </p:sp>
       <p:sp>
         <p:nvSpPr>
-          <p:cNvPr id="28" name="mk-e5"/>
-          <p:cNvSpPr/>
-          <p:nvPr/>
-        </p:nvSpPr>
-        <p:spPr>
-          <a:xfrm>
-            <a:off x="2852928" y="4727448"/>
-            <a:ext cx="822960" cy="0"/>
-          </a:xfrm>
-          <a:prstGeom prst="line">
-            <a:avLst/>
-          </a:prstGeom>
-          <a:noFill/>
-          <a:ln w="19050">
-            <a:solidFill>
-              <a:schemeClr val="accent5"/>
-            </a:solidFill>
-            <a:prstDash val="solid"/>
-          </a:ln>
-        </p:spPr>
-      </p:sp>
-      <p:sp>
-        <p:nvSpPr>
-          <p:cNvPr id="29" name="mk-n0"/>
-          <p:cNvSpPr/>
-          <p:nvPr/>
-        </p:nvSpPr>
-        <p:spPr>
-          <a:xfrm>
-            <a:off x="1097280" y="4160520"/>
+          <p:cNvPr id="30" name="mk-n0"/>
+          <p:cNvSpPr/>
+          <p:nvPr/>
+        </p:nvSpPr>
+        <p:spPr>
+          <a:xfrm>
+            <a:off x="1097280" y="3886200"/>
             <a:ext cx="219456" cy="219456"/>
           </a:xfrm>
           <a:prstGeom prst="ellipse">
@@ -13158,13 +13188,13 @@
       </p:sp>
       <p:sp>
         <p:nvSpPr>
-          <p:cNvPr id="30" name="mk-n1"/>
-          <p:cNvSpPr/>
-          <p:nvPr/>
-        </p:nvSpPr>
-        <p:spPr>
-          <a:xfrm>
-            <a:off x="1920240" y="4160520"/>
+          <p:cNvPr id="31" name="mk-n1"/>
+          <p:cNvSpPr/>
+          <p:nvPr/>
+        </p:nvSpPr>
+        <p:spPr>
+          <a:xfrm>
+            <a:off x="1920240" y="3886200"/>
             <a:ext cx="219456" cy="219456"/>
           </a:xfrm>
           <a:prstGeom prst="ellipse">
@@ -13185,13 +13215,13 @@
       </p:sp>
       <p:sp>
         <p:nvSpPr>
-          <p:cNvPr id="31" name="mk-n2"/>
-          <p:cNvSpPr/>
-          <p:nvPr/>
-        </p:nvSpPr>
-        <p:spPr>
-          <a:xfrm>
-            <a:off x="2743200" y="3703320"/>
+          <p:cNvPr id="32" name="mk-n2"/>
+          <p:cNvSpPr/>
+          <p:nvPr/>
+        </p:nvSpPr>
+        <p:spPr>
+          <a:xfrm>
+            <a:off x="2743200" y="3520440"/>
             <a:ext cx="219456" cy="219456"/>
           </a:xfrm>
           <a:prstGeom prst="ellipse">
@@ -13212,13 +13242,13 @@
       </p:sp>
       <p:sp>
         <p:nvSpPr>
-          <p:cNvPr id="32" name="mk-n3"/>
-          <p:cNvSpPr/>
-          <p:nvPr/>
-        </p:nvSpPr>
-        <p:spPr>
-          <a:xfrm>
-            <a:off x="2743200" y="4617720"/>
+          <p:cNvPr id="33" name="mk-n3"/>
+          <p:cNvSpPr/>
+          <p:nvPr/>
+        </p:nvSpPr>
+        <p:spPr>
+          <a:xfrm>
+            <a:off x="2743200" y="4251960"/>
             <a:ext cx="219456" cy="219456"/>
           </a:xfrm>
           <a:prstGeom prst="ellipse">
@@ -13239,13 +13269,13 @@
       </p:sp>
       <p:sp>
         <p:nvSpPr>
-          <p:cNvPr id="33" name="mk-n4"/>
-          <p:cNvSpPr/>
-          <p:nvPr/>
-        </p:nvSpPr>
-        <p:spPr>
-          <a:xfrm>
-            <a:off x="3566160" y="3703320"/>
+          <p:cNvPr id="34" name="mk-n4"/>
+          <p:cNvSpPr/>
+          <p:nvPr/>
+        </p:nvSpPr>
+        <p:spPr>
+          <a:xfrm>
+            <a:off x="3566160" y="3520440"/>
             <a:ext cx="219456" cy="219456"/>
           </a:xfrm>
           <a:prstGeom prst="roundRect">
@@ -13266,13 +13296,13 @@
       </p:sp>
       <p:sp>
         <p:nvSpPr>
-          <p:cNvPr id="34" name="mk-n5"/>
-          <p:cNvSpPr/>
-          <p:nvPr/>
-        </p:nvSpPr>
-        <p:spPr>
-          <a:xfrm>
-            <a:off x="4389120" y="3703320"/>
+          <p:cNvPr id="35" name="mk-n5"/>
+          <p:cNvSpPr/>
+          <p:nvPr/>
+        </p:nvSpPr>
+        <p:spPr>
+          <a:xfrm>
+            <a:off x="4389120" y="3520440"/>
             <a:ext cx="219456" cy="219456"/>
           </a:xfrm>
           <a:prstGeom prst="roundRect">
@@ -13293,13 +13323,13 @@
       </p:sp>
       <p:sp>
         <p:nvSpPr>
-          <p:cNvPr id="35" name="mk-n6"/>
-          <p:cNvSpPr/>
-          <p:nvPr/>
-        </p:nvSpPr>
-        <p:spPr>
-          <a:xfrm>
-            <a:off x="3566160" y="4617720"/>
+          <p:cNvPr id="36" name="mk-n6"/>
+          <p:cNvSpPr/>
+          <p:nvPr/>
+        </p:nvSpPr>
+        <p:spPr>
+          <a:xfrm>
+            <a:off x="3566160" y="4251960"/>
             <a:ext cx="219456" cy="219456"/>
           </a:xfrm>
           <a:prstGeom prst="ellipse">
@@ -13320,13 +13350,13 @@
       </p:sp>
       <p:sp>
         <p:nvSpPr>
-          <p:cNvPr id="36" name="Text 34"/>
-          <p:cNvSpPr txBox="1"/>
-          <p:nvPr/>
-        </p:nvSpPr>
-        <p:spPr>
-          <a:xfrm>
-            <a:off x="868680" y="4434840"/>
+          <p:cNvPr id="37" name="Text 35"/>
+          <p:cNvSpPr txBox="1"/>
+          <p:nvPr/>
+        </p:nvSpPr>
+        <p:spPr>
+          <a:xfrm>
+            <a:off x="868680" y="4142232"/>
             <a:ext cx="731520" cy="228600"/>
           </a:xfrm>
           <a:prstGeom prst="rect">
@@ -13356,14 +13386,14 @@
       </p:sp>
       <p:sp>
         <p:nvSpPr>
-          <p:cNvPr id="37" name="Text 35"/>
-          <p:cNvSpPr txBox="1"/>
-          <p:nvPr/>
-        </p:nvSpPr>
-        <p:spPr>
-          <a:xfrm>
-            <a:off x="3337560" y="3410712"/>
-            <a:ext cx="731520" cy="228600"/>
+          <p:cNvPr id="38" name="Text 36"/>
+          <p:cNvSpPr txBox="1"/>
+          <p:nvPr/>
+        </p:nvSpPr>
+        <p:spPr>
+          <a:xfrm>
+            <a:off x="3200400" y="3282696"/>
+            <a:ext cx="914400" cy="228600"/>
           </a:xfrm>
           <a:prstGeom prst="rect">
             <a:avLst/>
@@ -13384,7 +13414,7 @@
                   <a:schemeClr val="bg2"/>
                 </a:solidFill>
               </a:rPr>
-              <a:t>deposit</a:t>
+              <a:t>likely deposit</a:t>
             </a:r>
             <a:endParaRPr lang="en-US" sz="1000" dirty="0"/>
           </a:p>
@@ -13392,14 +13422,14 @@
       </p:sp>
       <p:sp>
         <p:nvSpPr>
-          <p:cNvPr id="38" name="Text 36"/>
-          <p:cNvSpPr txBox="1"/>
-          <p:nvPr/>
-        </p:nvSpPr>
-        <p:spPr>
-          <a:xfrm>
-            <a:off x="4160520" y="3410712"/>
-            <a:ext cx="731520" cy="228600"/>
+          <p:cNvPr id="39" name="Text 37"/>
+          <p:cNvSpPr txBox="1"/>
+          <p:nvPr/>
+        </p:nvSpPr>
+        <p:spPr>
+          <a:xfrm>
+            <a:off x="4069080" y="3282696"/>
+            <a:ext cx="868680" cy="228600"/>
           </a:xfrm>
           <a:prstGeom prst="rect">
             <a:avLst/>
@@ -13420,7 +13450,7 @@
                   <a:schemeClr val="bg2"/>
                 </a:solidFill>
               </a:rPr>
-              <a:t>exchange</a:t>
+              <a:t>Exchange X</a:t>
             </a:r>
             <a:endParaRPr lang="en-US" sz="1000" dirty="0"/>
           </a:p>
@@ -13428,18 +13458,54 @@
       </p:sp>
       <p:sp>
         <p:nvSpPr>
-          <p:cNvPr id="39" name="mk-contact"/>
-          <p:cNvSpPr/>
-          <p:nvPr/>
-        </p:nvSpPr>
-        <p:spPr>
-          <a:xfrm>
-            <a:off x="5166360" y="3063240"/>
-            <a:ext cx="3017520" cy="1828800"/>
+          <p:cNvPr id="40" name="Text 38"/>
+          <p:cNvSpPr txBox="1"/>
+          <p:nvPr/>
+        </p:nvSpPr>
+        <p:spPr>
+          <a:xfrm>
+            <a:off x="2148840" y="3044952"/>
+            <a:ext cx="2743200" cy="228600"/>
+          </a:xfrm>
+          <a:prstGeom prst="rect">
+            <a:avLst/>
+          </a:prstGeom>
+          <a:noFill/>
+          <a:ln/>
+        </p:spPr>
+        <p:txBody>
+          <a:bodyPr wrap="square" lIns="0" tIns="0" rIns="0" bIns="0" rtlCol="0" anchor="t"/>
+          <a:lstStyle/>
+          <a:p>
+            <a:pPr algn="r" indent="0" marL="0">
+              <a:buNone/>
+            </a:pPr>
+            <a:r>
+              <a:rPr lang="en-US" sz="900" dirty="0">
+                <a:solidFill>
+                  <a:schemeClr val="bg2"/>
+                </a:solidFill>
+              </a:rPr>
+              <a:t>solid = observed tx   dashed = inferred link</a:t>
+            </a:r>
+            <a:endParaRPr lang="en-US" sz="900" dirty="0"/>
+          </a:p>
+        </p:txBody>
+      </p:sp>
+      <p:sp>
+        <p:nvSpPr>
+          <p:cNvPr id="41" name="mk-contact"/>
+          <p:cNvSpPr/>
+          <p:nvPr/>
+        </p:nvSpPr>
+        <p:spPr>
+          <a:xfrm>
+            <a:off x="5166360" y="2971800"/>
+            <a:ext cx="3017520" cy="1600200"/>
           </a:xfrm>
           <a:prstGeom prst="roundRect">
             <a:avLst>
-              <a:gd name="adj" fmla="val 4000"/>
+              <a:gd name="adj" fmla="val 4571"/>
             </a:avLst>
           </a:prstGeom>
           <a:solidFill>
@@ -13455,13 +13521,13 @@
       </p:sp>
       <p:sp>
         <p:nvSpPr>
-          <p:cNvPr id="40" name="Text 38"/>
-          <p:cNvSpPr txBox="1"/>
-          <p:nvPr/>
-        </p:nvSpPr>
-        <p:spPr>
-          <a:xfrm>
-            <a:off x="5303520" y="3154680"/>
+          <p:cNvPr id="42" name="Text 40"/>
+          <p:cNvSpPr txBox="1"/>
+          <p:nvPr/>
+        </p:nvSpPr>
+        <p:spPr>
+          <a:xfrm>
+            <a:off x="5303520" y="3063240"/>
             <a:ext cx="2743200" cy="274320"/>
           </a:xfrm>
           <a:prstGeom prst="rect">
@@ -13483,7 +13549,7 @@
                   <a:schemeClr val="tx1"/>
                 </a:solidFill>
               </a:rPr>
-              <a:t>Exchange X: law-enforcement contact</a:t>
+              <a:t>Exchange X: official LE process</a:t>
             </a:r>
             <a:endParaRPr lang="en-US" sz="1200" dirty="0"/>
           </a:p>
@@ -13491,14 +13557,14 @@
       </p:sp>
       <p:sp>
         <p:nvSpPr>
-          <p:cNvPr id="41" name="mk-tf"/>
-          <p:cNvSpPr/>
-          <p:nvPr/>
-        </p:nvSpPr>
-        <p:spPr>
-          <a:xfrm>
-            <a:off x="5303520" y="3474720"/>
-            <a:ext cx="1691640" cy="237744"/>
+          <p:cNvPr id="43" name="mk-tf"/>
+          <p:cNvSpPr/>
+          <p:nvPr/>
+        </p:nvSpPr>
+        <p:spPr>
+          <a:xfrm>
+            <a:off x="5303520" y="3383280"/>
+            <a:ext cx="2103120" cy="237744"/>
           </a:xfrm>
           <a:prstGeom prst="roundRect">
             <a:avLst>
@@ -13518,14 +13584,14 @@
       </p:sp>
       <p:sp>
         <p:nvSpPr>
-          <p:cNvPr id="42" name="Text 40"/>
-          <p:cNvSpPr txBox="1"/>
-          <p:nvPr/>
-        </p:nvSpPr>
-        <p:spPr>
-          <a:xfrm>
-            <a:off x="5303520" y="3474720"/>
-            <a:ext cx="1691640" cy="237744"/>
+          <p:cNvPr id="44" name="Text 42"/>
+          <p:cNvSpPr txBox="1"/>
+          <p:nvPr/>
+        </p:nvSpPr>
+        <p:spPr>
+          <a:xfrm>
+            <a:off x="5303520" y="3383280"/>
+            <a:ext cx="2103120" cy="237744"/>
           </a:xfrm>
           <a:prstGeom prst="rect">
             <a:avLst/>
@@ -13546,7 +13612,7 @@
                   <a:schemeClr val="bg1"/>
                 </a:solidFill>
               </a:rPr>
-              <a:t>found by TinyFish Agent</a:t>
+              <a:t>via TinyFish Agent + source URL</a:t>
             </a:r>
             <a:endParaRPr lang="en-US" sz="1000" dirty="0"/>
           </a:p>
@@ -13554,14 +13620,14 @@
       </p:sp>
       <p:sp>
         <p:nvSpPr>
-          <p:cNvPr id="43" name="Text 41"/>
-          <p:cNvSpPr txBox="1"/>
-          <p:nvPr/>
-        </p:nvSpPr>
-        <p:spPr>
-          <a:xfrm>
-            <a:off x="5303520" y="3840480"/>
-            <a:ext cx="2743200" cy="777240"/>
+          <p:cNvPr id="45" name="Text 43"/>
+          <p:cNvSpPr txBox="1"/>
+          <p:nvPr/>
+        </p:nvSpPr>
+        <p:spPr>
+          <a:xfrm>
+            <a:off x="5303520" y="3703320"/>
+            <a:ext cx="2743200" cy="502920"/>
           </a:xfrm>
           <a:prstGeom prst="rect">
             <a:avLst/>
@@ -13577,7 +13643,7 @@
               <a:buNone/>
             </a:pPr>
             <a:r>
-              <a:rPr lang="en-US" sz="1100" b="1" dirty="0">
+              <a:rPr lang="en-US" sz="1000" b="1" dirty="0">
                 <a:solidFill>
                   <a:schemeClr val="tx1"/>
                 </a:solidFill>
@@ -13588,21 +13654,21 @@
               <a:buNone/>
             </a:pPr>
             <a:r>
-              <a:rPr lang="en-US" sz="1100" dirty="0">
+              <a:rPr lang="en-US" sz="1000" dirty="0">
                 <a:solidFill>
                   <a:schemeClr val="tx1"/>
                 </a:solidFill>
               </a:rPr>
               <a:t>LE request form</a:t>
             </a:r>
-            <a:endParaRPr lang="en-US" sz="1100" dirty="0"/>
+            <a:endParaRPr lang="en-US" sz="1000" dirty="0"/>
           </a:p>
           <a:p>
             <a:pPr indent="0" marL="0">
               <a:buNone/>
             </a:pPr>
             <a:r>
-              <a:rPr lang="en-US" sz="1100" b="1" dirty="0">
+              <a:rPr lang="en-US" sz="1000" b="1" dirty="0">
                 <a:solidFill>
                   <a:schemeClr val="tx1"/>
                 </a:solidFill>
@@ -13613,52 +13679,52 @@
               <a:buNone/>
             </a:pPr>
             <a:r>
-              <a:rPr lang="en-US" sz="1100" dirty="0">
+              <a:rPr lang="en-US" sz="1000" dirty="0">
                 <a:solidFill>
                   <a:schemeClr val="tx1"/>
                 </a:solidFill>
               </a:rPr>
               <a:t>official email, notice, submit</a:t>
             </a:r>
-            <a:endParaRPr lang="en-US" sz="1100" dirty="0"/>
+            <a:endParaRPr lang="en-US" sz="1000" dirty="0"/>
           </a:p>
           <a:p>
             <a:pPr indent="0" marL="0">
               <a:buNone/>
             </a:pPr>
             <a:r>
-              <a:rPr lang="en-US" sz="1100" b="1" dirty="0">
+              <a:rPr lang="en-US" sz="1000" b="1" dirty="0">
                 <a:solidFill>
                   <a:schemeClr val="tx1"/>
                 </a:solidFill>
               </a:rPr>
-              <a:t>Docs: </a:t>
+              <a:t>Retrieved: </a:t>
             </a:r>
             <a:pPr indent="0" marL="0">
               <a:buNone/>
             </a:pPr>
             <a:r>
-              <a:rPr lang="en-US" sz="1100" dirty="0">
+              <a:rPr lang="en-US" sz="1000" dirty="0">
                 <a:solidFill>
                   <a:schemeClr val="tx1"/>
                 </a:solidFill>
               </a:rPr>
-              <a:t>notice, officer ID, FIR no.</a:t>
-            </a:r>
-            <a:endParaRPr lang="en-US" sz="1100" dirty="0"/>
-          </a:p>
-        </p:txBody>
-      </p:sp>
-      <p:sp>
-        <p:nvSpPr>
-          <p:cNvPr id="44" name="mk-freeze"/>
-          <p:cNvSpPr/>
-          <p:nvPr/>
-        </p:nvSpPr>
-        <p:spPr>
-          <a:xfrm>
-            <a:off x="5303520" y="4507992"/>
-            <a:ext cx="2743200" cy="292608"/>
+              <a:t>10:44 UTC</a:t>
+            </a:r>
+            <a:endParaRPr lang="en-US" sz="1000" dirty="0"/>
+          </a:p>
+        </p:txBody>
+      </p:sp>
+      <p:sp>
+        <p:nvSpPr>
+          <p:cNvPr id="46" name="mk-freeze"/>
+          <p:cNvSpPr/>
+          <p:nvPr/>
+        </p:nvSpPr>
+        <p:spPr>
+          <a:xfrm>
+            <a:off x="5303520" y="4233672"/>
+            <a:ext cx="2743200" cy="274320"/>
           </a:xfrm>
           <a:prstGeom prst="roundRect">
             <a:avLst>
@@ -13678,14 +13744,14 @@
       </p:sp>
       <p:sp>
         <p:nvSpPr>
-          <p:cNvPr id="45" name="Text 43"/>
-          <p:cNvSpPr txBox="1"/>
-          <p:nvPr/>
-        </p:nvSpPr>
-        <p:spPr>
-          <a:xfrm>
-            <a:off x="5303520" y="4507992"/>
-            <a:ext cx="2743200" cy="292608"/>
+          <p:cNvPr id="47" name="Text 45"/>
+          <p:cNvSpPr txBox="1"/>
+          <p:nvPr/>
+        </p:nvSpPr>
+        <p:spPr>
+          <a:xfrm>
+            <a:off x="5303520" y="4233672"/>
+            <a:ext cx="2743200" cy="274320"/>
           </a:xfrm>
           <a:prstGeom prst="rect">
             <a:avLst/>
@@ -13706,7 +13772,7 @@
                   <a:schemeClr val="bg1"/>
                 </a:solidFill>
               </a:rPr>
-              <a:t>Generate freeze request</a:t>
+              <a:t>Draft request (officer verifies)</a:t>
             </a:r>
             <a:endParaRPr lang="en-US" sz="1100" dirty="0"/>
           </a:p>
@@ -13714,18 +13780,18 @@
       </p:sp>
       <p:sp>
         <p:nvSpPr>
-          <p:cNvPr id="46" name="mk-ev"/>
-          <p:cNvSpPr/>
-          <p:nvPr/>
-        </p:nvSpPr>
-        <p:spPr>
-          <a:xfrm>
-            <a:off x="777240" y="5074920"/>
-            <a:ext cx="7406640" cy="1005840"/>
+          <p:cNvPr id="48" name="mk-ev"/>
+          <p:cNvSpPr/>
+          <p:nvPr/>
+        </p:nvSpPr>
+        <p:spPr>
+          <a:xfrm>
+            <a:off x="777240" y="4709160"/>
+            <a:ext cx="7406640" cy="1417320"/>
           </a:xfrm>
           <a:prstGeom prst="roundRect">
             <a:avLst>
-              <a:gd name="adj" fmla="val 7273"/>
+              <a:gd name="adj" fmla="val 5161"/>
             </a:avLst>
           </a:prstGeom>
           <a:solidFill>
@@ -13741,14 +13807,14 @@
       </p:sp>
       <p:sp>
         <p:nvSpPr>
-          <p:cNvPr id="47" name="Text 45"/>
-          <p:cNvSpPr txBox="1"/>
-          <p:nvPr/>
-        </p:nvSpPr>
-        <p:spPr>
-          <a:xfrm>
-            <a:off x="914400" y="5148072"/>
-            <a:ext cx="2743200" cy="274320"/>
+          <p:cNvPr id="49" name="Text 47"/>
+          <p:cNvSpPr txBox="1"/>
+          <p:nvPr/>
+        </p:nvSpPr>
+        <p:spPr>
+          <a:xfrm>
+            <a:off x="914400" y="4764024"/>
+            <a:ext cx="2743200" cy="256032"/>
           </a:xfrm>
           <a:prstGeom prst="rect">
             <a:avLst/>
@@ -13777,14 +13843,372 @@
       </p:sp>
       <p:sp>
         <p:nvSpPr>
-          <p:cNvPr id="48" name="Text 46"/>
-          <p:cNvSpPr txBox="1"/>
-          <p:nvPr/>
-        </p:nvSpPr>
-        <p:spPr>
-          <a:xfrm>
-            <a:off x="914400" y="5458968"/>
-            <a:ext cx="1005840" cy="256032"/>
+          <p:cNvPr id="50" name="mk-ev0"/>
+          <p:cNvSpPr/>
+          <p:nvPr/>
+        </p:nvSpPr>
+        <p:spPr>
+          <a:xfrm>
+            <a:off x="914400" y="5074920"/>
+            <a:ext cx="868680" cy="219456"/>
+          </a:xfrm>
+          <a:prstGeom prst="roundRect">
+            <a:avLst>
+              <a:gd name="adj" fmla="val 50000"/>
+            </a:avLst>
+          </a:prstGeom>
+          <a:solidFill>
+            <a:schemeClr val="accent3"/>
+          </a:solidFill>
+          <a:ln w="12700">
+            <a:solidFill>
+              <a:schemeClr val="accent3"/>
+            </a:solidFill>
+            <a:prstDash val="solid"/>
+          </a:ln>
+        </p:spPr>
+      </p:sp>
+      <p:sp>
+        <p:nvSpPr>
+          <p:cNvPr id="51" name="Text 49"/>
+          <p:cNvSpPr txBox="1"/>
+          <p:nvPr/>
+        </p:nvSpPr>
+        <p:spPr>
+          <a:xfrm>
+            <a:off x="914400" y="5074920"/>
+            <a:ext cx="868680" cy="219456"/>
+          </a:xfrm>
+          <a:prstGeom prst="rect">
+            <a:avLst/>
+          </a:prstGeom>
+          <a:noFill/>
+          <a:ln/>
+        </p:spPr>
+        <p:txBody>
+          <a:bodyPr wrap="square" lIns="0" tIns="0" rIns="0" bIns="0" rtlCol="0" anchor="ctr"/>
+          <a:lstStyle/>
+          <a:p>
+            <a:pPr algn="ctr" indent="0" marL="0">
+              <a:buNone/>
+            </a:pPr>
+            <a:r>
+              <a:rPr lang="en-US" sz="900" b="1" dirty="0">
+                <a:solidFill>
+                  <a:schemeClr val="bg1"/>
+                </a:solidFill>
+              </a:rPr>
+              <a:t>OBSERVED</a:t>
+            </a:r>
+            <a:endParaRPr lang="en-US" sz="900" dirty="0"/>
+          </a:p>
+        </p:txBody>
+      </p:sp>
+      <p:sp>
+        <p:nvSpPr>
+          <p:cNvPr id="52" name="Text 50"/>
+          <p:cNvSpPr txBox="1"/>
+          <p:nvPr/>
+        </p:nvSpPr>
+        <p:spPr>
+          <a:xfrm>
+            <a:off x="1874520" y="5074920"/>
+            <a:ext cx="6126480" cy="219456"/>
+          </a:xfrm>
+          <a:prstGeom prst="rect">
+            <a:avLst/>
+          </a:prstGeom>
+          <a:noFill/>
+          <a:ln/>
+        </p:spPr>
+        <p:txBody>
+          <a:bodyPr wrap="square" lIns="0" tIns="0" rIns="0" bIns="0" rtlCol="0" anchor="ctr"/>
+          <a:lstStyle/>
+          <a:p>
+            <a:pPr indent="0" marL="0">
+              <a:buNone/>
+            </a:pPr>
+            <a:r>
+              <a:rPr lang="en-US" sz="1000" dirty="0">
+                <a:solidFill>
+                  <a:schemeClr val="tx1"/>
+                </a:solidFill>
+              </a:rPr>
+              <a:t>tx 9c1e…44a0   reported wallet → TQ7…9F2   8,990 USDT   08 Oct 13:27 UTC</a:t>
+            </a:r>
+            <a:endParaRPr lang="en-US" sz="1000" dirty="0"/>
+          </a:p>
+        </p:txBody>
+      </p:sp>
+      <p:sp>
+        <p:nvSpPr>
+          <p:cNvPr id="53" name="mk-ev1"/>
+          <p:cNvSpPr/>
+          <p:nvPr/>
+        </p:nvSpPr>
+        <p:spPr>
+          <a:xfrm>
+            <a:off x="914400" y="5349240"/>
+            <a:ext cx="868680" cy="219456"/>
+          </a:xfrm>
+          <a:prstGeom prst="roundRect">
+            <a:avLst>
+              <a:gd name="adj" fmla="val 50000"/>
+            </a:avLst>
+          </a:prstGeom>
+          <a:solidFill>
+            <a:schemeClr val="accent1"/>
+          </a:solidFill>
+          <a:ln w="12700">
+            <a:solidFill>
+              <a:schemeClr val="accent1"/>
+            </a:solidFill>
+            <a:prstDash val="solid"/>
+          </a:ln>
+        </p:spPr>
+      </p:sp>
+      <p:sp>
+        <p:nvSpPr>
+          <p:cNvPr id="54" name="Text 52"/>
+          <p:cNvSpPr txBox="1"/>
+          <p:nvPr/>
+        </p:nvSpPr>
+        <p:spPr>
+          <a:xfrm>
+            <a:off x="914400" y="5349240"/>
+            <a:ext cx="868680" cy="219456"/>
+          </a:xfrm>
+          <a:prstGeom prst="rect">
+            <a:avLst/>
+          </a:prstGeom>
+          <a:noFill/>
+          <a:ln/>
+        </p:spPr>
+        <p:txBody>
+          <a:bodyPr wrap="square" lIns="0" tIns="0" rIns="0" bIns="0" rtlCol="0" anchor="ctr"/>
+          <a:lstStyle/>
+          <a:p>
+            <a:pPr algn="ctr" indent="0" marL="0">
+              <a:buNone/>
+            </a:pPr>
+            <a:r>
+              <a:rPr lang="en-US" sz="900" b="1" dirty="0">
+                <a:solidFill>
+                  <a:schemeClr val="bg1"/>
+                </a:solidFill>
+              </a:rPr>
+              <a:t>INFERRED</a:t>
+            </a:r>
+            <a:endParaRPr lang="en-US" sz="900" dirty="0"/>
+          </a:p>
+        </p:txBody>
+      </p:sp>
+      <p:sp>
+        <p:nvSpPr>
+          <p:cNvPr id="55" name="Text 53"/>
+          <p:cNvSpPr txBox="1"/>
+          <p:nvPr/>
+        </p:nvSpPr>
+        <p:spPr>
+          <a:xfrm>
+            <a:off x="1874520" y="5349240"/>
+            <a:ext cx="6126480" cy="219456"/>
+          </a:xfrm>
+          <a:prstGeom prst="rect">
+            <a:avLst/>
+          </a:prstGeom>
+          <a:noFill/>
+          <a:ln/>
+        </p:spPr>
+        <p:txBody>
+          <a:bodyPr wrap="square" lIns="0" tIns="0" rIns="0" bIns="0" rtlCol="0" anchor="ctr"/>
+          <a:lstStyle/>
+          <a:p>
+            <a:pPr indent="0" marL="0">
+              <a:buNone/>
+            </a:pPr>
+            <a:r>
+              <a:rPr lang="en-US" sz="1000" dirty="0">
+                <a:solidFill>
+                  <a:schemeClr val="tx1"/>
+                </a:solidFill>
+              </a:rPr>
+              <a:t>TQ7…9F2 sweeps to an Exchange X wallet → likely deposit address (medium)</a:t>
+            </a:r>
+            <a:endParaRPr lang="en-US" sz="1000" dirty="0"/>
+          </a:p>
+        </p:txBody>
+      </p:sp>
+      <p:sp>
+        <p:nvSpPr>
+          <p:cNvPr id="56" name="mk-ev2"/>
+          <p:cNvSpPr/>
+          <p:nvPr/>
+        </p:nvSpPr>
+        <p:spPr>
+          <a:xfrm>
+            <a:off x="914400" y="5623560"/>
+            <a:ext cx="868680" cy="219456"/>
+          </a:xfrm>
+          <a:prstGeom prst="roundRect">
+            <a:avLst>
+              <a:gd name="adj" fmla="val 50000"/>
+            </a:avLst>
+          </a:prstGeom>
+          <a:solidFill>
+            <a:schemeClr val="accent2"/>
+          </a:solidFill>
+          <a:ln w="12700">
+            <a:solidFill>
+              <a:schemeClr val="accent2"/>
+            </a:solidFill>
+            <a:prstDash val="solid"/>
+          </a:ln>
+        </p:spPr>
+      </p:sp>
+      <p:sp>
+        <p:nvSpPr>
+          <p:cNvPr id="57" name="Text 55"/>
+          <p:cNvSpPr txBox="1"/>
+          <p:nvPr/>
+        </p:nvSpPr>
+        <p:spPr>
+          <a:xfrm>
+            <a:off x="914400" y="5623560"/>
+            <a:ext cx="868680" cy="219456"/>
+          </a:xfrm>
+          <a:prstGeom prst="rect">
+            <a:avLst/>
+          </a:prstGeom>
+          <a:noFill/>
+          <a:ln/>
+        </p:spPr>
+        <p:txBody>
+          <a:bodyPr wrap="square" lIns="0" tIns="0" rIns="0" bIns="0" rtlCol="0" anchor="ctr"/>
+          <a:lstStyle/>
+          <a:p>
+            <a:pPr algn="ctr" indent="0" marL="0">
+              <a:buNone/>
+            </a:pPr>
+            <a:r>
+              <a:rPr lang="en-US" sz="900" b="1" dirty="0">
+                <a:solidFill>
+                  <a:schemeClr val="bg1"/>
+                </a:solidFill>
+              </a:rPr>
+              <a:t>SOURCE</a:t>
+            </a:r>
+            <a:endParaRPr lang="en-US" sz="900" dirty="0"/>
+          </a:p>
+        </p:txBody>
+      </p:sp>
+      <p:sp>
+        <p:nvSpPr>
+          <p:cNvPr id="58" name="Text 56"/>
+          <p:cNvSpPr txBox="1"/>
+          <p:nvPr/>
+        </p:nvSpPr>
+        <p:spPr>
+          <a:xfrm>
+            <a:off x="1874520" y="5623560"/>
+            <a:ext cx="6126480" cy="219456"/>
+          </a:xfrm>
+          <a:prstGeom prst="rect">
+            <a:avLst/>
+          </a:prstGeom>
+          <a:noFill/>
+          <a:ln/>
+        </p:spPr>
+        <p:txBody>
+          <a:bodyPr wrap="square" lIns="0" tIns="0" rIns="0" bIns="0" rtlCol="0" anchor="ctr"/>
+          <a:lstStyle/>
+          <a:p>
+            <a:pPr indent="0" marL="0">
+              <a:buNone/>
+            </a:pPr>
+            <a:r>
+              <a:rPr lang="en-US" sz="1000" dirty="0">
+                <a:solidFill>
+                  <a:schemeClr val="tx1"/>
+                </a:solidFill>
+              </a:rPr>
+              <a:t>scam-report page, retrieved 10:42 UTC   sha256 3f9a…c1</a:t>
+            </a:r>
+            <a:endParaRPr lang="en-US" sz="1000" dirty="0"/>
+          </a:p>
+        </p:txBody>
+      </p:sp>
+      <p:sp>
+        <p:nvSpPr>
+          <p:cNvPr id="59" name="co0"/>
+          <p:cNvSpPr/>
+          <p:nvPr/>
+        </p:nvSpPr>
+        <p:spPr>
+          <a:xfrm>
+            <a:off x="8732520" y="1600200"/>
+            <a:ext cx="457200" cy="457200"/>
+          </a:xfrm>
+          <a:prstGeom prst="ellipse">
+            <a:avLst/>
+          </a:prstGeom>
+          <a:solidFill>
+            <a:schemeClr val="accent1"/>
+          </a:solidFill>
+          <a:ln w="12700">
+            <a:solidFill>
+              <a:schemeClr val="accent1"/>
+            </a:solidFill>
+            <a:prstDash val="solid"/>
+          </a:ln>
+        </p:spPr>
+      </p:sp>
+      <p:sp>
+        <p:nvSpPr>
+          <p:cNvPr id="60" name="Text 58"/>
+          <p:cNvSpPr txBox="1"/>
+          <p:nvPr/>
+        </p:nvSpPr>
+        <p:spPr>
+          <a:xfrm>
+            <a:off x="8732520" y="1600200"/>
+            <a:ext cx="457200" cy="457200"/>
+          </a:xfrm>
+          <a:prstGeom prst="rect">
+            <a:avLst/>
+          </a:prstGeom>
+          <a:noFill/>
+          <a:ln/>
+        </p:spPr>
+        <p:txBody>
+          <a:bodyPr wrap="square" lIns="0" tIns="0" rIns="0" bIns="0" rtlCol="0" anchor="ctr"/>
+          <a:lstStyle/>
+          <a:p>
+            <a:pPr algn="ctr" indent="0" marL="0">
+              <a:buNone/>
+            </a:pPr>
+            <a:r>
+              <a:rPr lang="en-US" sz="1600" b="1" dirty="0">
+                <a:solidFill>
+                  <a:schemeClr val="bg1"/>
+                </a:solidFill>
+              </a:rPr>
+              <a:t>1</a:t>
+            </a:r>
+            <a:endParaRPr lang="en-US" sz="1600" dirty="0"/>
+          </a:p>
+        </p:txBody>
+      </p:sp>
+      <p:sp>
+        <p:nvSpPr>
+          <p:cNvPr id="61" name="Text 59"/>
+          <p:cNvSpPr txBox="1"/>
+          <p:nvPr/>
+        </p:nvSpPr>
+        <p:spPr>
+          <a:xfrm>
+            <a:off x="9372600" y="1581912"/>
+            <a:ext cx="2270455" cy="365760"/>
           </a:xfrm>
           <a:prstGeom prst="rect">
             <a:avLst/>
@@ -13800,27 +14224,27 @@
               <a:buNone/>
             </a:pPr>
             <a:r>
-              <a:rPr lang="en-US" sz="1100" dirty="0">
-                <a:solidFill>
-                  <a:schemeClr val="accent5"/>
-                </a:solidFill>
-              </a:rPr>
-              <a:t>10:42 UTC</a:t>
-            </a:r>
-            <a:endParaRPr lang="en-US" sz="1100" dirty="0"/>
-          </a:p>
-        </p:txBody>
-      </p:sp>
-      <p:sp>
-        <p:nvSpPr>
-          <p:cNvPr id="49" name="Text 47"/>
-          <p:cNvSpPr txBox="1"/>
-          <p:nvPr/>
-        </p:nvSpPr>
-        <p:spPr>
-          <a:xfrm>
-            <a:off x="1965960" y="5458968"/>
-            <a:ext cx="4114800" cy="256032"/>
+              <a:rPr lang="en-US" sz="1600" b="1" dirty="0">
+                <a:solidFill>
+                  <a:schemeClr val="tx1"/>
+                </a:solidFill>
+              </a:rPr>
+              <a:t>Confidence, not verdict</a:t>
+            </a:r>
+            <a:endParaRPr lang="en-US" sz="1600" dirty="0"/>
+          </a:p>
+        </p:txBody>
+      </p:sp>
+      <p:sp>
+        <p:nvSpPr>
+          <p:cNvPr id="62" name="Text 60"/>
+          <p:cNvSpPr txBox="1"/>
+          <p:nvPr/>
+        </p:nvSpPr>
+        <p:spPr>
+          <a:xfrm>
+            <a:off x="9372600" y="1965960"/>
+            <a:ext cx="2270455" cy="548640"/>
           </a:xfrm>
           <a:prstGeom prst="rect">
             <a:avLst/>
@@ -13836,27 +14260,124 @@
               <a:buNone/>
             </a:pPr>
             <a:r>
-              <a:rPr lang="en-US" sz="1100" dirty="0">
+              <a:rPr lang="en-US" sz="1300" dirty="0">
+                <a:solidFill>
+                  <a:schemeClr val="tx2"/>
+                </a:solidFill>
+              </a:rPr>
+              <a:t>Every lead rated High / Medium / Low</a:t>
+            </a:r>
+            <a:endParaRPr lang="en-US" sz="1300" dirty="0"/>
+          </a:p>
+        </p:txBody>
+      </p:sp>
+      <p:sp>
+        <p:nvSpPr>
+          <p:cNvPr id="63" name="co1"/>
+          <p:cNvSpPr/>
+          <p:nvPr/>
+        </p:nvSpPr>
+        <p:spPr>
+          <a:xfrm>
+            <a:off x="8732520" y="2770632"/>
+            <a:ext cx="457200" cy="457200"/>
+          </a:xfrm>
+          <a:prstGeom prst="ellipse">
+            <a:avLst/>
+          </a:prstGeom>
+          <a:solidFill>
+            <a:schemeClr val="accent1"/>
+          </a:solidFill>
+          <a:ln w="12700">
+            <a:solidFill>
+              <a:schemeClr val="accent1"/>
+            </a:solidFill>
+            <a:prstDash val="solid"/>
+          </a:ln>
+        </p:spPr>
+      </p:sp>
+      <p:sp>
+        <p:nvSpPr>
+          <p:cNvPr id="64" name="Text 62"/>
+          <p:cNvSpPr txBox="1"/>
+          <p:nvPr/>
+        </p:nvSpPr>
+        <p:spPr>
+          <a:xfrm>
+            <a:off x="8732520" y="2770632"/>
+            <a:ext cx="457200" cy="457200"/>
+          </a:xfrm>
+          <a:prstGeom prst="rect">
+            <a:avLst/>
+          </a:prstGeom>
+          <a:noFill/>
+          <a:ln/>
+        </p:spPr>
+        <p:txBody>
+          <a:bodyPr wrap="square" lIns="0" tIns="0" rIns="0" bIns="0" rtlCol="0" anchor="ctr"/>
+          <a:lstStyle/>
+          <a:p>
+            <a:pPr algn="ctr" indent="0" marL="0">
+              <a:buNone/>
+            </a:pPr>
+            <a:r>
+              <a:rPr lang="en-US" sz="1600" b="1" dirty="0">
+                <a:solidFill>
+                  <a:schemeClr val="bg1"/>
+                </a:solidFill>
+              </a:rPr>
+              <a:t>2</a:t>
+            </a:r>
+            <a:endParaRPr lang="en-US" sz="1600" dirty="0"/>
+          </a:p>
+        </p:txBody>
+      </p:sp>
+      <p:sp>
+        <p:nvSpPr>
+          <p:cNvPr id="65" name="Text 63"/>
+          <p:cNvSpPr txBox="1"/>
+          <p:nvPr/>
+        </p:nvSpPr>
+        <p:spPr>
+          <a:xfrm>
+            <a:off x="9372600" y="2752344"/>
+            <a:ext cx="2270455" cy="365760"/>
+          </a:xfrm>
+          <a:prstGeom prst="rect">
+            <a:avLst/>
+          </a:prstGeom>
+          <a:noFill/>
+          <a:ln/>
+        </p:spPr>
+        <p:txBody>
+          <a:bodyPr wrap="square" lIns="0" tIns="0" rIns="0" bIns="0" rtlCol="0" anchor="t"/>
+          <a:lstStyle/>
+          <a:p>
+            <a:pPr indent="0" marL="0">
+              <a:buNone/>
+            </a:pPr>
+            <a:r>
+              <a:rPr lang="en-US" sz="1600" b="1" dirty="0">
                 <a:solidFill>
                   <a:schemeClr val="tx1"/>
                 </a:solidFill>
               </a:rPr>
-              <a:t>Scam-report page mentioning the wallet</a:t>
-            </a:r>
-            <a:endParaRPr lang="en-US" sz="1100" dirty="0"/>
-          </a:p>
-        </p:txBody>
-      </p:sp>
-      <p:sp>
-        <p:nvSpPr>
-          <p:cNvPr id="50" name="Text 48"/>
-          <p:cNvSpPr txBox="1"/>
-          <p:nvPr/>
-        </p:nvSpPr>
-        <p:spPr>
-          <a:xfrm>
-            <a:off x="6172200" y="5458968"/>
-            <a:ext cx="1828800" cy="256032"/>
+              <a:t>Observed vs inferred</a:t>
+            </a:r>
+            <a:endParaRPr lang="en-US" sz="1600" dirty="0"/>
+          </a:p>
+        </p:txBody>
+      </p:sp>
+      <p:sp>
+        <p:nvSpPr>
+          <p:cNvPr id="66" name="Text 64"/>
+          <p:cNvSpPr txBox="1"/>
+          <p:nvPr/>
+        </p:nvSpPr>
+        <p:spPr>
+          <a:xfrm>
+            <a:off x="9372600" y="3136392"/>
+            <a:ext cx="2270455" cy="548640"/>
           </a:xfrm>
           <a:prstGeom prst="rect">
             <a:avLst/>
@@ -13872,27 +14393,88 @@
               <a:buNone/>
             </a:pPr>
             <a:r>
-              <a:rPr lang="en-US" sz="1100" dirty="0">
-                <a:solidFill>
-                  <a:schemeClr val="accent5"/>
-                </a:solidFill>
-              </a:rPr>
-              <a:t>sha256 3f9a…c1</a:t>
-            </a:r>
-            <a:endParaRPr lang="en-US" sz="1100" dirty="0"/>
-          </a:p>
-        </p:txBody>
-      </p:sp>
-      <p:sp>
-        <p:nvSpPr>
-          <p:cNvPr id="51" name="Text 49"/>
-          <p:cNvSpPr txBox="1"/>
-          <p:nvPr/>
-        </p:nvSpPr>
-        <p:spPr>
-          <a:xfrm>
-            <a:off x="914400" y="5751576"/>
-            <a:ext cx="1005840" cy="256032"/>
+              <a:rPr lang="en-US" sz="1300" dirty="0">
+                <a:solidFill>
+                  <a:schemeClr val="tx2"/>
+                </a:solidFill>
+              </a:rPr>
+              <a:t>Tx hashes are facts; exchange links are inferences</a:t>
+            </a:r>
+            <a:endParaRPr lang="en-US" sz="1300" dirty="0"/>
+          </a:p>
+        </p:txBody>
+      </p:sp>
+      <p:sp>
+        <p:nvSpPr>
+          <p:cNvPr id="67" name="co2"/>
+          <p:cNvSpPr/>
+          <p:nvPr/>
+        </p:nvSpPr>
+        <p:spPr>
+          <a:xfrm>
+            <a:off x="8732520" y="3941064"/>
+            <a:ext cx="457200" cy="457200"/>
+          </a:xfrm>
+          <a:prstGeom prst="ellipse">
+            <a:avLst/>
+          </a:prstGeom>
+          <a:solidFill>
+            <a:schemeClr val="accent1"/>
+          </a:solidFill>
+          <a:ln w="12700">
+            <a:solidFill>
+              <a:schemeClr val="accent1"/>
+            </a:solidFill>
+            <a:prstDash val="solid"/>
+          </a:ln>
+        </p:spPr>
+      </p:sp>
+      <p:sp>
+        <p:nvSpPr>
+          <p:cNvPr id="68" name="Text 66"/>
+          <p:cNvSpPr txBox="1"/>
+          <p:nvPr/>
+        </p:nvSpPr>
+        <p:spPr>
+          <a:xfrm>
+            <a:off x="8732520" y="3941064"/>
+            <a:ext cx="457200" cy="457200"/>
+          </a:xfrm>
+          <a:prstGeom prst="rect">
+            <a:avLst/>
+          </a:prstGeom>
+          <a:noFill/>
+          <a:ln/>
+        </p:spPr>
+        <p:txBody>
+          <a:bodyPr wrap="square" lIns="0" tIns="0" rIns="0" bIns="0" rtlCol="0" anchor="ctr"/>
+          <a:lstStyle/>
+          <a:p>
+            <a:pPr algn="ctr" indent="0" marL="0">
+              <a:buNone/>
+            </a:pPr>
+            <a:r>
+              <a:rPr lang="en-US" sz="1600" b="1" dirty="0">
+                <a:solidFill>
+                  <a:schemeClr val="bg1"/>
+                </a:solidFill>
+              </a:rPr>
+              <a:t>3</a:t>
+            </a:r>
+            <a:endParaRPr lang="en-US" sz="1600" dirty="0"/>
+          </a:p>
+        </p:txBody>
+      </p:sp>
+      <p:sp>
+        <p:nvSpPr>
+          <p:cNvPr id="69" name="Text 67"/>
+          <p:cNvSpPr txBox="1"/>
+          <p:nvPr/>
+        </p:nvSpPr>
+        <p:spPr>
+          <a:xfrm>
+            <a:off x="9372600" y="3922776"/>
+            <a:ext cx="2270455" cy="365760"/>
           </a:xfrm>
           <a:prstGeom prst="rect">
             <a:avLst/>
@@ -13908,27 +14490,27 @@
               <a:buNone/>
             </a:pPr>
             <a:r>
-              <a:rPr lang="en-US" sz="1100" dirty="0">
-                <a:solidFill>
-                  <a:schemeClr val="accent5"/>
-                </a:solidFill>
-              </a:rPr>
-              <a:t>10:43 UTC</a:t>
-            </a:r>
-            <a:endParaRPr lang="en-US" sz="1100" dirty="0"/>
-          </a:p>
-        </p:txBody>
-      </p:sp>
-      <p:sp>
-        <p:nvSpPr>
-          <p:cNvPr id="52" name="Text 50"/>
-          <p:cNvSpPr txBox="1"/>
-          <p:nvPr/>
-        </p:nvSpPr>
-        <p:spPr>
-          <a:xfrm>
-            <a:off x="1965960" y="5751576"/>
-            <a:ext cx="4114800" cy="256032"/>
+              <a:rPr lang="en-US" sz="1600" b="1" dirty="0">
+                <a:solidFill>
+                  <a:schemeClr val="tx1"/>
+                </a:solidFill>
+              </a:rPr>
+              <a:t>Official process</a:t>
+            </a:r>
+            <a:endParaRPr lang="en-US" sz="1600" dirty="0"/>
+          </a:p>
+        </p:txBody>
+      </p:sp>
+      <p:sp>
+        <p:nvSpPr>
+          <p:cNvPr id="70" name="Text 68"/>
+          <p:cNvSpPr txBox="1"/>
+          <p:nvPr/>
+        </p:nvSpPr>
+        <p:spPr>
+          <a:xfrm>
+            <a:off x="9372600" y="4306824"/>
+            <a:ext cx="2270455" cy="548640"/>
           </a:xfrm>
           <a:prstGeom prst="rect">
             <a:avLst/>
@@ -13944,27 +14526,124 @@
               <a:buNone/>
             </a:pPr>
             <a:r>
-              <a:rPr lang="en-US" sz="1100" dirty="0">
+              <a:rPr lang="en-US" sz="1300" dirty="0">
+                <a:solidFill>
+                  <a:schemeClr val="tx2"/>
+                </a:solidFill>
+              </a:rPr>
+              <a:t>Found by the TinyFish agent, with its source URL</a:t>
+            </a:r>
+            <a:endParaRPr lang="en-US" sz="1300" dirty="0"/>
+          </a:p>
+        </p:txBody>
+      </p:sp>
+      <p:sp>
+        <p:nvSpPr>
+          <p:cNvPr id="71" name="co3"/>
+          <p:cNvSpPr/>
+          <p:nvPr/>
+        </p:nvSpPr>
+        <p:spPr>
+          <a:xfrm>
+            <a:off x="8732520" y="5111496"/>
+            <a:ext cx="457200" cy="457200"/>
+          </a:xfrm>
+          <a:prstGeom prst="ellipse">
+            <a:avLst/>
+          </a:prstGeom>
+          <a:solidFill>
+            <a:schemeClr val="accent1"/>
+          </a:solidFill>
+          <a:ln w="12700">
+            <a:solidFill>
+              <a:schemeClr val="accent1"/>
+            </a:solidFill>
+            <a:prstDash val="solid"/>
+          </a:ln>
+        </p:spPr>
+      </p:sp>
+      <p:sp>
+        <p:nvSpPr>
+          <p:cNvPr id="72" name="Text 70"/>
+          <p:cNvSpPr txBox="1"/>
+          <p:nvPr/>
+        </p:nvSpPr>
+        <p:spPr>
+          <a:xfrm>
+            <a:off x="8732520" y="5111496"/>
+            <a:ext cx="457200" cy="457200"/>
+          </a:xfrm>
+          <a:prstGeom prst="rect">
+            <a:avLst/>
+          </a:prstGeom>
+          <a:noFill/>
+          <a:ln/>
+        </p:spPr>
+        <p:txBody>
+          <a:bodyPr wrap="square" lIns="0" tIns="0" rIns="0" bIns="0" rtlCol="0" anchor="ctr"/>
+          <a:lstStyle/>
+          <a:p>
+            <a:pPr algn="ctr" indent="0" marL="0">
+              <a:buNone/>
+            </a:pPr>
+            <a:r>
+              <a:rPr lang="en-US" sz="1600" b="1" dirty="0">
+                <a:solidFill>
+                  <a:schemeClr val="bg1"/>
+                </a:solidFill>
+              </a:rPr>
+              <a:t>4</a:t>
+            </a:r>
+            <a:endParaRPr lang="en-US" sz="1600" dirty="0"/>
+          </a:p>
+        </p:txBody>
+      </p:sp>
+      <p:sp>
+        <p:nvSpPr>
+          <p:cNvPr id="73" name="Text 71"/>
+          <p:cNvSpPr txBox="1"/>
+          <p:nvPr/>
+        </p:nvSpPr>
+        <p:spPr>
+          <a:xfrm>
+            <a:off x="9372600" y="5093208"/>
+            <a:ext cx="2270455" cy="365760"/>
+          </a:xfrm>
+          <a:prstGeom prst="rect">
+            <a:avLst/>
+          </a:prstGeom>
+          <a:noFill/>
+          <a:ln/>
+        </p:spPr>
+        <p:txBody>
+          <a:bodyPr wrap="square" lIns="0" tIns="0" rIns="0" bIns="0" rtlCol="0" anchor="t"/>
+          <a:lstStyle/>
+          <a:p>
+            <a:pPr indent="0" marL="0">
+              <a:buNone/>
+            </a:pPr>
+            <a:r>
+              <a:rPr lang="en-US" sz="1600" b="1" dirty="0">
                 <a:solidFill>
                   <a:schemeClr val="tx1"/>
                 </a:solidFill>
               </a:rPr>
-              <a:t>Exchange X law-enforcement page</a:t>
-            </a:r>
-            <a:endParaRPr lang="en-US" sz="1100" dirty="0"/>
-          </a:p>
-        </p:txBody>
-      </p:sp>
-      <p:sp>
-        <p:nvSpPr>
-          <p:cNvPr id="53" name="Text 51"/>
-          <p:cNvSpPr txBox="1"/>
-          <p:nvPr/>
-        </p:nvSpPr>
-        <p:spPr>
-          <a:xfrm>
-            <a:off x="6172200" y="5751576"/>
-            <a:ext cx="1828800" cy="256032"/>
+              <a:t>Traceable evidence</a:t>
+            </a:r>
+            <a:endParaRPr lang="en-US" sz="1600" dirty="0"/>
+          </a:p>
+        </p:txBody>
+      </p:sp>
+      <p:sp>
+        <p:nvSpPr>
+          <p:cNvPr id="74" name="Text 72"/>
+          <p:cNvSpPr txBox="1"/>
+          <p:nvPr/>
+        </p:nvSpPr>
+        <p:spPr>
+          <a:xfrm>
+            <a:off x="9372600" y="5477256"/>
+            <a:ext cx="2270455" cy="548640"/>
           </a:xfrm>
           <a:prstGeom prst="rect">
             <a:avLst/>
@@ -13980,544 +14659,12 @@
               <a:buNone/>
             </a:pPr>
             <a:r>
-              <a:rPr lang="en-US" sz="1100" dirty="0">
-                <a:solidFill>
-                  <a:schemeClr val="accent5"/>
-                </a:solidFill>
-              </a:rPr>
-              <a:t>sha256 8b21…7e</a:t>
-            </a:r>
-            <a:endParaRPr lang="en-US" sz="1100" dirty="0"/>
-          </a:p>
-        </p:txBody>
-      </p:sp>
-      <p:sp>
-        <p:nvSpPr>
-          <p:cNvPr id="54" name="co0"/>
-          <p:cNvSpPr/>
-          <p:nvPr/>
-        </p:nvSpPr>
-        <p:spPr>
-          <a:xfrm>
-            <a:off x="8732520" y="1508760"/>
-            <a:ext cx="457200" cy="457200"/>
-          </a:xfrm>
-          <a:prstGeom prst="ellipse">
-            <a:avLst/>
-          </a:prstGeom>
-          <a:solidFill>
-            <a:schemeClr val="accent1"/>
-          </a:solidFill>
-          <a:ln w="12700">
-            <a:solidFill>
-              <a:schemeClr val="accent1"/>
-            </a:solidFill>
-            <a:prstDash val="solid"/>
-          </a:ln>
-        </p:spPr>
-      </p:sp>
-      <p:sp>
-        <p:nvSpPr>
-          <p:cNvPr id="55" name="Text 53"/>
-          <p:cNvSpPr txBox="1"/>
-          <p:nvPr/>
-        </p:nvSpPr>
-        <p:spPr>
-          <a:xfrm>
-            <a:off x="8732520" y="1508760"/>
-            <a:ext cx="457200" cy="457200"/>
-          </a:xfrm>
-          <a:prstGeom prst="rect">
-            <a:avLst/>
-          </a:prstGeom>
-          <a:noFill/>
-          <a:ln/>
-        </p:spPr>
-        <p:txBody>
-          <a:bodyPr wrap="square" lIns="0" tIns="0" rIns="0" bIns="0" rtlCol="0" anchor="ctr"/>
-          <a:lstStyle/>
-          <a:p>
-            <a:pPr algn="ctr" indent="0" marL="0">
-              <a:buNone/>
-            </a:pPr>
-            <a:r>
-              <a:rPr lang="en-US" sz="1600" b="1" dirty="0">
-                <a:solidFill>
-                  <a:schemeClr val="bg1"/>
-                </a:solidFill>
-              </a:rPr>
-              <a:t>1</a:t>
-            </a:r>
-            <a:endParaRPr lang="en-US" sz="1600" dirty="0"/>
-          </a:p>
-        </p:txBody>
-      </p:sp>
-      <p:sp>
-        <p:nvSpPr>
-          <p:cNvPr id="56" name="Text 54"/>
-          <p:cNvSpPr txBox="1"/>
-          <p:nvPr/>
-        </p:nvSpPr>
-        <p:spPr>
-          <a:xfrm>
-            <a:off x="9372600" y="1490472"/>
-            <a:ext cx="2270455" cy="365760"/>
-          </a:xfrm>
-          <a:prstGeom prst="rect">
-            <a:avLst/>
-          </a:prstGeom>
-          <a:noFill/>
-          <a:ln/>
-        </p:spPr>
-        <p:txBody>
-          <a:bodyPr wrap="square" lIns="0" tIns="0" rIns="0" bIns="0" rtlCol="0" anchor="t"/>
-          <a:lstStyle/>
-          <a:p>
-            <a:pPr indent="0" marL="0">
-              <a:buNone/>
-            </a:pPr>
-            <a:r>
-              <a:rPr lang="en-US" sz="1600" b="1" dirty="0">
-                <a:solidFill>
-                  <a:schemeClr val="tx1"/>
-                </a:solidFill>
-              </a:rPr>
-              <a:t>Risk lead with reasons</a:t>
-            </a:r>
-            <a:endParaRPr lang="en-US" sz="1600" dirty="0"/>
-          </a:p>
-        </p:txBody>
-      </p:sp>
-      <p:sp>
-        <p:nvSpPr>
-          <p:cNvPr id="57" name="Text 55"/>
-          <p:cNvSpPr txBox="1"/>
-          <p:nvPr/>
-        </p:nvSpPr>
-        <p:spPr>
-          <a:xfrm>
-            <a:off x="9372600" y="1874520"/>
-            <a:ext cx="2270455" cy="548640"/>
-          </a:xfrm>
-          <a:prstGeom prst="rect">
-            <a:avLst/>
-          </a:prstGeom>
-          <a:noFill/>
-          <a:ln/>
-        </p:spPr>
-        <p:txBody>
-          <a:bodyPr wrap="square" lIns="0" tIns="0" rIns="0" bIns="0" rtlCol="0" anchor="t"/>
-          <a:lstStyle/>
-          <a:p>
-            <a:pPr indent="0" marL="0">
-              <a:buNone/>
-            </a:pPr>
-            <a:r>
               <a:rPr lang="en-US" sz="1300" dirty="0">
                 <a:solidFill>
                   <a:schemeClr val="tx2"/>
                 </a:solidFill>
               </a:rPr>
-              <a:t>Explained score, never a verdict</a:t>
-            </a:r>
-            <a:endParaRPr lang="en-US" sz="1300" dirty="0"/>
-          </a:p>
-        </p:txBody>
-      </p:sp>
-      <p:sp>
-        <p:nvSpPr>
-          <p:cNvPr id="58" name="co1"/>
-          <p:cNvSpPr/>
-          <p:nvPr/>
-        </p:nvSpPr>
-        <p:spPr>
-          <a:xfrm>
-            <a:off x="8732520" y="2697480"/>
-            <a:ext cx="457200" cy="457200"/>
-          </a:xfrm>
-          <a:prstGeom prst="ellipse">
-            <a:avLst/>
-          </a:prstGeom>
-          <a:solidFill>
-            <a:schemeClr val="accent1"/>
-          </a:solidFill>
-          <a:ln w="12700">
-            <a:solidFill>
-              <a:schemeClr val="accent1"/>
-            </a:solidFill>
-            <a:prstDash val="solid"/>
-          </a:ln>
-        </p:spPr>
-      </p:sp>
-      <p:sp>
-        <p:nvSpPr>
-          <p:cNvPr id="59" name="Text 57"/>
-          <p:cNvSpPr txBox="1"/>
-          <p:nvPr/>
-        </p:nvSpPr>
-        <p:spPr>
-          <a:xfrm>
-            <a:off x="8732520" y="2697480"/>
-            <a:ext cx="457200" cy="457200"/>
-          </a:xfrm>
-          <a:prstGeom prst="rect">
-            <a:avLst/>
-          </a:prstGeom>
-          <a:noFill/>
-          <a:ln/>
-        </p:spPr>
-        <p:txBody>
-          <a:bodyPr wrap="square" lIns="0" tIns="0" rIns="0" bIns="0" rtlCol="0" anchor="ctr"/>
-          <a:lstStyle/>
-          <a:p>
-            <a:pPr algn="ctr" indent="0" marL="0">
-              <a:buNone/>
-            </a:pPr>
-            <a:r>
-              <a:rPr lang="en-US" sz="1600" b="1" dirty="0">
-                <a:solidFill>
-                  <a:schemeClr val="bg1"/>
-                </a:solidFill>
-              </a:rPr>
-              <a:t>2</a:t>
-            </a:r>
-            <a:endParaRPr lang="en-US" sz="1600" dirty="0"/>
-          </a:p>
-        </p:txBody>
-      </p:sp>
-      <p:sp>
-        <p:nvSpPr>
-          <p:cNvPr id="60" name="Text 58"/>
-          <p:cNvSpPr txBox="1"/>
-          <p:nvPr/>
-        </p:nvSpPr>
-        <p:spPr>
-          <a:xfrm>
-            <a:off x="9372600" y="2679192"/>
-            <a:ext cx="2270455" cy="365760"/>
-          </a:xfrm>
-          <a:prstGeom prst="rect">
-            <a:avLst/>
-          </a:prstGeom>
-          <a:noFill/>
-          <a:ln/>
-        </p:spPr>
-        <p:txBody>
-          <a:bodyPr wrap="square" lIns="0" tIns="0" rIns="0" bIns="0" rtlCol="0" anchor="t"/>
-          <a:lstStyle/>
-          <a:p>
-            <a:pPr indent="0" marL="0">
-              <a:buNone/>
-            </a:pPr>
-            <a:r>
-              <a:rPr lang="en-US" sz="1600" b="1" dirty="0">
-                <a:solidFill>
-                  <a:schemeClr val="tx1"/>
-                </a:solidFill>
-              </a:rPr>
-              <a:t>Path to the money</a:t>
-            </a:r>
-            <a:endParaRPr lang="en-US" sz="1600" dirty="0"/>
-          </a:p>
-        </p:txBody>
-      </p:sp>
-      <p:sp>
-        <p:nvSpPr>
-          <p:cNvPr id="61" name="Text 59"/>
-          <p:cNvSpPr txBox="1"/>
-          <p:nvPr/>
-        </p:nvSpPr>
-        <p:spPr>
-          <a:xfrm>
-            <a:off x="9372600" y="3063240"/>
-            <a:ext cx="2270455" cy="548640"/>
-          </a:xfrm>
-          <a:prstGeom prst="rect">
-            <a:avLst/>
-          </a:prstGeom>
-          <a:noFill/>
-          <a:ln/>
-        </p:spPr>
-        <p:txBody>
-          <a:bodyPr wrap="square" lIns="0" tIns="0" rIns="0" bIns="0" rtlCol="0" anchor="t"/>
-          <a:lstStyle/>
-          <a:p>
-            <a:pPr indent="0" marL="0">
-              <a:buNone/>
-            </a:pPr>
-            <a:r>
-              <a:rPr lang="en-US" sz="1300" dirty="0">
-                <a:solidFill>
-                  <a:schemeClr val="tx2"/>
-                </a:solidFill>
-              </a:rPr>
-              <a:t>Hops from the reported wallet to the exchange</a:t>
-            </a:r>
-            <a:endParaRPr lang="en-US" sz="1300" dirty="0"/>
-          </a:p>
-        </p:txBody>
-      </p:sp>
-      <p:sp>
-        <p:nvSpPr>
-          <p:cNvPr id="62" name="co2"/>
-          <p:cNvSpPr/>
-          <p:nvPr/>
-        </p:nvSpPr>
-        <p:spPr>
-          <a:xfrm>
-            <a:off x="8732520" y="3886200"/>
-            <a:ext cx="457200" cy="457200"/>
-          </a:xfrm>
-          <a:prstGeom prst="ellipse">
-            <a:avLst/>
-          </a:prstGeom>
-          <a:solidFill>
-            <a:schemeClr val="accent1"/>
-          </a:solidFill>
-          <a:ln w="12700">
-            <a:solidFill>
-              <a:schemeClr val="accent1"/>
-            </a:solidFill>
-            <a:prstDash val="solid"/>
-          </a:ln>
-        </p:spPr>
-      </p:sp>
-      <p:sp>
-        <p:nvSpPr>
-          <p:cNvPr id="63" name="Text 61"/>
-          <p:cNvSpPr txBox="1"/>
-          <p:nvPr/>
-        </p:nvSpPr>
-        <p:spPr>
-          <a:xfrm>
-            <a:off x="8732520" y="3886200"/>
-            <a:ext cx="457200" cy="457200"/>
-          </a:xfrm>
-          <a:prstGeom prst="rect">
-            <a:avLst/>
-          </a:prstGeom>
-          <a:noFill/>
-          <a:ln/>
-        </p:spPr>
-        <p:txBody>
-          <a:bodyPr wrap="square" lIns="0" tIns="0" rIns="0" bIns="0" rtlCol="0" anchor="ctr"/>
-          <a:lstStyle/>
-          <a:p>
-            <a:pPr algn="ctr" indent="0" marL="0">
-              <a:buNone/>
-            </a:pPr>
-            <a:r>
-              <a:rPr lang="en-US" sz="1600" b="1" dirty="0">
-                <a:solidFill>
-                  <a:schemeClr val="bg1"/>
-                </a:solidFill>
-              </a:rPr>
-              <a:t>3</a:t>
-            </a:r>
-            <a:endParaRPr lang="en-US" sz="1600" dirty="0"/>
-          </a:p>
-        </p:txBody>
-      </p:sp>
-      <p:sp>
-        <p:nvSpPr>
-          <p:cNvPr id="64" name="Text 62"/>
-          <p:cNvSpPr txBox="1"/>
-          <p:nvPr/>
-        </p:nvSpPr>
-        <p:spPr>
-          <a:xfrm>
-            <a:off x="9372600" y="3867912"/>
-            <a:ext cx="2270455" cy="365760"/>
-          </a:xfrm>
-          <a:prstGeom prst="rect">
-            <a:avLst/>
-          </a:prstGeom>
-          <a:noFill/>
-          <a:ln/>
-        </p:spPr>
-        <p:txBody>
-          <a:bodyPr wrap="square" lIns="0" tIns="0" rIns="0" bIns="0" rtlCol="0" anchor="t"/>
-          <a:lstStyle/>
-          <a:p>
-            <a:pPr indent="0" marL="0">
-              <a:buNone/>
-            </a:pPr>
-            <a:r>
-              <a:rPr lang="en-US" sz="1600" b="1" dirty="0">
-                <a:solidFill>
-                  <a:schemeClr val="tx1"/>
-                </a:solidFill>
-              </a:rPr>
-              <a:t>Who to contact</a:t>
-            </a:r>
-            <a:endParaRPr lang="en-US" sz="1600" dirty="0"/>
-          </a:p>
-        </p:txBody>
-      </p:sp>
-      <p:sp>
-        <p:nvSpPr>
-          <p:cNvPr id="65" name="Text 63"/>
-          <p:cNvSpPr txBox="1"/>
-          <p:nvPr/>
-        </p:nvSpPr>
-        <p:spPr>
-          <a:xfrm>
-            <a:off x="9372600" y="4251960"/>
-            <a:ext cx="2270455" cy="548640"/>
-          </a:xfrm>
-          <a:prstGeom prst="rect">
-            <a:avLst/>
-          </a:prstGeom>
-          <a:noFill/>
-          <a:ln/>
-        </p:spPr>
-        <p:txBody>
-          <a:bodyPr wrap="square" lIns="0" tIns="0" rIns="0" bIns="0" rtlCol="0" anchor="t"/>
-          <a:lstStyle/>
-          <a:p>
-            <a:pPr indent="0" marL="0">
-              <a:buNone/>
-            </a:pPr>
-            <a:r>
-              <a:rPr lang="en-US" sz="1300" dirty="0">
-                <a:solidFill>
-                  <a:schemeClr val="tx2"/>
-                </a:solidFill>
-              </a:rPr>
-              <a:t>Found by the TinyFish agent</a:t>
-            </a:r>
-            <a:endParaRPr lang="en-US" sz="1300" dirty="0"/>
-          </a:p>
-        </p:txBody>
-      </p:sp>
-      <p:sp>
-        <p:nvSpPr>
-          <p:cNvPr id="66" name="co3"/>
-          <p:cNvSpPr/>
-          <p:nvPr/>
-        </p:nvSpPr>
-        <p:spPr>
-          <a:xfrm>
-            <a:off x="8732520" y="5074920"/>
-            <a:ext cx="457200" cy="457200"/>
-          </a:xfrm>
-          <a:prstGeom prst="ellipse">
-            <a:avLst/>
-          </a:prstGeom>
-          <a:solidFill>
-            <a:schemeClr val="accent1"/>
-          </a:solidFill>
-          <a:ln w="12700">
-            <a:solidFill>
-              <a:schemeClr val="accent1"/>
-            </a:solidFill>
-            <a:prstDash val="solid"/>
-          </a:ln>
-        </p:spPr>
-      </p:sp>
-      <p:sp>
-        <p:nvSpPr>
-          <p:cNvPr id="67" name="Text 65"/>
-          <p:cNvSpPr txBox="1"/>
-          <p:nvPr/>
-        </p:nvSpPr>
-        <p:spPr>
-          <a:xfrm>
-            <a:off x="8732520" y="5074920"/>
-            <a:ext cx="457200" cy="457200"/>
-          </a:xfrm>
-          <a:prstGeom prst="rect">
-            <a:avLst/>
-          </a:prstGeom>
-          <a:noFill/>
-          <a:ln/>
-        </p:spPr>
-        <p:txBody>
-          <a:bodyPr wrap="square" lIns="0" tIns="0" rIns="0" bIns="0" rtlCol="0" anchor="ctr"/>
-          <a:lstStyle/>
-          <a:p>
-            <a:pPr algn="ctr" indent="0" marL="0">
-              <a:buNone/>
-            </a:pPr>
-            <a:r>
-              <a:rPr lang="en-US" sz="1600" b="1" dirty="0">
-                <a:solidFill>
-                  <a:schemeClr val="bg1"/>
-                </a:solidFill>
-              </a:rPr>
-              <a:t>4</a:t>
-            </a:r>
-            <a:endParaRPr lang="en-US" sz="1600" dirty="0"/>
-          </a:p>
-        </p:txBody>
-      </p:sp>
-      <p:sp>
-        <p:nvSpPr>
-          <p:cNvPr id="68" name="Text 66"/>
-          <p:cNvSpPr txBox="1"/>
-          <p:nvPr/>
-        </p:nvSpPr>
-        <p:spPr>
-          <a:xfrm>
-            <a:off x="9372600" y="5056632"/>
-            <a:ext cx="2270455" cy="365760"/>
-          </a:xfrm>
-          <a:prstGeom prst="rect">
-            <a:avLst/>
-          </a:prstGeom>
-          <a:noFill/>
-          <a:ln/>
-        </p:spPr>
-        <p:txBody>
-          <a:bodyPr wrap="square" lIns="0" tIns="0" rIns="0" bIns="0" rtlCol="0" anchor="t"/>
-          <a:lstStyle/>
-          <a:p>
-            <a:pPr indent="0" marL="0">
-              <a:buNone/>
-            </a:pPr>
-            <a:r>
-              <a:rPr lang="en-US" sz="1600" b="1" dirty="0">
-                <a:solidFill>
-                  <a:schemeClr val="tx1"/>
-                </a:solidFill>
-              </a:rPr>
-              <a:t>Proof for the case</a:t>
-            </a:r>
-            <a:endParaRPr lang="en-US" sz="1600" dirty="0"/>
-          </a:p>
-        </p:txBody>
-      </p:sp>
-      <p:sp>
-        <p:nvSpPr>
-          <p:cNvPr id="69" name="Text 67"/>
-          <p:cNvSpPr txBox="1"/>
-          <p:nvPr/>
-        </p:nvSpPr>
-        <p:spPr>
-          <a:xfrm>
-            <a:off x="9372600" y="5440680"/>
-            <a:ext cx="2270455" cy="548640"/>
-          </a:xfrm>
-          <a:prstGeom prst="rect">
-            <a:avLst/>
-          </a:prstGeom>
-          <a:noFill/>
-          <a:ln/>
-        </p:spPr>
-        <p:txBody>
-          <a:bodyPr wrap="square" lIns="0" tIns="0" rIns="0" bIns="0" rtlCol="0" anchor="t"/>
-          <a:lstStyle/>
-          <a:p>
-            <a:pPr indent="0" marL="0">
-              <a:buNone/>
-            </a:pPr>
-            <a:r>
-              <a:rPr lang="en-US" sz="1300" dirty="0">
-                <a:solidFill>
-                  <a:schemeClr val="tx2"/>
-                </a:solidFill>
-              </a:rPr>
-              <a:t>Timestamped, hashed page snapshots</a:t>
+              <a:t>Source URLs, retrieval times, hashes</a:t>
             </a:r>
             <a:endParaRPr lang="en-US" sz="1300" dirty="0"/>
           </a:p>

</xml_diff>

<commit_message>
Deck: new title line, team expertise on slide 1, stronger sample labels on prototype slide
Co-Authored-By: Claude Opus 5.5 <noreply@anthropic.com>
Claude-Session: https://claude.ai/code/session_01RiioRpvzPREAo253VWx5eZ
</commit_message>
<xml_diff>
--- a/docs/pitch/ChainSight_Round1_9slides.pptx
+++ b/docs/pitch/ChainSight_Round1_9slides.pptx
@@ -115,43 +115,43 @@
   <p:extLst>
     <p:ext uri="{521415D9-36F7-43E2-AB2F-B90AF26B5E84}">
       <p14:sectionLst xmlns:p14="http://schemas.microsoft.com/office/powerpoint/2010/main">
-        <p14:section name="Team Details" id="{455f73c0-a68d-0d5e-983b-b805d4efc2d3}">
+        <p14:section name="Team Details" id="{2533f81c-ac1c-f298-4185-85b772a3aace}">
           <p14:sldIdLst>
             <p14:sldId id="256"/>
           </p14:sldIdLst>
         </p14:section>
-        <p14:section name="Problem" id="{7b6ec578-3b7e-0c3f-1593-f9915ccf63df}">
+        <p14:section name="Problem" id="{0ce983b5-1662-539d-3cfe-1ccb2e9a20cd}">
           <p14:sldIdLst>
             <p14:sldId id="257"/>
           </p14:sldIdLst>
         </p14:section>
-        <p14:section name="Solution" id="{c54650f8-a67d-8ce5-1b0c-0859751311e5}">
+        <p14:section name="Solution" id="{1f3b1db0-ba7d-8f6f-b2df-1f6100514c42}">
           <p14:sldIdLst>
             <p14:sldId id="258"/>
           </p14:sldIdLst>
         </p14:section>
-        <p14:section name="Users" id="{25f23637-ea91-2591-87d2-9ee536bc8941}">
+        <p14:section name="Users" id="{cd91ef24-dac8-529d-41ab-347c8c5eee22}">
           <p14:sldIdLst>
             <p14:sldId id="259"/>
           </p14:sldIdLst>
         </p14:section>
-        <p14:section name="Architecture" id="{165dc66f-9d2b-a85c-4b56-b4b5954079be}">
+        <p14:section name="Architecture" id="{aadbf60c-982c-f9c9-e310-0657b75ffb5a}">
           <p14:sldIdLst>
             <p14:sldId id="260"/>
           </p14:sldIdLst>
         </p14:section>
-        <p14:section name="TinyFish" id="{fd0c91b5-2842-991d-9c34-8e60e86d56c1}">
+        <p14:section name="TinyFish" id="{d34ea300-f261-c071-6337-fa32691b1a2d}">
           <p14:sldIdLst>
             <p14:sldId id="261"/>
           </p14:sldIdLst>
         </p14:section>
-        <p14:section name="Scale" id="{904f9064-2c35-d53b-cf90-f651fe8bd853}">
+        <p14:section name="Scale" id="{f79befba-6ef0-3df3-738f-d75f56be0532}">
           <p14:sldIdLst>
             <p14:sldId id="262"/>
             <p14:sldId id="263"/>
           </p14:sldIdLst>
         </p14:section>
-        <p14:section name="Prototype" id="{17ad1eea-f221-7290-8b3f-81d676d9e01b}">
+        <p14:section name="Prototype" id="{92588646-8c6d-ba22-0099-1fbd81393e87}">
           <p14:sldIdLst>
             <p14:sldId id="264"/>
           </p14:sldIdLst>
@@ -1370,8 +1370,8 @@
         </p:nvSpPr>
         <p:spPr>
           <a:xfrm>
-            <a:off x="548640" y="1600200"/>
-            <a:ext cx="6766560" cy="1097280"/>
+            <a:off x="548640" y="685800"/>
+            <a:ext cx="6766560" cy="868680"/>
           </a:xfrm>
           <a:prstGeom prst="rect">
             <a:avLst/>
@@ -1384,7 +1384,7 @@
           <a:lstStyle>
             <a:lvl1pPr algn="l" indent="0" marL="0">
               <a:buNone/>
-              <a:defRPr lang="en-US" sz="6000" b="1" dirty="0">
+              <a:defRPr lang="en-US" sz="5400" b="1" dirty="0">
                 <a:solidFill>
                   <a:schemeClr val="bg1"/>
                 </a:solidFill>
@@ -1398,7 +1398,7 @@
             <a:pPr algn="l" indent="0" marL="0">
               <a:buNone/>
             </a:pPr>
-            <a:endParaRPr lang="en-US" sz="6000" dirty="0"/>
+            <a:endParaRPr lang="en-US" sz="5400" dirty="0"/>
           </a:p>
         </p:txBody>
       </p:sp>
@@ -1412,8 +1412,8 @@
         </p:nvSpPr>
         <p:spPr>
           <a:xfrm>
-            <a:off x="548640" y="2788920"/>
-            <a:ext cx="6583680" cy="822960"/>
+            <a:off x="548640" y="1993392"/>
+            <a:ext cx="7498080" cy="640080"/>
           </a:xfrm>
           <a:prstGeom prst="rect">
             <a:avLst/>
@@ -1426,7 +1426,7 @@
           <a:lstStyle>
             <a:lvl1pPr algn="l" indent="0" marL="0">
               <a:buNone/>
-              <a:defRPr lang="en-US" sz="2200" dirty="0">
+              <a:defRPr lang="en-US" sz="1700" dirty="0">
                 <a:solidFill>
                   <a:schemeClr val="bg2"/>
                 </a:solidFill>
@@ -1437,7 +1437,7 @@
             <a:pPr algn="l" indent="0" marL="0">
               <a:buNone/>
             </a:pPr>
-            <a:endParaRPr lang="en-US" sz="2200" dirty="0"/>
+            <a:endParaRPr lang="en-US" sz="1700" dirty="0"/>
           </a:p>
         </p:txBody>
       </p:sp>
@@ -1953,8 +1953,8 @@
         </p:nvSpPr>
         <p:spPr>
           <a:xfrm>
-            <a:off x="548640" y="502920"/>
-            <a:ext cx="3657600" cy="320040"/>
+            <a:off x="548640" y="365760"/>
+            <a:ext cx="3657600" cy="274320"/>
           </a:xfrm>
           <a:prstGeom prst="rect">
             <a:avLst/>
@@ -1970,14 +1970,14 @@
               <a:buNone/>
             </a:pPr>
             <a:r>
-              <a:rPr lang="en-US" sz="1400" b="1" spc="200" kern="0" dirty="0">
+              <a:rPr lang="en-US" sz="1300" b="1" spc="200" kern="0" dirty="0">
                 <a:solidFill>
                   <a:schemeClr val="accent1"/>
                 </a:solidFill>
               </a:rPr>
               <a:t>TEAM DETAILS</a:t>
             </a:r>
-            <a:endParaRPr lang="en-US" sz="1400" dirty="0"/>
+            <a:endParaRPr lang="en-US" sz="1300" dirty="0"/>
           </a:p>
         </p:txBody>
       </p:sp>
@@ -1991,8 +1991,8 @@
         </p:nvSpPr>
         <p:spPr>
           <a:xfrm>
-            <a:off x="548640" y="1600200"/>
-            <a:ext cx="6766560" cy="1097280"/>
+            <a:off x="548640" y="685800"/>
+            <a:ext cx="6766560" cy="868680"/>
           </a:xfrm>
           <a:prstGeom prst="rect">
             <a:avLst/>
@@ -2008,7 +2008,7 @@
               <a:buNone/>
             </a:pPr>
             <a:r>
-              <a:rPr lang="en-US" sz="6000" b="1" dirty="0">
+              <a:rPr lang="en-US" sz="5400" b="1" dirty="0">
                 <a:solidFill>
                   <a:schemeClr val="bg1"/>
                 </a:solidFill>
@@ -2018,13 +2018,49 @@
               </a:rPr>
               <a:t>ChainSight</a:t>
             </a:r>
-            <a:endParaRPr lang="en-US" sz="6000" dirty="0"/>
-          </a:p>
-        </p:txBody>
-      </p:sp>
-      <p:sp>
-        <p:nvSpPr>
-          <p:cNvPr id="4" name="Text 0"/>
+            <a:endParaRPr lang="en-US" sz="5400" dirty="0"/>
+          </a:p>
+        </p:txBody>
+      </p:sp>
+      <p:sp>
+        <p:nvSpPr>
+          <p:cNvPr id="4" name="Text 2"/>
+          <p:cNvSpPr txBox="1"/>
+          <p:nvPr/>
+        </p:nvSpPr>
+        <p:spPr>
+          <a:xfrm>
+            <a:off x="548640" y="1536192"/>
+            <a:ext cx="7498080" cy="411480"/>
+          </a:xfrm>
+          <a:prstGeom prst="rect">
+            <a:avLst/>
+          </a:prstGeom>
+          <a:noFill/>
+          <a:ln/>
+        </p:spPr>
+        <p:txBody>
+          <a:bodyPr wrap="square" lIns="0" tIns="0" rIns="0" bIns="0" rtlCol="0" anchor="t"/>
+          <a:lstStyle/>
+          <a:p>
+            <a:pPr indent="0" marL="0">
+              <a:buNone/>
+            </a:pPr>
+            <a:r>
+              <a:rPr lang="en-US" sz="2200" b="1" dirty="0">
+                <a:solidFill>
+                  <a:schemeClr val="accent1"/>
+                </a:solidFill>
+              </a:rPr>
+              <a:t>Crypto Fraud Investigation Intelligence</a:t>
+            </a:r>
+            <a:endParaRPr lang="en-US" sz="2200" dirty="0"/>
+          </a:p>
+        </p:txBody>
+      </p:sp>
+      <p:sp>
+        <p:nvSpPr>
+          <p:cNvPr id="5" name="Text 0"/>
           <p:cNvSpPr/>
           <p:nvPr>
             <p:ph idx="101" type="body" hasCustomPrompt="1"/>
@@ -2032,8 +2068,8 @@
         </p:nvSpPr>
         <p:spPr>
           <a:xfrm>
-            <a:off x="548640" y="2788920"/>
-            <a:ext cx="6583680" cy="822960"/>
+            <a:off x="548640" y="1993392"/>
+            <a:ext cx="7498080" cy="640080"/>
           </a:xfrm>
           <a:prstGeom prst="rect">
             <a:avLst/>
@@ -2049,27 +2085,27 @@
               <a:buNone/>
             </a:pPr>
             <a:r>
-              <a:rPr lang="en-US" sz="2200" dirty="0">
+              <a:rPr lang="en-US" sz="1700" dirty="0">
                 <a:solidFill>
                   <a:schemeClr val="bg2"/>
                 </a:solidFill>
               </a:rPr>
-              <a:t>Confidence-rated fund-flow leads to likely exchange-associated addresses, for investigator verification</a:t>
-            </a:r>
-            <a:endParaRPr lang="en-US" sz="2200" dirty="0"/>
-          </a:p>
-        </p:txBody>
-      </p:sp>
-      <p:sp>
-        <p:nvSpPr>
-          <p:cNvPr id="5" name="t-edge0"/>
-          <p:cNvSpPr/>
-          <p:nvPr/>
-        </p:nvSpPr>
-        <p:spPr>
-          <a:xfrm>
-            <a:off x="8641080" y="1051560"/>
-            <a:ext cx="1005840" cy="548640"/>
+              <a:t>From a reported wallet to traceable fund flows, likely exchange links and source-backed evidence.</a:t>
+            </a:r>
+            <a:endParaRPr lang="en-US" sz="1700" dirty="0"/>
+          </a:p>
+        </p:txBody>
+      </p:sp>
+      <p:sp>
+        <p:nvSpPr>
+          <p:cNvPr id="6" name="t-edge0"/>
+          <p:cNvSpPr/>
+          <p:nvPr/>
+        </p:nvSpPr>
+        <p:spPr>
+          <a:xfrm>
+            <a:off x="8906256" y="630936"/>
+            <a:ext cx="914400" cy="457200"/>
           </a:xfrm>
           <a:prstGeom prst="line">
             <a:avLst/>
@@ -2085,14 +2121,14 @@
       </p:sp>
       <p:sp>
         <p:nvSpPr>
-          <p:cNvPr id="6" name="t-edge1"/>
+          <p:cNvPr id="7" name="t-edge1"/>
           <p:cNvSpPr/>
           <p:nvPr/>
         </p:nvSpPr>
         <p:spPr>
           <a:xfrm flipH="1">
-            <a:off x="9098280" y="1600200"/>
-            <a:ext cx="548640" cy="822960"/>
+            <a:off x="9363456" y="1088136"/>
+            <a:ext cx="457200" cy="731520"/>
           </a:xfrm>
           <a:prstGeom prst="line">
             <a:avLst/>
@@ -2108,14 +2144,14 @@
       </p:sp>
       <p:sp>
         <p:nvSpPr>
-          <p:cNvPr id="7" name="t-edge2"/>
-          <p:cNvSpPr/>
-          <p:nvPr/>
-        </p:nvSpPr>
-        <p:spPr>
-          <a:xfrm>
-            <a:off x="9098280" y="2423160"/>
-            <a:ext cx="1188720" cy="365760"/>
+          <p:cNvPr id="8" name="t-edge2"/>
+          <p:cNvSpPr/>
+          <p:nvPr/>
+        </p:nvSpPr>
+        <p:spPr>
+          <a:xfrm>
+            <a:off x="9363456" y="1819656"/>
+            <a:ext cx="1097280" cy="320040"/>
           </a:xfrm>
           <a:prstGeom prst="line">
             <a:avLst/>
@@ -2131,14 +2167,14 @@
       </p:sp>
       <p:sp>
         <p:nvSpPr>
-          <p:cNvPr id="8" name="t-edge3"/>
+          <p:cNvPr id="9" name="t-edge3"/>
           <p:cNvSpPr/>
           <p:nvPr/>
         </p:nvSpPr>
         <p:spPr>
           <a:xfrm flipH="1">
-            <a:off x="10287000" y="1965960"/>
-            <a:ext cx="822960" cy="822960"/>
+            <a:off x="10460736" y="1408176"/>
+            <a:ext cx="822960" cy="731520"/>
           </a:xfrm>
           <a:prstGeom prst="line">
             <a:avLst/>
@@ -2154,14 +2190,14 @@
       </p:sp>
       <p:sp>
         <p:nvSpPr>
-          <p:cNvPr id="9" name="t-node0"/>
-          <p:cNvSpPr/>
-          <p:nvPr/>
-        </p:nvSpPr>
-        <p:spPr>
-          <a:xfrm>
-            <a:off x="8503920" y="914400"/>
-            <a:ext cx="292608" cy="292608"/>
+          <p:cNvPr id="10" name="t-node0"/>
+          <p:cNvSpPr/>
+          <p:nvPr/>
+        </p:nvSpPr>
+        <p:spPr>
+          <a:xfrm>
+            <a:off x="8778240" y="502920"/>
+            <a:ext cx="256032" cy="256032"/>
           </a:xfrm>
           <a:prstGeom prst="ellipse">
             <a:avLst/>
@@ -2179,14 +2215,14 @@
       </p:sp>
       <p:sp>
         <p:nvSpPr>
-          <p:cNvPr id="10" name="t-node1"/>
-          <p:cNvSpPr/>
-          <p:nvPr/>
-        </p:nvSpPr>
-        <p:spPr>
-          <a:xfrm>
-            <a:off x="9509760" y="1463040"/>
-            <a:ext cx="292608" cy="292608"/>
+          <p:cNvPr id="11" name="t-node1"/>
+          <p:cNvSpPr/>
+          <p:nvPr/>
+        </p:nvSpPr>
+        <p:spPr>
+          <a:xfrm>
+            <a:off x="9692640" y="960120"/>
+            <a:ext cx="256032" cy="256032"/>
           </a:xfrm>
           <a:prstGeom prst="ellipse">
             <a:avLst/>
@@ -2204,14 +2240,14 @@
       </p:sp>
       <p:sp>
         <p:nvSpPr>
-          <p:cNvPr id="11" name="t-node2"/>
-          <p:cNvSpPr/>
-          <p:nvPr/>
-        </p:nvSpPr>
-        <p:spPr>
-          <a:xfrm>
-            <a:off x="8961120" y="2286000"/>
-            <a:ext cx="292608" cy="292608"/>
+          <p:cNvPr id="12" name="t-node2"/>
+          <p:cNvSpPr/>
+          <p:nvPr/>
+        </p:nvSpPr>
+        <p:spPr>
+          <a:xfrm>
+            <a:off x="9235440" y="1691640"/>
+            <a:ext cx="256032" cy="256032"/>
           </a:xfrm>
           <a:prstGeom prst="ellipse">
             <a:avLst/>
@@ -2229,14 +2265,14 @@
       </p:sp>
       <p:sp>
         <p:nvSpPr>
-          <p:cNvPr id="12" name="t-node3"/>
-          <p:cNvSpPr/>
-          <p:nvPr/>
-        </p:nvSpPr>
-        <p:spPr>
-          <a:xfrm>
-            <a:off x="10149840" y="2651760"/>
-            <a:ext cx="292608" cy="292608"/>
+          <p:cNvPr id="13" name="t-node3"/>
+          <p:cNvSpPr/>
+          <p:nvPr/>
+        </p:nvSpPr>
+        <p:spPr>
+          <a:xfrm>
+            <a:off x="10332720" y="2011680"/>
+            <a:ext cx="256032" cy="256032"/>
           </a:xfrm>
           <a:prstGeom prst="ellipse">
             <a:avLst/>
@@ -2254,18 +2290,18 @@
       </p:sp>
       <p:sp>
         <p:nvSpPr>
-          <p:cNvPr id="13" name="t-node4"/>
-          <p:cNvSpPr/>
-          <p:nvPr/>
-        </p:nvSpPr>
-        <p:spPr>
-          <a:xfrm>
-            <a:off x="10972800" y="1828800"/>
-            <a:ext cx="292608" cy="292608"/>
+          <p:cNvPr id="14" name="t-node4"/>
+          <p:cNvSpPr/>
+          <p:nvPr/>
+        </p:nvSpPr>
+        <p:spPr>
+          <a:xfrm>
+            <a:off x="11155680" y="1280160"/>
+            <a:ext cx="256032" cy="256032"/>
           </a:xfrm>
           <a:prstGeom prst="roundRect">
             <a:avLst>
-              <a:gd name="adj" fmla="val 18750"/>
+              <a:gd name="adj" fmla="val 21429"/>
             </a:avLst>
           </a:prstGeom>
           <a:solidFill>
@@ -2281,90 +2317,18 @@
       </p:sp>
       <p:sp>
         <p:nvSpPr>
-          <p:cNvPr id="14" name="Text 12"/>
-          <p:cNvSpPr txBox="1"/>
-          <p:nvPr/>
-        </p:nvSpPr>
-        <p:spPr>
-          <a:xfrm>
-            <a:off x="7589520" y="566928"/>
-            <a:ext cx="1463040" cy="274320"/>
-          </a:xfrm>
-          <a:prstGeom prst="rect">
-            <a:avLst/>
-          </a:prstGeom>
-          <a:noFill/>
-          <a:ln/>
-        </p:spPr>
-        <p:txBody>
-          <a:bodyPr wrap="square" lIns="0" tIns="0" rIns="0" bIns="0" rtlCol="0" anchor="t"/>
-          <a:lstStyle/>
-          <a:p>
-            <a:pPr indent="0" marL="0">
-              <a:buNone/>
-            </a:pPr>
-            <a:r>
-              <a:rPr lang="en-US" sz="1200" dirty="0">
-                <a:solidFill>
-                  <a:schemeClr val="bg2"/>
-                </a:solidFill>
-              </a:rPr>
-              <a:t>scam wallet</a:t>
-            </a:r>
-            <a:endParaRPr lang="en-US" sz="1200" dirty="0"/>
-          </a:p>
-        </p:txBody>
-      </p:sp>
-      <p:sp>
-        <p:nvSpPr>
-          <p:cNvPr id="15" name="Text 13"/>
-          <p:cNvSpPr txBox="1"/>
-          <p:nvPr/>
-        </p:nvSpPr>
-        <p:spPr>
-          <a:xfrm>
-            <a:off x="10972800" y="2212848"/>
-            <a:ext cx="1097280" cy="274320"/>
-          </a:xfrm>
-          <a:prstGeom prst="rect">
-            <a:avLst/>
-          </a:prstGeom>
-          <a:noFill/>
-          <a:ln/>
-        </p:spPr>
-        <p:txBody>
-          <a:bodyPr wrap="square" lIns="0" tIns="0" rIns="0" bIns="0" rtlCol="0" anchor="t"/>
-          <a:lstStyle/>
-          <a:p>
-            <a:pPr indent="0" marL="0">
-              <a:buNone/>
-            </a:pPr>
-            <a:r>
-              <a:rPr lang="en-US" sz="1200" dirty="0">
-                <a:solidFill>
-                  <a:schemeClr val="bg2"/>
-                </a:solidFill>
-              </a:rPr>
-              <a:t>exchange</a:t>
-            </a:r>
-            <a:endParaRPr lang="en-US" sz="1200" dirty="0"/>
-          </a:p>
-        </p:txBody>
-      </p:sp>
-      <p:sp>
-        <p:nvSpPr>
-          <p:cNvPr id="16" name="ps-card"/>
-          <p:cNvSpPr/>
-          <p:nvPr/>
-        </p:nvSpPr>
-        <p:spPr>
-          <a:xfrm>
-            <a:off x="548640" y="3886200"/>
-            <a:ext cx="6949440" cy="2194560"/>
+          <p:cNvPr id="15" name="ps-card"/>
+          <p:cNvSpPr/>
+          <p:nvPr/>
+        </p:nvSpPr>
+        <p:spPr>
+          <a:xfrm>
+            <a:off x="548640" y="2788920"/>
+            <a:ext cx="11094415" cy="1234440"/>
           </a:xfrm>
           <a:prstGeom prst="roundRect">
             <a:avLst>
-              <a:gd name="adj" fmla="val 3333"/>
+              <a:gd name="adj" fmla="val 5926"/>
             </a:avLst>
           </a:prstGeom>
           <a:solidFill>
@@ -2380,14 +2344,50 @@
       </p:sp>
       <p:sp>
         <p:nvSpPr>
+          <p:cNvPr id="16" name="Text 14"/>
+          <p:cNvSpPr txBox="1"/>
+          <p:nvPr/>
+        </p:nvSpPr>
+        <p:spPr>
+          <a:xfrm>
+            <a:off x="822960" y="2898648"/>
+            <a:ext cx="4572000" cy="256032"/>
+          </a:xfrm>
+          <a:prstGeom prst="rect">
+            <a:avLst/>
+          </a:prstGeom>
+          <a:noFill/>
+          <a:ln/>
+        </p:spPr>
+        <p:txBody>
+          <a:bodyPr wrap="square" lIns="0" tIns="0" rIns="0" bIns="0" rtlCol="0" anchor="t"/>
+          <a:lstStyle/>
+          <a:p>
+            <a:pPr indent="0" marL="0">
+              <a:buNone/>
+            </a:pPr>
+            <a:r>
+              <a:rPr lang="en-US" sz="1100" b="1" spc="200" kern="0" dirty="0">
+                <a:solidFill>
+                  <a:schemeClr val="accent1"/>
+                </a:solidFill>
+              </a:rPr>
+              <a:t>PROBLEM STATEMENT</a:t>
+            </a:r>
+            <a:endParaRPr lang="en-US" sz="1100" dirty="0"/>
+          </a:p>
+        </p:txBody>
+      </p:sp>
+      <p:sp>
+        <p:nvSpPr>
           <p:cNvPr id="17" name="Text 15"/>
           <p:cNvSpPr txBox="1"/>
           <p:nvPr/>
         </p:nvSpPr>
         <p:spPr>
           <a:xfrm>
-            <a:off x="822960" y="4069080"/>
-            <a:ext cx="4572000" cy="274320"/>
+            <a:off x="822960" y="3172968"/>
+            <a:ext cx="7406640" cy="731520"/>
           </a:xfrm>
           <a:prstGeom prst="rect">
             <a:avLst/>
@@ -2403,27 +2403,99 @@
               <a:buNone/>
             </a:pPr>
             <a:r>
-              <a:rPr lang="en-US" sz="1200" b="1" spc="200" kern="0" dirty="0">
+              <a:rPr lang="en-US" sz="1400" b="1" dirty="0">
+                <a:solidFill>
+                  <a:schemeClr val="bg1"/>
+                </a:solidFill>
+              </a:rPr>
+              <a:t>Real-Time Identification of Fraud-Linked Cryptocurrency Exchanges from Victim-Reported Suspect Wallet Addresses through Automated Blockchain Analytics</a:t>
+            </a:r>
+            <a:endParaRPr lang="en-US" sz="1400" dirty="0"/>
+          </a:p>
+        </p:txBody>
+      </p:sp>
+      <p:sp>
+        <p:nvSpPr>
+          <p:cNvPr id="18" name="Text 16"/>
+          <p:cNvSpPr txBox="1"/>
+          <p:nvPr/>
+        </p:nvSpPr>
+        <p:spPr>
+          <a:xfrm>
+            <a:off x="8641080" y="3172968"/>
+            <a:ext cx="2926080" cy="731520"/>
+          </a:xfrm>
+          <a:prstGeom prst="rect">
+            <a:avLst/>
+          </a:prstGeom>
+          <a:noFill/>
+          <a:ln/>
+        </p:spPr>
+        <p:txBody>
+          <a:bodyPr wrap="square" lIns="0" tIns="0" rIns="0" bIns="0" rtlCol="0" anchor="ctr"/>
+          <a:lstStyle/>
+          <a:p>
+            <a:pPr indent="0" marL="0">
+              <a:buNone/>
+            </a:pPr>
+            <a:r>
+              <a:rPr lang="en-US" sz="1400" b="1" dirty="0">
                 <a:solidFill>
                   <a:schemeClr val="accent1"/>
                 </a:solidFill>
               </a:rPr>
-              <a:t>PROBLEM STATEMENT</a:t>
-            </a:r>
-            <a:endParaRPr lang="en-US" sz="1200" dirty="0"/>
-          </a:p>
-        </p:txBody>
-      </p:sp>
-      <p:sp>
-        <p:nvSpPr>
-          <p:cNvPr id="18" name="Text 16"/>
-          <p:cNvSpPr txBox="1"/>
-          <p:nvPr/>
-        </p:nvSpPr>
-        <p:spPr>
-          <a:xfrm>
-            <a:off x="822960" y="4434840"/>
-            <a:ext cx="6400800" cy="1005840"/>
+              <a:t>Theme: </a:t>
+            </a:r>
+            <a:pPr indent="0" marL="0">
+              <a:buNone/>
+            </a:pPr>
+            <a:r>
+              <a:rPr lang="en-US" sz="1400" dirty="0">
+                <a:solidFill>
+                  <a:schemeClr val="bg1"/>
+                </a:solidFill>
+              </a:rPr>
+              <a:t>Blockchain &amp; Cybersecurity</a:t>
+            </a:r>
+            <a:endParaRPr lang="en-US" sz="1400" dirty="0"/>
+          </a:p>
+          <a:p>
+            <a:pPr indent="0" marL="0">
+              <a:buNone/>
+            </a:pPr>
+            <a:r>
+              <a:rPr lang="en-US" sz="1400" b="1" dirty="0">
+                <a:solidFill>
+                  <a:schemeClr val="accent1"/>
+                </a:solidFill>
+              </a:rPr>
+              <a:t>Category: </a:t>
+            </a:r>
+            <a:pPr indent="0" marL="0">
+              <a:buNone/>
+            </a:pPr>
+            <a:r>
+              <a:rPr lang="en-US" sz="1400" dirty="0">
+                <a:solidFill>
+                  <a:schemeClr val="bg1"/>
+                </a:solidFill>
+              </a:rPr>
+              <a:t>Software</a:t>
+            </a:r>
+            <a:endParaRPr lang="en-US" sz="1400" dirty="0"/>
+          </a:p>
+        </p:txBody>
+      </p:sp>
+      <p:sp>
+        <p:nvSpPr>
+          <p:cNvPr id="19" name="Text 17"/>
+          <p:cNvSpPr txBox="1"/>
+          <p:nvPr/>
+        </p:nvSpPr>
+        <p:spPr>
+          <a:xfrm>
+            <a:off x="548640" y="4206240"/>
+            <a:ext cx="3657600" cy="256032"/>
           </a:xfrm>
           <a:prstGeom prst="rect">
             <a:avLst/>
@@ -2439,136 +2511,31 @@
               <a:buNone/>
             </a:pPr>
             <a:r>
-              <a:rPr lang="en-US" sz="1600" b="1" dirty="0">
-                <a:solidFill>
-                  <a:schemeClr val="bg1"/>
-                </a:solidFill>
-              </a:rPr>
-              <a:t>Real-Time Identification of Fraud-Linked Cryptocurrency Exchanges from Victim-Reported Suspect Wallet Addresses through Automated Blockchain Analytics</a:t>
-            </a:r>
-            <a:endParaRPr lang="en-US" sz="1600" dirty="0"/>
-          </a:p>
-        </p:txBody>
-      </p:sp>
-      <p:sp>
-        <p:nvSpPr>
-          <p:cNvPr id="19" name="Text 17"/>
-          <p:cNvSpPr txBox="1"/>
-          <p:nvPr/>
-        </p:nvSpPr>
-        <p:spPr>
-          <a:xfrm>
-            <a:off x="822960" y="5532120"/>
-            <a:ext cx="6400800" cy="365760"/>
-          </a:xfrm>
-          <a:prstGeom prst="rect">
-            <a:avLst/>
-          </a:prstGeom>
-          <a:noFill/>
-          <a:ln/>
-        </p:spPr>
-        <p:txBody>
-          <a:bodyPr wrap="square" lIns="0" tIns="0" rIns="0" bIns="0" rtlCol="0" anchor="t"/>
-          <a:lstStyle/>
-          <a:p>
-            <a:pPr indent="0" marL="0">
-              <a:buNone/>
-            </a:pPr>
-            <a:r>
-              <a:rPr lang="en-US" sz="1400" b="1" dirty="0">
+              <a:rPr lang="en-US" sz="1100" b="1" spc="200" kern="0" dirty="0">
                 <a:solidFill>
                   <a:schemeClr val="accent1"/>
                 </a:solidFill>
               </a:rPr>
-              <a:t>Theme: </a:t>
-            </a:r>
-            <a:pPr indent="0" marL="0">
-              <a:buNone/>
-            </a:pPr>
-            <a:r>
-              <a:rPr lang="en-US" sz="1400" dirty="0">
-                <a:solidFill>
-                  <a:schemeClr val="bg1"/>
-                </a:solidFill>
-              </a:rPr>
-              <a:t>Blockchain &amp; Cybersecurity      </a:t>
-            </a:r>
-            <a:pPr indent="0" marL="0">
-              <a:buNone/>
-            </a:pPr>
-            <a:r>
-              <a:rPr lang="en-US" sz="1400" b="1" dirty="0">
-                <a:solidFill>
-                  <a:schemeClr val="accent1"/>
-                </a:solidFill>
-              </a:rPr>
-              <a:t>Category: </a:t>
-            </a:r>
-            <a:pPr indent="0" marL="0">
-              <a:buNone/>
-            </a:pPr>
-            <a:r>
-              <a:rPr lang="en-US" sz="1400" dirty="0">
-                <a:solidFill>
-                  <a:schemeClr val="bg1"/>
-                </a:solidFill>
-              </a:rPr>
-              <a:t>Software</a:t>
-            </a:r>
-            <a:endParaRPr lang="en-US" sz="1400" dirty="0"/>
-          </a:p>
-        </p:txBody>
-      </p:sp>
-      <p:sp>
-        <p:nvSpPr>
-          <p:cNvPr id="20" name="Text 18"/>
-          <p:cNvSpPr txBox="1"/>
-          <p:nvPr/>
-        </p:nvSpPr>
-        <p:spPr>
-          <a:xfrm>
-            <a:off x="7909560" y="3886200"/>
-            <a:ext cx="3657600" cy="274320"/>
-          </a:xfrm>
-          <a:prstGeom prst="rect">
-            <a:avLst/>
-          </a:prstGeom>
-          <a:noFill/>
-          <a:ln/>
-        </p:spPr>
-        <p:txBody>
-          <a:bodyPr wrap="square" lIns="0" tIns="0" rIns="0" bIns="0" rtlCol="0" anchor="t"/>
-          <a:lstStyle/>
-          <a:p>
-            <a:pPr indent="0" marL="0">
-              <a:buNone/>
-            </a:pPr>
-            <a:r>
-              <a:rPr lang="en-US" sz="1200" b="1" spc="200" kern="0" dirty="0">
-                <a:solidFill>
-                  <a:schemeClr val="accent1"/>
-                </a:solidFill>
-              </a:rPr>
-              <a:t>TEAM MEMBERS</a:t>
-            </a:r>
-            <a:endParaRPr lang="en-US" sz="1200" dirty="0"/>
-          </a:p>
-        </p:txBody>
-      </p:sp>
-      <p:sp>
-        <p:nvSpPr>
-          <p:cNvPr id="21" name="member0"/>
-          <p:cNvSpPr/>
-          <p:nvPr/>
-        </p:nvSpPr>
-        <p:spPr>
-          <a:xfrm>
-            <a:off x="7909560" y="4297680"/>
-            <a:ext cx="3733495" cy="777240"/>
+              <a:t>TEAM EXPERTISE</a:t>
+            </a:r>
+            <a:endParaRPr lang="en-US" sz="1100" dirty="0"/>
+          </a:p>
+        </p:txBody>
+      </p:sp>
+      <p:sp>
+        <p:nvSpPr>
+          <p:cNvPr id="20" name="exp0"/>
+          <p:cNvSpPr/>
+          <p:nvPr/>
+        </p:nvSpPr>
+        <p:spPr>
+          <a:xfrm>
+            <a:off x="548640" y="4526280"/>
+            <a:ext cx="5410048" cy="1828800"/>
           </a:xfrm>
           <a:prstGeom prst="roundRect">
             <a:avLst>
-              <a:gd name="adj" fmla="val 9412"/>
+              <a:gd name="adj" fmla="val 4000"/>
             </a:avLst>
           </a:prstGeom>
           <a:solidFill>
@@ -2584,14 +2551,14 @@
       </p:sp>
       <p:sp>
         <p:nvSpPr>
-          <p:cNvPr id="22" name="mem0-circle"/>
-          <p:cNvSpPr/>
-          <p:nvPr/>
-        </p:nvSpPr>
-        <p:spPr>
-          <a:xfrm>
-            <a:off x="8092440" y="4434840"/>
-            <a:ext cx="502920" cy="502920"/>
+          <p:cNvPr id="21" name="mem0-circle"/>
+          <p:cNvSpPr/>
+          <p:nvPr/>
+        </p:nvSpPr>
+        <p:spPr>
+          <a:xfrm>
+            <a:off x="777240" y="4727448"/>
+            <a:ext cx="548640" cy="548640"/>
           </a:xfrm>
           <a:prstGeom prst="ellipse">
             <a:avLst/>
@@ -2609,7 +2576,7 @@
       </p:sp>
       <p:pic>
         <p:nvPicPr>
-          <p:cNvPr id="23" name="mem0-icon" descr="preencoded.png">    </p:cNvPr>
+          <p:cNvPr id="22" name="mem0-icon" descr="preencoded.png">    </p:cNvPr>
           <p:cNvPicPr>
             <a:picLocks noChangeAspect="1"/>
           </p:cNvPicPr>
@@ -2623,8 +2590,8 @@
         </p:blipFill>
         <p:spPr>
           <a:xfrm>
-            <a:off x="8223199" y="4565599"/>
-            <a:ext cx="241402" cy="241402"/>
+            <a:off x="919886" y="4870094"/>
+            <a:ext cx="263347" cy="263347"/>
           </a:xfrm>
           <a:prstGeom prst="rect">
             <a:avLst/>
@@ -2633,54 +2600,166 @@
       </p:pic>
       <p:sp>
         <p:nvSpPr>
+          <p:cNvPr id="23" name="Text 20"/>
+          <p:cNvSpPr txBox="1"/>
+          <p:nvPr/>
+        </p:nvSpPr>
+        <p:spPr>
+          <a:xfrm>
+            <a:off x="1463040" y="4663440"/>
+            <a:ext cx="4312768" cy="347472"/>
+          </a:xfrm>
+          <a:prstGeom prst="rect">
+            <a:avLst/>
+          </a:prstGeom>
+          <a:noFill/>
+          <a:ln/>
+        </p:spPr>
+        <p:txBody>
+          <a:bodyPr wrap="square" lIns="0" tIns="0" rIns="0" bIns="0" rtlCol="0" anchor="t"/>
+          <a:lstStyle/>
+          <a:p>
+            <a:pPr indent="0" marL="0">
+              <a:buNone/>
+            </a:pPr>
+            <a:r>
+              <a:rPr lang="en-US" sz="1800" b="1" dirty="0">
+                <a:solidFill>
+                  <a:schemeClr val="bg1"/>
+                </a:solidFill>
+              </a:rPr>
+              <a:t>Ayush Sharma</a:t>
+            </a:r>
+            <a:endParaRPr lang="en-US" sz="1800" dirty="0"/>
+          </a:p>
+        </p:txBody>
+      </p:sp>
+      <p:sp>
+        <p:nvSpPr>
           <p:cNvPr id="24" name="Text 21"/>
           <p:cNvSpPr txBox="1"/>
           <p:nvPr/>
         </p:nvSpPr>
         <p:spPr>
           <a:xfrm>
-            <a:off x="8778240" y="4297680"/>
-            <a:ext cx="2743200" cy="777240"/>
-          </a:xfrm>
-          <a:prstGeom prst="rect">
-            <a:avLst/>
-          </a:prstGeom>
-          <a:noFill/>
-          <a:ln/>
-        </p:spPr>
-        <p:txBody>
-          <a:bodyPr wrap="square" lIns="0" tIns="0" rIns="0" bIns="0" rtlCol="0" anchor="ctr"/>
+            <a:off x="1463040" y="5010912"/>
+            <a:ext cx="4312768" cy="292608"/>
+          </a:xfrm>
+          <a:prstGeom prst="rect">
+            <a:avLst/>
+          </a:prstGeom>
+          <a:noFill/>
+          <a:ln/>
+        </p:spPr>
+        <p:txBody>
+          <a:bodyPr wrap="square" lIns="0" tIns="0" rIns="0" bIns="0" rtlCol="0" anchor="t"/>
           <a:lstStyle/>
           <a:p>
             <a:pPr indent="0" marL="0">
               <a:buNone/>
             </a:pPr>
             <a:r>
-              <a:rPr lang="en-US" sz="1800" b="1" dirty="0">
-                <a:solidFill>
-                  <a:schemeClr val="bg1"/>
-                </a:solidFill>
-              </a:rPr>
-              <a:t>Ayush Sharma</a:t>
-            </a:r>
-            <a:endParaRPr lang="en-US" sz="1800" dirty="0"/>
-          </a:p>
-        </p:txBody>
-      </p:sp>
-      <p:sp>
-        <p:nvSpPr>
-          <p:cNvPr id="25" name="member1"/>
-          <p:cNvSpPr/>
-          <p:nvPr/>
-        </p:nvSpPr>
-        <p:spPr>
-          <a:xfrm>
-            <a:off x="7909560" y="5212080"/>
-            <a:ext cx="3733495" cy="777240"/>
+              <a:rPr lang="en-US" sz="1300" b="1" dirty="0">
+                <a:solidFill>
+                  <a:schemeClr val="accent1"/>
+                </a:solidFill>
+              </a:rPr>
+              <a:t>Crypto Domain &amp; Product Research</a:t>
+            </a:r>
+            <a:endParaRPr lang="en-US" sz="1300" dirty="0"/>
+          </a:p>
+        </p:txBody>
+      </p:sp>
+      <p:sp>
+        <p:nvSpPr>
+          <p:cNvPr id="25" name="Text 22"/>
+          <p:cNvSpPr txBox="1"/>
+          <p:nvPr/>
+        </p:nvSpPr>
+        <p:spPr>
+          <a:xfrm>
+            <a:off x="822960" y="5422392"/>
+            <a:ext cx="4952848" cy="868680"/>
+          </a:xfrm>
+          <a:prstGeom prst="rect">
+            <a:avLst/>
+          </a:prstGeom>
+          <a:noFill/>
+          <a:ln/>
+        </p:spPr>
+        <p:txBody>
+          <a:bodyPr wrap="square" lIns="0" tIns="0" rIns="0" bIns="0" rtlCol="0" anchor="t"/>
+          <a:lstStyle/>
+          <a:p>
+            <a:pPr marL="152400" indent="-152400">
+              <a:spcAft>
+                <a:spcPts val="300"/>
+              </a:spcAft>
+              <a:buSzPct val="100000"/>
+              <a:buChar char="•"/>
+            </a:pPr>
+            <a:r>
+              <a:rPr lang="en-US" sz="1200" dirty="0">
+                <a:solidFill>
+                  <a:schemeClr val="bg2"/>
+                </a:solidFill>
+              </a:rPr>
+              <a:t>1+ year of hands-on experience in cryptocurrency markets</a:t>
+            </a:r>
+            <a:endParaRPr lang="en-US" sz="1200" dirty="0"/>
+          </a:p>
+          <a:p>
+            <a:pPr marL="152400" indent="-152400">
+              <a:spcAft>
+                <a:spcPts val="300"/>
+              </a:spcAft>
+              <a:buSzPct val="100000"/>
+              <a:buChar char="•"/>
+            </a:pPr>
+            <a:r>
+              <a:rPr lang="en-US" sz="1200" dirty="0">
+                <a:solidFill>
+                  <a:schemeClr val="bg2"/>
+                </a:solidFill>
+              </a:rPr>
+              <a:t>Understands crypto users, exchanges and market risks</a:t>
+            </a:r>
+            <a:endParaRPr lang="en-US" sz="1200" dirty="0"/>
+          </a:p>
+          <a:p>
+            <a:pPr marL="152400" indent="-152400">
+              <a:spcAft>
+                <a:spcPts val="300"/>
+              </a:spcAft>
+              <a:buSzPct val="100000"/>
+              <a:buChar char="•"/>
+            </a:pPr>
+            <a:r>
+              <a:rPr lang="en-US" sz="1200" dirty="0">
+                <a:solidFill>
+                  <a:schemeClr val="bg2"/>
+                </a:solidFill>
+              </a:rPr>
+              <a:t>Leads problem research; turns domain knowledge into product requirements</a:t>
+            </a:r>
+            <a:endParaRPr lang="en-US" sz="1200" dirty="0"/>
+          </a:p>
+        </p:txBody>
+      </p:sp>
+      <p:sp>
+        <p:nvSpPr>
+          <p:cNvPr id="26" name="exp1"/>
+          <p:cNvSpPr/>
+          <p:nvPr/>
+        </p:nvSpPr>
+        <p:spPr>
+          <a:xfrm>
+            <a:off x="6233008" y="4526280"/>
+            <a:ext cx="5410048" cy="1828800"/>
           </a:xfrm>
           <a:prstGeom prst="roundRect">
             <a:avLst>
-              <a:gd name="adj" fmla="val 9412"/>
+              <a:gd name="adj" fmla="val 4000"/>
             </a:avLst>
           </a:prstGeom>
           <a:solidFill>
@@ -2696,14 +2775,14 @@
       </p:sp>
       <p:sp>
         <p:nvSpPr>
-          <p:cNvPr id="26" name="mem1-circle"/>
-          <p:cNvSpPr/>
-          <p:nvPr/>
-        </p:nvSpPr>
-        <p:spPr>
-          <a:xfrm>
-            <a:off x="8092440" y="5349240"/>
-            <a:ext cx="502920" cy="502920"/>
+          <p:cNvPr id="27" name="mem1-circle"/>
+          <p:cNvSpPr/>
+          <p:nvPr/>
+        </p:nvSpPr>
+        <p:spPr>
+          <a:xfrm>
+            <a:off x="6461608" y="4727448"/>
+            <a:ext cx="548640" cy="548640"/>
           </a:xfrm>
           <a:prstGeom prst="ellipse">
             <a:avLst/>
@@ -2721,7 +2800,7 @@
       </p:sp>
       <p:pic>
         <p:nvPicPr>
-          <p:cNvPr id="27" name="mem1-icon" descr="preencoded.png">    </p:cNvPr>
+          <p:cNvPr id="28" name="mem1-icon" descr="preencoded.png">    </p:cNvPr>
           <p:cNvPicPr>
             <a:picLocks noChangeAspect="1"/>
           </p:cNvPicPr>
@@ -2735,8 +2814,8 @@
         </p:blipFill>
         <p:spPr>
           <a:xfrm>
-            <a:off x="8223199" y="5479999"/>
-            <a:ext cx="241402" cy="241402"/>
+            <a:off x="6604254" y="4870094"/>
+            <a:ext cx="263347" cy="263347"/>
           </a:xfrm>
           <a:prstGeom prst="rect">
             <a:avLst/>
@@ -2745,23 +2824,23 @@
       </p:pic>
       <p:sp>
         <p:nvSpPr>
-          <p:cNvPr id="28" name="Text 24"/>
-          <p:cNvSpPr txBox="1"/>
-          <p:nvPr/>
-        </p:nvSpPr>
-        <p:spPr>
-          <a:xfrm>
-            <a:off x="8778240" y="5212080"/>
-            <a:ext cx="2743200" cy="777240"/>
-          </a:xfrm>
-          <a:prstGeom prst="rect">
-            <a:avLst/>
-          </a:prstGeom>
-          <a:noFill/>
-          <a:ln/>
-        </p:spPr>
-        <p:txBody>
-          <a:bodyPr wrap="square" lIns="0" tIns="0" rIns="0" bIns="0" rtlCol="0" anchor="ctr"/>
+          <p:cNvPr id="29" name="Text 25"/>
+          <p:cNvSpPr txBox="1"/>
+          <p:nvPr/>
+        </p:nvSpPr>
+        <p:spPr>
+          <a:xfrm>
+            <a:off x="7147408" y="4663440"/>
+            <a:ext cx="4312768" cy="347472"/>
+          </a:xfrm>
+          <a:prstGeom prst="rect">
+            <a:avLst/>
+          </a:prstGeom>
+          <a:noFill/>
+          <a:ln/>
+        </p:spPr>
+        <p:txBody>
+          <a:bodyPr wrap="square" lIns="0" tIns="0" rIns="0" bIns="0" rtlCol="0" anchor="t"/>
           <a:lstStyle/>
           <a:p>
             <a:pPr indent="0" marL="0">
@@ -2776,6 +2855,118 @@
               <a:t>Chhaya Attri</a:t>
             </a:r>
             <a:endParaRPr lang="en-US" sz="1800" dirty="0"/>
+          </a:p>
+        </p:txBody>
+      </p:sp>
+      <p:sp>
+        <p:nvSpPr>
+          <p:cNvPr id="30" name="Text 26"/>
+          <p:cNvSpPr txBox="1"/>
+          <p:nvPr/>
+        </p:nvSpPr>
+        <p:spPr>
+          <a:xfrm>
+            <a:off x="7147408" y="5010912"/>
+            <a:ext cx="4312768" cy="292608"/>
+          </a:xfrm>
+          <a:prstGeom prst="rect">
+            <a:avLst/>
+          </a:prstGeom>
+          <a:noFill/>
+          <a:ln/>
+        </p:spPr>
+        <p:txBody>
+          <a:bodyPr wrap="square" lIns="0" tIns="0" rIns="0" bIns="0" rtlCol="0" anchor="t"/>
+          <a:lstStyle/>
+          <a:p>
+            <a:pPr indent="0" marL="0">
+              <a:buNone/>
+            </a:pPr>
+            <a:r>
+              <a:rPr lang="en-US" sz="1300" b="1" dirty="0">
+                <a:solidFill>
+                  <a:srgbClr val="8FB3FF"/>
+                </a:solidFill>
+              </a:rPr>
+              <a:t>Full-Stack Development &amp; Intelligence Research</a:t>
+            </a:r>
+            <a:endParaRPr lang="en-US" sz="1300" dirty="0"/>
+          </a:p>
+        </p:txBody>
+      </p:sp>
+      <p:sp>
+        <p:nvSpPr>
+          <p:cNvPr id="31" name="Text 27"/>
+          <p:cNvSpPr txBox="1"/>
+          <p:nvPr/>
+        </p:nvSpPr>
+        <p:spPr>
+          <a:xfrm>
+            <a:off x="6507328" y="5422392"/>
+            <a:ext cx="4952848" cy="868680"/>
+          </a:xfrm>
+          <a:prstGeom prst="rect">
+            <a:avLst/>
+          </a:prstGeom>
+          <a:noFill/>
+          <a:ln/>
+        </p:spPr>
+        <p:txBody>
+          <a:bodyPr wrap="square" lIns="0" tIns="0" rIns="0" bIns="0" rtlCol="0" anchor="t"/>
+          <a:lstStyle/>
+          <a:p>
+            <a:pPr marL="152400" indent="-152400">
+              <a:spcAft>
+                <a:spcPts val="300"/>
+              </a:spcAft>
+              <a:buSzPct val="100000"/>
+              <a:buChar char="•"/>
+            </a:pPr>
+            <a:r>
+              <a:rPr lang="en-US" sz="1200" dirty="0">
+                <a:solidFill>
+                  <a:schemeClr val="bg2"/>
+                </a:solidFill>
+              </a:rPr>
+              <a:t>Full-stack developer: builds the dashboard, backend and APIs</a:t>
+            </a:r>
+            <a:endParaRPr lang="en-US" sz="1200" dirty="0"/>
+          </a:p>
+          <a:p>
+            <a:pPr marL="152400" indent="-152400">
+              <a:spcAft>
+                <a:spcPts val="300"/>
+              </a:spcAft>
+              <a:buSzPct val="100000"/>
+              <a:buChar char="•"/>
+            </a:pPr>
+            <a:r>
+              <a:rPr lang="en-US" sz="1200" dirty="0">
+                <a:solidFill>
+                  <a:schemeClr val="bg2"/>
+                </a:solidFill>
+              </a:rPr>
+              <a:t>Scam-intelligence research and TinyFish research workflows</a:t>
+            </a:r>
+            <a:endParaRPr lang="en-US" sz="1200" dirty="0"/>
+          </a:p>
+          <a:p>
+            <a:pPr marL="152400" indent="-152400">
+              <a:spcAft>
+                <a:spcPts val="300"/>
+              </a:spcAft>
+              <a:buSzPct val="100000"/>
+              <a:buChar char="•"/>
+            </a:pPr>
+            <a:r>
+              <a:rPr lang="en-US" sz="1200" dirty="0">
+                <a:solidFill>
+                  <a:schemeClr val="bg2"/>
+                </a:solidFill>
+              </a:rPr>
+              <a:t>Source verification and evidence documentation</a:t>
+            </a:r>
+            <a:endParaRPr lang="en-US" sz="1200" dirty="0"/>
           </a:p>
         </p:txBody>
       </p:sp>
@@ -12413,7 +12604,43 @@
       </p:sp>
       <p:sp>
         <p:nvSpPr>
-          <p:cNvPr id="5" name="mk-frame"/>
+          <p:cNvPr id="5" name="Text 3"/>
+          <p:cNvSpPr txBox="1"/>
+          <p:nvPr/>
+        </p:nvSpPr>
+        <p:spPr>
+          <a:xfrm>
+            <a:off x="6766560" y="1024128"/>
+            <a:ext cx="4846320" cy="329184"/>
+          </a:xfrm>
+          <a:prstGeom prst="rect">
+            <a:avLst/>
+          </a:prstGeom>
+          <a:noFill/>
+          <a:ln/>
+        </p:spPr>
+        <p:txBody>
+          <a:bodyPr wrap="square" lIns="0" tIns="0" rIns="0" bIns="0" rtlCol="0" anchor="ctr"/>
+          <a:lstStyle/>
+          <a:p>
+            <a:pPr indent="0" marL="0">
+              <a:buNone/>
+            </a:pPr>
+            <a:r>
+              <a:rPr lang="en-US" sz="1200" i="1" dirty="0">
+                <a:solidFill>
+                  <a:schemeClr val="tx2"/>
+                </a:solidFill>
+              </a:rPr>
+              <a:t>Status: design only, to be built during the hackathon. No live findings.</a:t>
+            </a:r>
+            <a:endParaRPr lang="en-US" sz="1200" dirty="0"/>
+          </a:p>
+        </p:txBody>
+      </p:sp>
+      <p:sp>
+        <p:nvSpPr>
+          <p:cNvPr id="6" name="mk-frame"/>
           <p:cNvSpPr/>
           <p:nvPr/>
         </p:nvSpPr>
@@ -12440,7 +12667,7 @@
       </p:sp>
       <p:sp>
         <p:nvSpPr>
-          <p:cNvPr id="6" name="mk-bar"/>
+          <p:cNvPr id="7" name="mk-bar"/>
           <p:cNvSpPr/>
           <p:nvPr/>
         </p:nvSpPr>
@@ -12465,7 +12692,7 @@
       </p:sp>
       <p:sp>
         <p:nvSpPr>
-          <p:cNvPr id="7" name="Text 5"/>
+          <p:cNvPr id="8" name="Text 6"/>
           <p:cNvSpPr txBox="1"/>
           <p:nvPr/>
         </p:nvSpPr>
@@ -12493,7 +12720,7 @@
                   <a:schemeClr val="bg1"/>
                 </a:solidFill>
               </a:rPr>
-              <a:t>ChainSight   Case DEMO-001   |   Tron</a:t>
+              <a:t>ChainSight   Case DEMO-001 (sample)   |   Tron</a:t>
             </a:r>
             <a:endParaRPr lang="en-US" sz="1200" dirty="0"/>
           </a:p>
@@ -12501,7 +12728,7 @@
       </p:sp>
       <p:sp>
         <p:nvSpPr>
-          <p:cNvPr id="8" name="mk-dl"/>
+          <p:cNvPr id="9" name="mk-dl"/>
           <p:cNvSpPr/>
           <p:nvPr/>
         </p:nvSpPr>
@@ -12528,7 +12755,7 @@
       </p:sp>
       <p:sp>
         <p:nvSpPr>
-          <p:cNvPr id="9" name="Text 7"/>
+          <p:cNvPr id="10" name="Text 8"/>
           <p:cNvSpPr txBox="1"/>
           <p:nvPr/>
         </p:nvSpPr>
@@ -12564,7 +12791,7 @@
       </p:sp>
       <p:sp>
         <p:nvSpPr>
-          <p:cNvPr id="10" name="mk-k0"/>
+          <p:cNvPr id="11" name="mk-k0"/>
           <p:cNvSpPr/>
           <p:nvPr/>
         </p:nvSpPr>
@@ -12591,7 +12818,7 @@
       </p:sp>
       <p:sp>
         <p:nvSpPr>
-          <p:cNvPr id="11" name="Text 9"/>
+          <p:cNvPr id="12" name="Text 10"/>
           <p:cNvSpPr txBox="1"/>
           <p:nvPr/>
         </p:nvSpPr>
@@ -12627,7 +12854,7 @@
       </p:sp>
       <p:sp>
         <p:nvSpPr>
-          <p:cNvPr id="12" name="Text 10"/>
+          <p:cNvPr id="13" name="Text 11"/>
           <p:cNvSpPr txBox="1"/>
           <p:nvPr/>
         </p:nvSpPr>
@@ -12663,7 +12890,7 @@
       </p:sp>
       <p:sp>
         <p:nvSpPr>
-          <p:cNvPr id="13" name="mk-k1"/>
+          <p:cNvPr id="14" name="mk-k1"/>
           <p:cNvSpPr/>
           <p:nvPr/>
         </p:nvSpPr>
@@ -12690,7 +12917,7 @@
       </p:sp>
       <p:sp>
         <p:nvSpPr>
-          <p:cNvPr id="14" name="Text 12"/>
+          <p:cNvPr id="15" name="Text 13"/>
           <p:cNvSpPr txBox="1"/>
           <p:nvPr/>
         </p:nvSpPr>
@@ -12726,7 +12953,7 @@
       </p:sp>
       <p:sp>
         <p:nvSpPr>
-          <p:cNvPr id="15" name="Text 13"/>
+          <p:cNvPr id="16" name="Text 14"/>
           <p:cNvSpPr txBox="1"/>
           <p:nvPr/>
         </p:nvSpPr>
@@ -12762,7 +12989,7 @@
       </p:sp>
       <p:sp>
         <p:nvSpPr>
-          <p:cNvPr id="16" name="mk-k2"/>
+          <p:cNvPr id="17" name="mk-k2"/>
           <p:cNvSpPr/>
           <p:nvPr/>
         </p:nvSpPr>
@@ -12789,7 +13016,7 @@
       </p:sp>
       <p:sp>
         <p:nvSpPr>
-          <p:cNvPr id="17" name="Text 15"/>
+          <p:cNvPr id="18" name="Text 16"/>
           <p:cNvSpPr txBox="1"/>
           <p:nvPr/>
         </p:nvSpPr>
@@ -12825,7 +13052,7 @@
       </p:sp>
       <p:sp>
         <p:nvSpPr>
-          <p:cNvPr id="18" name="Text 16"/>
+          <p:cNvPr id="19" name="Text 17"/>
           <p:cNvSpPr txBox="1"/>
           <p:nvPr/>
         </p:nvSpPr>
@@ -12861,7 +13088,7 @@
       </p:sp>
       <p:sp>
         <p:nvSpPr>
-          <p:cNvPr id="19" name="mk-k3"/>
+          <p:cNvPr id="20" name="mk-k3"/>
           <p:cNvSpPr/>
           <p:nvPr/>
         </p:nvSpPr>
@@ -12888,7 +13115,7 @@
       </p:sp>
       <p:sp>
         <p:nvSpPr>
-          <p:cNvPr id="20" name="Text 18"/>
+          <p:cNvPr id="21" name="Text 19"/>
           <p:cNvSpPr txBox="1"/>
           <p:nvPr/>
         </p:nvSpPr>
@@ -12924,7 +13151,7 @@
       </p:sp>
       <p:sp>
         <p:nvSpPr>
-          <p:cNvPr id="21" name="Text 19"/>
+          <p:cNvPr id="22" name="Text 20"/>
           <p:cNvSpPr txBox="1"/>
           <p:nvPr/>
         </p:nvSpPr>
@@ -12960,7 +13187,7 @@
       </p:sp>
       <p:sp>
         <p:nvSpPr>
-          <p:cNvPr id="22" name="mk-graph"/>
+          <p:cNvPr id="23" name="mk-graph"/>
           <p:cNvSpPr/>
           <p:nvPr/>
         </p:nvSpPr>
@@ -12987,7 +13214,7 @@
       </p:sp>
       <p:sp>
         <p:nvSpPr>
-          <p:cNvPr id="23" name="Text 21"/>
+          <p:cNvPr id="24" name="Text 22"/>
           <p:cNvSpPr txBox="1"/>
           <p:nvPr/>
         </p:nvSpPr>
@@ -13023,7 +13250,7 @@
       </p:sp>
       <p:sp>
         <p:nvSpPr>
-          <p:cNvPr id="24" name="mk-e0"/>
+          <p:cNvPr id="25" name="mk-e0"/>
           <p:cNvSpPr/>
           <p:nvPr/>
         </p:nvSpPr>
@@ -13046,7 +13273,7 @@
       </p:sp>
       <p:sp>
         <p:nvSpPr>
-          <p:cNvPr id="25" name="mk-e1"/>
+          <p:cNvPr id="26" name="mk-e1"/>
           <p:cNvSpPr/>
           <p:nvPr/>
         </p:nvSpPr>
@@ -13069,7 +13296,7 @@
       </p:sp>
       <p:sp>
         <p:nvSpPr>
-          <p:cNvPr id="26" name="mk-e2"/>
+          <p:cNvPr id="27" name="mk-e2"/>
           <p:cNvSpPr/>
           <p:nvPr/>
         </p:nvSpPr>
@@ -13092,7 +13319,7 @@
       </p:sp>
       <p:sp>
         <p:nvSpPr>
-          <p:cNvPr id="27" name="mk-e3"/>
+          <p:cNvPr id="28" name="mk-e3"/>
           <p:cNvSpPr/>
           <p:nvPr/>
         </p:nvSpPr>
@@ -13115,7 +13342,7 @@
       </p:sp>
       <p:sp>
         <p:nvSpPr>
-          <p:cNvPr id="28" name="mk-e4"/>
+          <p:cNvPr id="29" name="mk-e4"/>
           <p:cNvSpPr/>
           <p:nvPr/>
         </p:nvSpPr>
@@ -13138,7 +13365,7 @@
       </p:sp>
       <p:sp>
         <p:nvSpPr>
-          <p:cNvPr id="29" name="mk-e5"/>
+          <p:cNvPr id="30" name="mk-e5"/>
           <p:cNvSpPr/>
           <p:nvPr/>
         </p:nvSpPr>
@@ -13161,7 +13388,7 @@
       </p:sp>
       <p:sp>
         <p:nvSpPr>
-          <p:cNvPr id="30" name="mk-n0"/>
+          <p:cNvPr id="31" name="mk-n0"/>
           <p:cNvSpPr/>
           <p:nvPr/>
         </p:nvSpPr>
@@ -13188,7 +13415,7 @@
       </p:sp>
       <p:sp>
         <p:nvSpPr>
-          <p:cNvPr id="31" name="mk-n1"/>
+          <p:cNvPr id="32" name="mk-n1"/>
           <p:cNvSpPr/>
           <p:nvPr/>
         </p:nvSpPr>
@@ -13215,7 +13442,7 @@
       </p:sp>
       <p:sp>
         <p:nvSpPr>
-          <p:cNvPr id="32" name="mk-n2"/>
+          <p:cNvPr id="33" name="mk-n2"/>
           <p:cNvSpPr/>
           <p:nvPr/>
         </p:nvSpPr>
@@ -13242,7 +13469,7 @@
       </p:sp>
       <p:sp>
         <p:nvSpPr>
-          <p:cNvPr id="33" name="mk-n3"/>
+          <p:cNvPr id="34" name="mk-n3"/>
           <p:cNvSpPr/>
           <p:nvPr/>
         </p:nvSpPr>
@@ -13269,7 +13496,7 @@
       </p:sp>
       <p:sp>
         <p:nvSpPr>
-          <p:cNvPr id="34" name="mk-n4"/>
+          <p:cNvPr id="35" name="mk-n4"/>
           <p:cNvSpPr/>
           <p:nvPr/>
         </p:nvSpPr>
@@ -13296,7 +13523,7 @@
       </p:sp>
       <p:sp>
         <p:nvSpPr>
-          <p:cNvPr id="35" name="mk-n5"/>
+          <p:cNvPr id="36" name="mk-n5"/>
           <p:cNvSpPr/>
           <p:nvPr/>
         </p:nvSpPr>
@@ -13323,7 +13550,7 @@
       </p:sp>
       <p:sp>
         <p:nvSpPr>
-          <p:cNvPr id="36" name="mk-n6"/>
+          <p:cNvPr id="37" name="mk-n6"/>
           <p:cNvSpPr/>
           <p:nvPr/>
         </p:nvSpPr>
@@ -13350,7 +13577,7 @@
       </p:sp>
       <p:sp>
         <p:nvSpPr>
-          <p:cNvPr id="37" name="Text 35"/>
+          <p:cNvPr id="38" name="Text 36"/>
           <p:cNvSpPr txBox="1"/>
           <p:nvPr/>
         </p:nvSpPr>
@@ -13386,7 +13613,7 @@
       </p:sp>
       <p:sp>
         <p:nvSpPr>
-          <p:cNvPr id="38" name="Text 36"/>
+          <p:cNvPr id="39" name="Text 37"/>
           <p:cNvSpPr txBox="1"/>
           <p:nvPr/>
         </p:nvSpPr>
@@ -13422,7 +13649,7 @@
       </p:sp>
       <p:sp>
         <p:nvSpPr>
-          <p:cNvPr id="39" name="Text 37"/>
+          <p:cNvPr id="40" name="Text 38"/>
           <p:cNvSpPr txBox="1"/>
           <p:nvPr/>
         </p:nvSpPr>
@@ -13458,7 +13685,7 @@
       </p:sp>
       <p:sp>
         <p:nvSpPr>
-          <p:cNvPr id="40" name="Text 38"/>
+          <p:cNvPr id="41" name="Text 39"/>
           <p:cNvSpPr txBox="1"/>
           <p:nvPr/>
         </p:nvSpPr>
@@ -13494,7 +13721,7 @@
       </p:sp>
       <p:sp>
         <p:nvSpPr>
-          <p:cNvPr id="41" name="mk-contact"/>
+          <p:cNvPr id="42" name="mk-contact"/>
           <p:cNvSpPr/>
           <p:nvPr/>
         </p:nvSpPr>
@@ -13521,7 +13748,7 @@
       </p:sp>
       <p:sp>
         <p:nvSpPr>
-          <p:cNvPr id="42" name="Text 40"/>
+          <p:cNvPr id="43" name="Text 41"/>
           <p:cNvSpPr txBox="1"/>
           <p:nvPr/>
         </p:nvSpPr>
@@ -13557,7 +13784,7 @@
       </p:sp>
       <p:sp>
         <p:nvSpPr>
-          <p:cNvPr id="43" name="mk-tf"/>
+          <p:cNvPr id="44" name="mk-tf"/>
           <p:cNvSpPr/>
           <p:nvPr/>
         </p:nvSpPr>
@@ -13584,7 +13811,7 @@
       </p:sp>
       <p:sp>
         <p:nvSpPr>
-          <p:cNvPr id="44" name="Text 42"/>
+          <p:cNvPr id="45" name="Text 43"/>
           <p:cNvSpPr txBox="1"/>
           <p:nvPr/>
         </p:nvSpPr>
@@ -13620,7 +13847,7 @@
       </p:sp>
       <p:sp>
         <p:nvSpPr>
-          <p:cNvPr id="45" name="Text 43"/>
+          <p:cNvPr id="46" name="Text 44"/>
           <p:cNvSpPr txBox="1"/>
           <p:nvPr/>
         </p:nvSpPr>
@@ -13717,7 +13944,7 @@
       </p:sp>
       <p:sp>
         <p:nvSpPr>
-          <p:cNvPr id="46" name="mk-freeze"/>
+          <p:cNvPr id="47" name="mk-freeze"/>
           <p:cNvSpPr/>
           <p:nvPr/>
         </p:nvSpPr>
@@ -13744,7 +13971,7 @@
       </p:sp>
       <p:sp>
         <p:nvSpPr>
-          <p:cNvPr id="47" name="Text 45"/>
+          <p:cNvPr id="48" name="Text 46"/>
           <p:cNvSpPr txBox="1"/>
           <p:nvPr/>
         </p:nvSpPr>
@@ -13780,7 +14007,7 @@
       </p:sp>
       <p:sp>
         <p:nvSpPr>
-          <p:cNvPr id="48" name="mk-ev"/>
+          <p:cNvPr id="49" name="mk-ev"/>
           <p:cNvSpPr/>
           <p:nvPr/>
         </p:nvSpPr>
@@ -13807,7 +14034,7 @@
       </p:sp>
       <p:sp>
         <p:nvSpPr>
-          <p:cNvPr id="49" name="Text 47"/>
+          <p:cNvPr id="50" name="Text 48"/>
           <p:cNvSpPr txBox="1"/>
           <p:nvPr/>
         </p:nvSpPr>
@@ -13835,7 +14062,7 @@
                   <a:schemeClr val="tx1"/>
                 </a:solidFill>
               </a:rPr>
-              <a:t>Evidence trail</a:t>
+              <a:t>Evidence trail (sample entries)</a:t>
             </a:r>
             <a:endParaRPr lang="en-US" sz="1200" dirty="0"/>
           </a:p>
@@ -13843,7 +14070,7 @@
       </p:sp>
       <p:sp>
         <p:nvSpPr>
-          <p:cNvPr id="50" name="mk-ev0"/>
+          <p:cNvPr id="51" name="mk-ev0"/>
           <p:cNvSpPr/>
           <p:nvPr/>
         </p:nvSpPr>
@@ -13870,7 +14097,7 @@
       </p:sp>
       <p:sp>
         <p:nvSpPr>
-          <p:cNvPr id="51" name="Text 49"/>
+          <p:cNvPr id="52" name="Text 50"/>
           <p:cNvSpPr txBox="1"/>
           <p:nvPr/>
         </p:nvSpPr>
@@ -13906,7 +14133,7 @@
       </p:sp>
       <p:sp>
         <p:nvSpPr>
-          <p:cNvPr id="52" name="Text 50"/>
+          <p:cNvPr id="53" name="Text 51"/>
           <p:cNvSpPr txBox="1"/>
           <p:nvPr/>
         </p:nvSpPr>
@@ -13942,7 +14169,7 @@
       </p:sp>
       <p:sp>
         <p:nvSpPr>
-          <p:cNvPr id="53" name="mk-ev1"/>
+          <p:cNvPr id="54" name="mk-ev1"/>
           <p:cNvSpPr/>
           <p:nvPr/>
         </p:nvSpPr>
@@ -13969,7 +14196,7 @@
       </p:sp>
       <p:sp>
         <p:nvSpPr>
-          <p:cNvPr id="54" name="Text 52"/>
+          <p:cNvPr id="55" name="Text 53"/>
           <p:cNvSpPr txBox="1"/>
           <p:nvPr/>
         </p:nvSpPr>
@@ -14005,7 +14232,7 @@
       </p:sp>
       <p:sp>
         <p:nvSpPr>
-          <p:cNvPr id="55" name="Text 53"/>
+          <p:cNvPr id="56" name="Text 54"/>
           <p:cNvSpPr txBox="1"/>
           <p:nvPr/>
         </p:nvSpPr>
@@ -14041,7 +14268,7 @@
       </p:sp>
       <p:sp>
         <p:nvSpPr>
-          <p:cNvPr id="56" name="mk-ev2"/>
+          <p:cNvPr id="57" name="mk-ev2"/>
           <p:cNvSpPr/>
           <p:nvPr/>
         </p:nvSpPr>
@@ -14068,7 +14295,7 @@
       </p:sp>
       <p:sp>
         <p:nvSpPr>
-          <p:cNvPr id="57" name="Text 55"/>
+          <p:cNvPr id="58" name="Text 56"/>
           <p:cNvSpPr txBox="1"/>
           <p:nvPr/>
         </p:nvSpPr>
@@ -14104,7 +14331,7 @@
       </p:sp>
       <p:sp>
         <p:nvSpPr>
-          <p:cNvPr id="58" name="Text 56"/>
+          <p:cNvPr id="59" name="Text 57"/>
           <p:cNvSpPr txBox="1"/>
           <p:nvPr/>
         </p:nvSpPr>
@@ -14140,7 +14367,7 @@
       </p:sp>
       <p:sp>
         <p:nvSpPr>
-          <p:cNvPr id="59" name="co0"/>
+          <p:cNvPr id="60" name="co0"/>
           <p:cNvSpPr/>
           <p:nvPr/>
         </p:nvSpPr>
@@ -14165,7 +14392,7 @@
       </p:sp>
       <p:sp>
         <p:nvSpPr>
-          <p:cNvPr id="60" name="Text 58"/>
+          <p:cNvPr id="61" name="Text 59"/>
           <p:cNvSpPr txBox="1"/>
           <p:nvPr/>
         </p:nvSpPr>
@@ -14201,7 +14428,7 @@
       </p:sp>
       <p:sp>
         <p:nvSpPr>
-          <p:cNvPr id="61" name="Text 59"/>
+          <p:cNvPr id="62" name="Text 60"/>
           <p:cNvSpPr txBox="1"/>
           <p:nvPr/>
         </p:nvSpPr>
@@ -14237,7 +14464,7 @@
       </p:sp>
       <p:sp>
         <p:nvSpPr>
-          <p:cNvPr id="62" name="Text 60"/>
+          <p:cNvPr id="63" name="Text 61"/>
           <p:cNvSpPr txBox="1"/>
           <p:nvPr/>
         </p:nvSpPr>
@@ -14273,7 +14500,7 @@
       </p:sp>
       <p:sp>
         <p:nvSpPr>
-          <p:cNvPr id="63" name="co1"/>
+          <p:cNvPr id="64" name="co1"/>
           <p:cNvSpPr/>
           <p:nvPr/>
         </p:nvSpPr>
@@ -14298,7 +14525,7 @@
       </p:sp>
       <p:sp>
         <p:nvSpPr>
-          <p:cNvPr id="64" name="Text 62"/>
+          <p:cNvPr id="65" name="Text 63"/>
           <p:cNvSpPr txBox="1"/>
           <p:nvPr/>
         </p:nvSpPr>
@@ -14334,7 +14561,7 @@
       </p:sp>
       <p:sp>
         <p:nvSpPr>
-          <p:cNvPr id="65" name="Text 63"/>
+          <p:cNvPr id="66" name="Text 64"/>
           <p:cNvSpPr txBox="1"/>
           <p:nvPr/>
         </p:nvSpPr>
@@ -14370,7 +14597,7 @@
       </p:sp>
       <p:sp>
         <p:nvSpPr>
-          <p:cNvPr id="66" name="Text 64"/>
+          <p:cNvPr id="67" name="Text 65"/>
           <p:cNvSpPr txBox="1"/>
           <p:nvPr/>
         </p:nvSpPr>
@@ -14406,7 +14633,7 @@
       </p:sp>
       <p:sp>
         <p:nvSpPr>
-          <p:cNvPr id="67" name="co2"/>
+          <p:cNvPr id="68" name="co2"/>
           <p:cNvSpPr/>
           <p:nvPr/>
         </p:nvSpPr>
@@ -14431,7 +14658,7 @@
       </p:sp>
       <p:sp>
         <p:nvSpPr>
-          <p:cNvPr id="68" name="Text 66"/>
+          <p:cNvPr id="69" name="Text 67"/>
           <p:cNvSpPr txBox="1"/>
           <p:nvPr/>
         </p:nvSpPr>
@@ -14467,7 +14694,7 @@
       </p:sp>
       <p:sp>
         <p:nvSpPr>
-          <p:cNvPr id="69" name="Text 67"/>
+          <p:cNvPr id="70" name="Text 68"/>
           <p:cNvSpPr txBox="1"/>
           <p:nvPr/>
         </p:nvSpPr>
@@ -14503,7 +14730,7 @@
       </p:sp>
       <p:sp>
         <p:nvSpPr>
-          <p:cNvPr id="70" name="Text 68"/>
+          <p:cNvPr id="71" name="Text 69"/>
           <p:cNvSpPr txBox="1"/>
           <p:nvPr/>
         </p:nvSpPr>
@@ -14539,7 +14766,7 @@
       </p:sp>
       <p:sp>
         <p:nvSpPr>
-          <p:cNvPr id="71" name="co3"/>
+          <p:cNvPr id="72" name="co3"/>
           <p:cNvSpPr/>
           <p:nvPr/>
         </p:nvSpPr>
@@ -14564,7 +14791,7 @@
       </p:sp>
       <p:sp>
         <p:nvSpPr>
-          <p:cNvPr id="72" name="Text 70"/>
+          <p:cNvPr id="73" name="Text 71"/>
           <p:cNvSpPr txBox="1"/>
           <p:nvPr/>
         </p:nvSpPr>
@@ -14600,7 +14827,7 @@
       </p:sp>
       <p:sp>
         <p:nvSpPr>
-          <p:cNvPr id="73" name="Text 71"/>
+          <p:cNvPr id="74" name="Text 72"/>
           <p:cNvSpPr txBox="1"/>
           <p:nvPr/>
         </p:nvSpPr>
@@ -14636,7 +14863,7 @@
       </p:sp>
       <p:sp>
         <p:nvSpPr>
-          <p:cNvPr id="74" name="Text 72"/>
+          <p:cNvPr id="75" name="Text 73"/>
           <p:cNvSpPr txBox="1"/>
           <p:nvPr/>
         </p:nvSpPr>

</xml_diff>